<commit_message>
Publish anonymized SOC reference and latest presentation guidance
Add the complete 16-slide reference and its paired original notes, remove presenter identity and editor metadata, and retain the generic template. Sync narration and formula guidance; document third-party assets separately from the pending license.
</commit_message>
<xml_diff>
--- a/skills/artifact-template-soc-ppt/assets/reference.pptx
+++ b/skills/artifact-template-soc-ppt/assets/reference.pptx
@@ -338,7 +338,7 @@
             <a:pPr lvl="0"/>
             <a:r>
               <a:rPr lang="en-US" smtClean="0"/>
-              <a:t/>
+              <a:t>Click to edit Master text styles</a:t>
             </a:r>
             <a:endParaRPr lang="en-US" smtClean="0"/>
           </a:p>
@@ -346,7 +346,7 @@
             <a:pPr lvl="1"/>
             <a:r>
               <a:rPr lang="en-US" smtClean="0"/>
-              <a:t/>
+              <a:t>Second level</a:t>
             </a:r>
             <a:endParaRPr lang="en-US" smtClean="0"/>
           </a:p>
@@ -354,7 +354,7 @@
             <a:pPr lvl="2"/>
             <a:r>
               <a:rPr lang="en-US" smtClean="0"/>
-              <a:t/>
+              <a:t>Third level</a:t>
             </a:r>
             <a:endParaRPr lang="en-US" smtClean="0"/>
           </a:p>
@@ -362,7 +362,7 @@
             <a:pPr lvl="3"/>
             <a:r>
               <a:rPr lang="en-US" smtClean="0"/>
-              <a:t/>
+              <a:t>Fourth level</a:t>
             </a:r>
             <a:endParaRPr lang="en-US" smtClean="0"/>
           </a:p>
@@ -370,7 +370,7 @@
             <a:pPr lvl="4"/>
             <a:r>
               <a:rPr lang="en-US" smtClean="0"/>
-              <a:t/>
+              <a:t>Fifth level</a:t>
             </a:r>
             <a:endParaRPr lang="en-US"/>
           </a:p>
@@ -584,22 +584,23 @@
           <a:lstStyle/>
           <a:p>
             <a:r>
-              <a:t>【口播模板】</a:t>
-            </a:r>
-          </a:p>
-          <a:p>
-            <a:r>
-              <a:t>各位老师、同学，今天介绍的是［论文题名］。它关注［研究对象］中的［实际问题］。作者通过［总体思路］，希望回答［核心问题］。接下来先说明这个问题为什么值得研究，再看方法与证据。</a:t>
-            </a:r>
-          </a:p>
-          <a:p>
-            <a:r>
-              <a:t>【使用与来源提示，不口播】</a:t>
-            </a:r>
-          </a:p>
-          <a:p>
-            <a:r>
-              <a:t>本页是封面模板，括号内容与示意数字均待真实材料替换，不是实测结果。核对当前论文、听众、授权与目标时长后改写；这里的来源/制作说明不口播。</a:t>
+              <a:t>【口播稿】</a:t>
+            </a:r>
+          </a:p>
+          <a:p>
+            <a:r>
+              <a:t>各位老师、同学，今天汇报的是True Attacks, Attack Attempts, or Benign Triggers? An Empirical Measurement of Network Alerts in a Security Operations Center，中文是“真实攻击、攻击尝试，还是良性触发？——对一个安全运营中心网络告警的实证测量”。这篇论文发表于USENIX Security 2024，团队来自UIUC、NCSA和IBM Research。它是一篇测量研究：作者把2018至2022年的两段网络告警日志，与过去20年的成功攻击取证报告联系起来，回答真实SOC的告警体量、触发原因和攻击关联问题。今天以论文测量结果为主，最后谈方法论借鉴。</a:t>
+            </a:r>
+          </a:p>
+          <a:p/>
+          <a:p>
+            <a:r>
+              <a:t>【来源与审校记录，不口播】</a:t>
+            </a:r>
+          </a:p>
+          <a:p>
+            <a:r>
+              <a:t>事实来源：PDF2/1525首页、摘要；PDF4–5/1527–1528 §3；Table3在PDF8/1531。4年是跨2018–2022的两段有数据时期；20年报告为2002/01—2022/03，227是已发现成功攻击，重叠11。汇报者的“方法论借鉴”归纳仅在后部个人栏目。</a:t>
             </a:r>
           </a:p>
         </p:txBody>
@@ -669,22 +670,38 @@
           <a:lstStyle/>
           <a:p>
             <a:r>
-              <a:t>【口播模板】</a:t>
-            </a:r>
-          </a:p>
-          <a:p>
-            <a:r>
-              <a:t>进一步看对象特征。图中［指标或位置］显示［主要差异］，而［特殊对象］说明分布并不均匀。这项分析支持［结论］，它的范围仍限于［样本与条件］。</a:t>
-            </a:r>
-          </a:p>
-          <a:p>
-            <a:r>
-              <a:t>【使用与来源提示，不口播】</a:t>
-            </a:r>
-          </a:p>
-          <a:p>
-            <a:r>
-              <a:t>本页是对象特征模板，括号内容与示意数字均待真实材料替换，不是实测结果。核对当前论文、听众、授权与目标时长后改写；这里的来源/制作说明不口播。</a:t>
+              <a:t>【口播稿】</a:t>
+            </a:r>
+          </a:p>
+          <a:p>
+            <a:r>
+              <a:t>第三点看攻击尝试画像。在后期BHR标识的外部来源中，作者记录721,169个IP，映射到223个国家和地区，前五为中国、美国、印度、巴西、德国。这是来源IP的位置，不代表已确认攻击者身份。已识别尝试告警中，地址、随机和端口扫描合计96.7%，其他主要为SSH口令猜测和可疑SSH客户端。</a:t>
+            </a:r>
+          </a:p>
+          <a:p>
+            <a:r>
+              <a:t>Figure9显示约75%的来源IP仅活跃1日，但也有来源反复出现。最活跃来源累计活跃573日，事后查明是SOC成员未记录的外部BHR测试扫描器；573表示累计有活动的天数。</a:t>
+            </a:r>
+          </a:p>
+          <a:p>
+            <a:r>
+              <a:t>在连接数足够的子集中，66.22%的连接间隔规律性符合作者使用的botnet启发式特征，检验阈值是p小于0.05。这个结果不是对全部来源独立验证的僵尸网络占比，手动攻击也可能使用自动化工具。</a:t>
+            </a:r>
+          </a:p>
+          <a:p>
+            <a:r>
+              <a:t>Figure10的受害端分布也很偏斜：1,576个IP，约2.3%，关联55%的告警，其他67,780个IP关联45%；每主机告警中位数为203条。这个分析利用连接日志恢复受害者关联信息，不把扩展关联记录当成新生成的原始告警。SOC确认部分高告警主机提供公网开放服务；作者据此讨论per-host预测模型面对的不均衡分布。</a:t>
+            </a:r>
+          </a:p>
+          <a:p/>
+          <a:p>
+            <a:r>
+              <a:t>【来源与审校记录，不口播】</a:t>
+            </a:r>
+          </a:p>
+          <a:p>
+            <a:r>
+              <a:t>§6.3 PDF9–11/1532–1534，Table5、Figures9–12。721,169是BHR标识外部来源，总体包含未记录SOC测试扫描器这一案例，不能把IP归类当独立恶意真值。0.3%/28IP并列分母未解：只存审校，正文/口播用少量反复来源，不造替代值。573为累计活跃日，不是连续天。37.17%连接足够子集、66.22%是该子集启发式估计，原文at least5/more than5边界歧义不解；不写所有IP都botnet。Figure10为后期受害IP恢复后的关联数据，1,576/69,356≈2.3%对应55%，部分高告警主机公网服务非全部；203为每主机记录中位数。保持左图右数字结构，必要只换文本。</a:t>
             </a:r>
           </a:p>
         </p:txBody>
@@ -754,22 +771,38 @@
           <a:lstStyle/>
           <a:p>
             <a:r>
-              <a:t>【口播模板】</a:t>
-            </a:r>
-          </a:p>
-          <a:p>
-            <a:r>
-              <a:t>这张表把［系统输出］与［目标记录］放在一起比较。先区分［证据状态］和［发现渠道］，再看［关键行］。表中的缺失、零值与未判定各有含义，因此这里支持的是［结论范围］。</a:t>
-            </a:r>
-          </a:p>
-          <a:p>
-            <a:r>
-              <a:t>【使用与来源提示，不口播】</a:t>
-            </a:r>
-          </a:p>
-          <a:p>
-            <a:r>
-              <a:t>本页是证据表模板，括号内容与示意数字均待真实材料替换，不是实测结果。核对当前论文、听众、授权与目标时长后改写；这里的来源/制作说明不口播。</a:t>
+              <a:t>【口播稿】</a:t>
+            </a:r>
+          </a:p>
+          <a:p>
+            <a:r>
+              <a:t>第四点看11起已知成功攻击的发现渠道和告警状态。研究按取证报告中的IP和同日时间关联告警。Table8中7起由Zeek发现，4起由用户或其他渠道发现。这是这11个案例的发现渠道统计，不是整体检测召回率。</a:t>
+            </a:r>
+          </a:p>
+          <a:p>
+            <a:r>
+              <a:t>表中状态不能混同：ID4、6的精确相关日志缺失，报告支持由Zeek发现，不能将缺失当成测得零条；ID6同日告警总量也缺失。ID1有两条告警，但与该攻击无关；ID3、7、8相关告警列为零。最后一列是同日全部告警量，包含事件相关和其他告警，不是单独的其他告警数量。</a:t>
+            </a:r>
+          </a:p>
+          <a:p>
+            <a:r>
+              <a:t>可恢复的案例包括Postgres的1,101条、反射DoS的12条和内部账号挖矿的1条。作者发现失陷后的扫描、密码猜测等网络行为更容易触发告警；少量数据泄漏、少量钓鱼邮件和合法账号的隐蔽使用可能缺少相关网络告警。合法账号可从外部网络登录，未按政策启用2FA也增加判断困难。</a:t>
+            </a:r>
+          </a:p>
+          <a:p>
+            <a:r>
+              <a:t>挖矿案例后SOC增设规则，后续另一个挖矿事件出现相关告警。这说明有规则迭代，但没有控制实验验证其收益。整体结论是：网络告警对初始失陷和失陷后的隐蔽活动存在盲区。</a:t>
+            </a:r>
+          </a:p>
+          <a:p/>
+          <a:p>
+            <a:r>
+              <a:t>【来源与审校记录，不口播】</a:t>
+            </a:r>
+          </a:p>
+          <a:p>
+            <a:r>
+              <a:t>Table8/§7.1/Remark7 PDF12–13/1535–1536。完整11行与原脚注见P11_table8_full JSON；7为Zeek渠道ID2/4/5/6/9/10/11；4为User/Other ID1/3/7/8。ID4/6相关日志缺失，ID6总量缺失，ID1两条无关；不能写抓7漏4或全部零。非零可恢复6行含ID1无关，直接相关5行，不与7渠道混用。原正文“7触发且一例无关”歧义留记录。ID9 alert type=0原表如此，不补猜。Total列含相关与其他，ID2 Total163,878，Other144,689，不能混称。规则迭代是作者报告，无控制实验效益；账号/2FA为作者场景解释，不证明普适因果。</a:t>
             </a:r>
           </a:p>
         </p:txBody>
@@ -839,22 +872,38 @@
           <a:lstStyle/>
           <a:p>
             <a:r>
-              <a:t>【口播模板】</a:t>
-            </a:r>
-          </a:p>
-          <a:p>
-            <a:r>
-              <a:t>三个子图分别观察［指标A］、［指标B］和［指标C］。先看［定位词与发现］，再比较［另一子图的差异］。合起来，它们提供［认识］；样本规模与探索性边界是［限定］。</a:t>
-            </a:r>
-          </a:p>
-          <a:p>
-            <a:r>
-              <a:t>【使用与来源提示，不口播】</a:t>
-            </a:r>
-          </a:p>
-          <a:p>
-            <a:r>
-              <a:t>本页是并列证据模板，括号内容与示意数字均待真实材料替换，不是实测结果。核对当前论文、听众、授权与目标时长后改写；这里的来源/制作说明不口播。</a:t>
+              <a:t>【口播稿】</a:t>
+            </a:r>
+          </a:p>
+          <a:p>
+            <a:r>
+              <a:t>再看Figure13中的主机级特征探索。星号是后期三个已知事件ID9、10、11，不是背景类别的CDF曲线。三组短结论分别对应原图：(a)每日告警量熵中是ID10离群；(b)告警序列熵中是ID10、11离群；(c)告警稀有度中是ID9、10、11均离群。</a:t>
+            </a:r>
+          </a:p>
+          <a:p>
+            <a:r>
+              <a:t>三起事件各持续1日，作者用受害主机此前10天告警计算两种熵，熵较低意味着更强规律性。攻击尝试的日量更随机，但序列更可预测；良性和unknown相对日量更稳定、序列更难预测，这与大量尝试为扫描和口令猜测相符。</a:t>
+            </a:r>
+          </a:p>
+          <a:p>
+            <a:r>
+              <a:t>稀有度的直观含义是主机当天出现的告警类型有多罕见。作者按全数据频次给告警类型排序，再聚合当天出现的不同类型得分；这里不把具体实现解释扩展到原文未说明的细节。</a:t>
+            </a:r>
+          </a:p>
+          <a:p>
+            <a:r>
+              <a:t>作者认为这些现象提供了用主机级异常特征识别、优先排序成功攻击信号的机会。但这只基于3起案例的探索性观察，尚不能视为一个已验证的新检测方法，没有独立检测准确率、召回率或部署收益评估。</a:t>
+            </a:r>
+          </a:p>
+          <a:p/>
+          <a:p>
+            <a:r>
+              <a:t>【来源与审校记录，不口播】</a:t>
+            </a:r>
+          </a:p>
+          <a:p>
+            <a:r>
+              <a:t>Figure13 PDF13/1536；§7.2/Remark8 PDF14/1537。样本仅ID9/10/11，两熵用受害主机此前10天；(a)10、(b)10/11、(c)9/10/11。不得三维全离群。稀有度正文按告警频次排名，主机某日不同类型分数求和，轴却写Average Rareness of Alerts，未给可消歧平均分母；不补实现、不改原图。口播采用排名聚合的直观含义，不讲未解疑点。三个案例的探索不是已验证检测方法，未报告独立准确率/recall/上线收益。</a:t>
             </a:r>
           </a:p>
         </p:txBody>
@@ -924,22 +973,38 @@
           <a:lstStyle/>
           <a:p>
             <a:r>
-              <a:t>【口播模板】</a:t>
-            </a:r>
-          </a:p>
-          <a:p>
-            <a:r>
-              <a:t>把前面的发现放回实际场景，可以得到［证据支持的启示］。作者据此建议［建议］，其中［部分］已有实现证据，［部分］仍是展望或待验证方向。这里要把发现、建议和实现状态分开。</a:t>
-            </a:r>
-          </a:p>
-          <a:p>
-            <a:r>
-              <a:t>【使用与来源提示，不口播】</a:t>
-            </a:r>
-          </a:p>
-          <a:p>
-            <a:r>
-              <a:t>本页是研究启示模板，括号内容与示意数字均待真实材料替换，不是实测结果。核对当前论文、听众、授权与目标时长后改写；这里的来源/制作说明不口播。</a:t>
+              <a:t>【口播稿】</a:t>
+            </a:r>
+          </a:p>
+          <a:p>
+            <a:r>
+              <a:t>把结果收拢为运营启示。首先是人的投入：107份有人力记录的报告中，65%的事件至少有两名分析师参与。2016年后28起有相关时间戳的事件，攻击后调查平均历时53.2天、最长253天。这是调查经过的日历时长，不是累计劳动工时，也不代表每个事件都有人连续工作53天。</a:t>
+            </a:r>
+          </a:p>
+          <a:p>
+            <a:r>
+              <a:t>发现时间与分析师工作时间相关：周日发现最少、周一最多，小时分布在8至10点达到峰值。非工作时段发生的事件可能面临更长发现延迟，这是相关观察，时区等其他解释仍然存在，也没有证据证明攻击者刻意选择SOC下班时间。</a:t>
+            </a:r>
+          </a:p>
+          <a:p>
+            <a:r>
+              <a:t>作者建议把受害IP等关键元数据保留在告警中，使不同日志可链接、可查询，并探索更省存储的表示；这一建议对应告警聚合造成的信息损失和连接日志保存期限。对扫描器和例外服务，作者强调更完善的上下文记录与资产管理。自动遏制和LLM引导分析属于研究建议，其中LLM没有本研究实验验证。</a:t>
+            </a:r>
+          </a:p>
+          <a:p>
+            <a:r>
+              <a:t>一个已报告的落地结果是新增BHR规则：Postgres案例中的一组HTTP basic认证凭据还匹配3,377条告警，用户名在同类尝试中排第三，SOC据此新增阻断规则。报告表明规则被添加，不是已经验证上线后的检测收益。</a:t>
+            </a:r>
+          </a:p>
+          <a:p/>
+          <a:p>
+            <a:r>
+              <a:t>【来源与审校记录，不口播】</a:t>
+            </a:r>
+          </a:p>
+          <a:p>
+            <a:r>
+              <a:t>§5 PDF7–8/1530–1531；AppendixA/Figure14/15 PDF18/1541；§6.3 PDF10–11/1533–1534；§7.3 PDF14/1537；§8.2 PDF15/1538；AppendixB PDF19/1542。107份有人力记录报告中65%≥2分析师；调查53.2/max253为2016后28具时戳事件的历时，非累计工时；96双日期报告63同日(66%)为另一分母。off-hours观察只相关，时区为替代解释。日志链接/资产管理为作者建议；LLM设想无本研究实验；新BHR规则为报告落地，无上线对照。3,377是相同认证凭据额外匹配告警，用户名第三，不是整体弱口令检测准确率。</a:t>
             </a:r>
           </a:p>
         </p:txBody>
@@ -1009,22 +1074,33 @@
           <a:lstStyle/>
           <a:p>
             <a:r>
-              <a:t>【口播模板】</a:t>
-            </a:r>
-          </a:p>
-          <a:p>
-            <a:r>
-              <a:t>这些结论仍有边界。最关键的是［场景覆盖］、［数据或定义限制］以及［样本与推断范围］。因此，本文能够说明［已支持范围］，但还不能回答［范围之外的问题］。</a:t>
-            </a:r>
-          </a:p>
-          <a:p>
-            <a:r>
-              <a:t>【使用与来源提示，不口播】</a:t>
-            </a:r>
-          </a:p>
-          <a:p>
-            <a:r>
-              <a:t>本页是研究局限模板，括号内容与示意数字均待真实材料替换，不是实测结果。核对当前论文、听众、授权与目标时长后改写；这里的来源/制作说明不口播。</a:t>
+              <a:t>【口播稿】</a:t>
+            </a:r>
+          </a:p>
+          <a:p>
+            <a:r>
+              <a:t>这些结果的适用范围有几个边界。第一，单一SOC：NCSA是部分开放的科研设施，其网络、用户与规则环境不代表所有政府或企业SOC；跨时区轮班的大组织也可能有不同的非工作时段问题。第二，研究只获得网络告警，不能直接推广到整个SOC的全部检测能力。第三，数据止于2022年，规则与威胁面会变化。</a:t>
+            </a:r>
+          </a:p>
+          <a:p>
+            <a:r>
+              <a:t>第四，归因保守且不完备：攻击尝试与良性触发只识别证据明确的部分，unknown占23.72%；取证报告也只涵盖已被发现并调查的成功攻击，无法补齐未知漏发现事件。第五，这是观察性研究：例如2011年前后设施升级和攻击数变化只能解释为相关，不能归为已证实因果效果。</a:t>
+            </a:r>
+          </a:p>
+          <a:p>
+            <a:r>
+              <a:t>第六，子分析样本有限：调查历时只有2016年后28起；小时级起始与发现分布分别88、91起；双日期延迟96起；Figure13仅3起。因此引用数字时需要同时保留样本、时间和统计单位。公开项目代码与一月样本有助于研究，但不等于全部私有数据都可复现。</a:t>
+            </a:r>
+          </a:p>
+          <a:p/>
+          <a:p>
+            <a:r>
+              <a:t>【来源与审校记录，不口播】</a:t>
+            </a:r>
+          </a:p>
+          <a:p>
+            <a:r>
+              <a:t>§3 PDF4–5/1527–1528；§5 PDF7–8/1530–1531；§8.3 PDF15–16/1538–1539；AppendixA PDF18–19/1541–1542。单站偏差、网络源下界、旧时段、归因不完备及小样本均保留。2011升级与事件数仅相关，原文明确不应因果。漏发现事件不在报告是从已知报告选择方式的汇报者方法论限定，不声称作者测出漏发现总数。公开一月样本不等于原始四年日志全可复现。</a:t>
             </a:r>
           </a:p>
         </p:txBody>
@@ -1094,22 +1170,33 @@
           <a:lstStyle/>
           <a:p>
             <a:r>
-              <a:t>【口播模板】</a:t>
-            </a:r>
-          </a:p>
-          <a:p>
-            <a:r>
-              <a:t>对当前研究，可以借鉴的是［方法层面的做法］：先定义对象与指标，再建立互补证据，并明确不确定性。迁移时需要满足［条件］，不能把这篇论文的具体结果直接套到其他场景。</a:t>
-            </a:r>
-          </a:p>
-          <a:p>
-            <a:r>
-              <a:t>【使用与来源提示，不口播】</a:t>
-            </a:r>
-          </a:p>
-          <a:p>
-            <a:r>
-              <a:t>本页是方法论借鉴模板，括号内容与示意数字均待真实材料替换，不是实测结果。核对当前论文、听众、授权与目标时长后改写；这里的来源/制作说明不口播。</a:t>
+              <a:t>【口播稿】</a:t>
+            </a:r>
+          </a:p>
+          <a:p>
+            <a:r>
+              <a:t>最后谈方法论借鉴，这是我对测量设计的归纳。第一，双数据源：海量自动日志描述规模，人工确认的取证事件提供事件证据，两者按IP和时间对齐，使系统输出与已知事件可以互相解释。第二，先定义标签语义：成功攻击、攻击尝试和良性触发之间的区别，说明简单的恶意/良性二分会掩盖重要中间状态；研究开展前，应先明确负样本和背景流量的含义。</a:t>
+            </a:r>
+          </a:p>
+          <a:p>
+            <a:r>
+              <a:t>第三，保守归因并呈现不确定性：不能判定的告警单列unknown，不为了得到完整分类而强行赋标签。第四，守住证据范围：观察性结果不自动写成因果，小样本探索不当成检测器性能验证。</a:t>
+            </a:r>
+          </a:p>
+          <a:p>
+            <a:r>
+              <a:t>可迁移的是这些实证分析方法。论文提供运营侧的告警图景，与算法侧WF防御研究可以互补看待，但NCSA的具体业务比例和告警规则不能直接迁移到我们的场景。</a:t>
+            </a:r>
+          </a:p>
+          <a:p/>
+          <a:p>
+            <a:r>
+              <a:t>【来源与审校记录，不口播】</a:t>
+            </a:r>
+          </a:p>
+          <a:p>
+            <a:r>
+              <a:t>本页为汇报者方法论归纳，参照§3数据源、§6.2分类、§7关联、§8讨论。WF连接是个人借鉴，非主论文的实验或作者验证结论；只迁移测量设计，不迁移具体SOC比例。移走【推】但保留“方法论借鉴”栏目及备注归属，不能伪装全部作者原话。</a:t>
             </a:r>
           </a:p>
         </p:txBody>
@@ -1179,22 +1266,33 @@
           <a:lstStyle/>
           <a:p>
             <a:r>
-              <a:t>【口播模板】</a:t>
-            </a:r>
-          </a:p>
-          <a:p>
-            <a:r>
-              <a:t>回到开场的三个问题，本文分别用［证据一］、［证据二］和［证据三］给出［对应回答］。最值得保留的认识是［核心结论］，适用范围是［关键边界］。谢谢大家，欢迎讨论。</a:t>
-            </a:r>
-          </a:p>
-          <a:p>
-            <a:r>
-              <a:t>【使用与来源提示，不口播】</a:t>
-            </a:r>
-          </a:p>
-          <a:p>
-            <a:r>
-              <a:t>本页是结语模板，括号内容与示意数字均待真实材料替换，不是实测结果。核对当前论文、听众、授权与目标时长后改写；这里的来源/制作说明不口播。</a:t>
+              <a:t>【口播稿】</a:t>
+            </a:r>
+          </a:p>
+          <a:p>
+            <a:r>
+              <a:t>收个尾。这篇研究用一个真实SOC的两段网络日志和20年的成功攻击取证报告，把告警过载转成了可追溯的测量结果。后期14,429,534条告警中，与已知成功攻击相关的条数占0.01%，已确认攻击尝试占27.37%，已确认良性触发占48.91%，unknown占23.72%，但未知不表示安全。</a:t>
+            </a:r>
+          </a:p>
+          <a:p>
+            <a:r>
+              <a:t>同一时期BHR自动处理44.9%，仍剩约1.4万条每天的非BHR处理余量；这提示工作压力，不等于实际逐条人工作业量。11起已知案例中，4起由用户或其他渠道发现，缺少攻击相关网络告警；另有两起Zeek发现事件的精确日志缺失，不能当成测得零。</a:t>
+            </a:r>
+          </a:p>
+          <a:p>
+            <a:r>
+              <a:t>作者认为运营瓶颈包括人工投入和数据可链接性，机器学习研究应重新审视标签语义，并探索稀有告警组合。这里的稀有模式仍是3案例的探索性线索。对我们，价值主要是双数据源、保守归因和相关性表述纪律这些测量方法。谢谢大家，欢迎讨论。</a:t>
+            </a:r>
+          </a:p>
+          <a:p/>
+          <a:p>
+            <a:r>
+              <a:t>【来源与审校记录，不口播】</a:t>
+            </a:r>
+          </a:p>
+          <a:p>
+            <a:r>
+              <a:t>摘要PDF2/1525；Table3 PDF8/1531；Table4 PDF9/1532；Table8 PDF13/1536；§7.2/§8 PDF14–16/1537–1539。新增正式清理授权覆盖16页，因此旧“范围外只登记第16页”限制已被本次追加的准确口播/限定整理替代：本页改为7/4渠道对应、缺失非零及非BHR记录余量，保持原数字模块结构。0.01%为后期已知事件相关告警条数比例；unknown非安全；稀有模式仅3样本。归纳句以作者发现/建议为基础，WF方法迁移为汇报者理解，无新增性能宣称。</a:t>
             </a:r>
           </a:p>
         </p:txBody>
@@ -1264,22 +1362,28 @@
           <a:lstStyle/>
           <a:p>
             <a:r>
-              <a:t>【口播模板】</a:t>
-            </a:r>
-          </a:p>
-          <a:p>
-            <a:r>
-              <a:t>这项研究由［作者与团队］完成。这里最相关的背景是［研究基础或合作条件］：它让作者能够获得［数据或设施］，并理解［领域上下文］。这也解释了本文为什么能回答后面的问题。</a:t>
-            </a:r>
-          </a:p>
-          <a:p>
-            <a:r>
-              <a:t>【使用与来源提示，不口播】</a:t>
-            </a:r>
-          </a:p>
-          <a:p>
-            <a:r>
-              <a:t>本页是作者与团队模板，括号内容与示意数字均待真实材料替换，不是实测结果。核对当前论文、听众、授权与目标时长后改写；这里的来源/制作说明不口播。</a:t>
+              <a:t>【口播稿】</a:t>
+            </a:r>
+          </a:p>
+          <a:p>
+            <a:r>
+              <a:t>论文的共同第一作者是Limin Yang和Zhi Chen，作者团队来自UIUC、NCSA和IBM Research。Limin Yang的博士导师是Gang Wang，研究背景包括机器学习安全与互联网测量，之前以第一作者参与了USENIX Security 2021的概念漂移检测工作CADE。NCSA安全团队提供了真实运营数据和组织上下文，团队中有一位成员隶属该SOC。右侧书目页面显示本论文条目，另一幅是NCSA机构网页。</a:t>
+            </a:r>
+          </a:p>
+          <a:p>
+            <a:r>
+              <a:t>由于数据敏感，研究通过了IRB审查。多数分析使用哈希IP，案例研究中的受限访问另有保护安排。作者公开了项目代码和Postgres案例当月的一份告警样本，含真实攻击、攻击尝试和良性触发标签；这不等于公开完整四年日志或所有私有取证材料。</a:t>
+            </a:r>
+          </a:p>
+          <a:p/>
+          <a:p>
+            <a:r>
+              <a:t>【来源与审校记录，不口播】</a:t>
+            </a:r>
+          </a:p>
+          <a:p>
+            <a:r>
+              <a:t>作者、机构与共一：PDF2/1525题名页及*脚注；原文未标单独通讯作者。数据合作/IRB/IP保护：§3 PDF4–5/1527–1528；共享范围：§8.3 PDF15–16/1538–1539。CADE书目信息由USENIX官方2021页面和主论文参考[79]交叉支持；作者博士导师/研究兴趣由其公开旧CV支持，均描述学术背景，不当成当前职位。原P02图片1已目视：dblp同名消歧页面，页面明确不代表单一真实人物，含本论文条目；不可称个人完整学术主页，也不能将页面其他同名作品归给本文作者。该dblpURL两次实时打开超时，搜索索引及原截图可见，原抓取日期未记录。NCSA原P02图片2已目视，机构官网实时内容可访问，不能称本轮重拍。外部精确链接在source_footers JSON。删除“开源全部代码”的满额口气，采用“公开项目代码”，样本一月、无IP和载荷，不承诺完整复现。</a:t>
             </a:r>
           </a:p>
         </p:txBody>
@@ -1349,22 +1453,23 @@
           <a:lstStyle/>
           <a:p>
             <a:r>
-              <a:t>【口播模板】</a:t>
-            </a:r>
-          </a:p>
-          <a:p>
-            <a:r>
-              <a:t>接下来先看研究场景与问题，再介绍总体方法和数据，随后用核心证据回答问题，最后讨论启示与边界。</a:t>
-            </a:r>
-          </a:p>
-          <a:p>
-            <a:r>
-              <a:t>【使用与来源提示，不口播】</a:t>
-            </a:r>
-          </a:p>
-          <a:p>
-            <a:r>
-              <a:t>本页是目录模板，括号内容与示意数字均待真实材料替换，不是实测结果。核对当前论文、听众、授权与目标时长后改写；这里的来源/制作说明不口播。</a:t>
+              <a:t>【口播稿】</a:t>
+            </a:r>
+          </a:p>
+          <a:p>
+            <a:r>
+              <a:t>汇报分四部分。第一是背景与概念，解释SOC、SIEM和告警分诊，并说明三个研究问题。第二是数据集与方法，介绍两段Zeek告警日志、227起成功攻击取证报告，以及真实攻击、攻击尝试和良性触发的定义与判定，无法归因的告警单列unknown。第三是核心量化发现：Postgres案例、告警体量、四分类组成、攻击尝试画像、告警与攻击关联，以及稀有主机模式的探索。第四是运营启示、研究局限和方法论借鉴，并区分测量结果、作者建议与个人归纳。</a:t>
+            </a:r>
+          </a:p>
+          <a:p/>
+          <a:p>
+            <a:r>
+              <a:t>【来源与审校记录，不口播】</a:t>
+            </a:r>
+          </a:p>
+          <a:p>
+            <a:r>
+              <a:t>目录为汇报者组织，据§1三个研究问题与§3–8论文主线，不是原文逐字目录。四原因分类保留unknown；一般FP定义单独说明，不把FP错作Table4第四类别。</a:t>
             </a:r>
           </a:p>
         </p:txBody>
@@ -1434,22 +1539,33 @@
           <a:lstStyle/>
           <a:p>
             <a:r>
-              <a:t>【口播模板】</a:t>
-            </a:r>
-          </a:p>
-          <a:p>
-            <a:r>
-              <a:t>先看［研究场景］。其中［对象］产生［可观察信息］，但仅靠这些信息还不能判断［目标问题］。因此本文提出三个问题：［问题一］、［问题二］和［问题三］。它们分别对应后面要建立的证据。</a:t>
-            </a:r>
-          </a:p>
-          <a:p>
-            <a:r>
-              <a:t>【使用与来源提示，不口播】</a:t>
-            </a:r>
-          </a:p>
-          <a:p>
-            <a:r>
-              <a:t>本页是研究场景与问题模板，括号内容与示意数字均待真实材料替换，不是实测结果。核对当前论文、听众、授权与目标时长后改写；这里的来源/制作说明不口播。</a:t>
+              <a:t>【口播稿】</a:t>
+            </a:r>
+          </a:p>
+          <a:p>
+            <a:r>
+              <a:t>先看Figure1中的SOC工作流。左侧汇集网络监控、主机日志、蜜罐和威胁情报等输入，SIEM在本文由Splunk实现；分析师做威胁分诊、检测和响应，再进行攻击后的取证。响应与取证获得的新信息又反馈到检测和规则中。BHR是黑洞路由器，负责按规则自动阻断相关IP。绿色模块标出本文主要数据来源，本文并没有获得全部主机侧及商业工具告警。</a:t>
+            </a:r>
+          </a:p>
+          <a:p>
+            <a:r>
+              <a:t>SOC是安全运营中心；SIEM是聚合安全信息并提供事件视图的平台；IDS是入侵检测系统；triage就是对告警筛查、判断并决定升级或响应。本文没有披露这个SOC完整的告警等级、阈值或处置SLA。</a:t>
+            </a:r>
+          </a:p>
+          <a:p>
+            <a:r>
+              <a:t>已有用户研究讨论告警过载与分析师疲劳，但还缺乏定量认识。因此三个问题是：SOC威胁检测的关键瓶颈是什么，攻击者如何利用或响应这些瓶颈；告警到底过量到什么程度，常见触发原因是什么；告警能在多大程度上关联或指示成功攻击。</a:t>
+            </a:r>
+          </a:p>
+          <a:p/>
+          <a:p>
+            <a:r>
+              <a:t>【来源与审校记录，不口播】</a:t>
+            </a:r>
+          </a:p>
+          <a:p>
+            <a:r>
+              <a:t>§1 RQ1/2/3在PDF2/1525；§2在PDF3–4/1526–1527；§3 Figure1在PDF4/1527。工作流包含反馈，绿色框为本文主要数据来源；SIEM具体Splunk见§3。SOC/IDS/SIEM/triage中文解释为教学转述。系统severity/分析师优先级/本文触发原因不同，原文未给本SOC分级阈值或SLA；不得补造。Target与疲劳是主论文引用前作的背景，未独立核验Target调查报告全文，不宣称本文测出过载因果。</a:t>
             </a:r>
           </a:p>
         </p:txBody>
@@ -1519,22 +1635,33 @@
           <a:lstStyle/>
           <a:p>
             <a:r>
-              <a:t>【口播模板】</a:t>
-            </a:r>
-          </a:p>
-          <a:p>
-            <a:r>
-              <a:t>为回答这些问题，作者使用［数据源A］与［数据源B］。前者提供［信息A］，后者提供［信息B］。通过［处理与对齐条件］，作者得到［输出证据］。理解这条总体思路后，再看两组数据的规模与边界。</a:t>
-            </a:r>
-          </a:p>
-          <a:p>
-            <a:r>
-              <a:t>【使用与来源提示，不口播】</a:t>
-            </a:r>
-          </a:p>
-          <a:p>
-            <a:r>
-              <a:t>本页是总体方法与数据模板，括号内容与示意数字均待真实材料替换，不是实测结果。核对当前论文、听众、授权与目标时长后改写；这里的来源/制作说明不口播。</a:t>
+              <a:t>【口播稿】</a:t>
+            </a:r>
+          </a:p>
+          <a:p>
+            <a:r>
+              <a:t>数据来自两个渠道。第一是NCSA SOC的Zeek网络告警：2018年4月至2020年8月和2020年12月至2022年7月两段，共1,329个有数据日、115,617,526条告警。每条有时间戳、涉及IP、类别和元数据。后期的BHR自动阻断记录为识别部分攻击尝试提供依据。本文未获得主机IDS、其他站点和商业工具的全部告警，因此网络日志只是这个SOC总告警量的下界。</a:t>
+            </a:r>
+          </a:p>
+          <a:p>
+            <a:r>
+              <a:t>第二是2002年1月至2022年3月的227起已知成功攻击取证报告，其中11起落在告警日志重叠期。成功攻击指发生系统失陷、数据泄漏，或者对系统运行造成重大降级或中断。两名研究人员用一到两个月将非结构化报告编码成事件信息和相关MITRE ATT&amp;CK技术。</a:t>
+            </a:r>
+          </a:p>
+          <a:p>
+            <a:r>
+              <a:t>研究场景是数千服务器、一万七千多活跃用户和9名SOC成员的科研设施。部分网络严格隔离，部分向内部和外部研究者开放，合法连接和恶意连接都可能来自不同地方。这种业务环境有研究价值，但不能直接代表所有企业SOC。取证报告也只记录已被发现并调查的成功攻击。</a:t>
+            </a:r>
+          </a:p>
+          <a:p/>
+          <a:p>
+            <a:r>
+              <a:t>【来源与审校记录，不口播】</a:t>
+            </a:r>
+          </a:p>
+          <a:p>
+            <a:r>
+              <a:t>§3 PDF4–5/1527–1528；Table3 PDF8/1531；编码时间§5 PDF7/1530、AppendixA PDF18/1541。两时期751/578日，不是连续四年；网络告警是全部SOC来源的下界；227是已发现且取证成功攻击，11重叠。原制作纠错段及错误数字仅在这里保留核查记录：旧稿“566”无本论文依据，不上屏、不口播；口播只正常报227/11。9人是本SOC人数，2–10为论文转述常见规模区间，不能说9是所有SOC固定规模。</a:t>
             </a:r>
           </a:p>
         </p:txBody>
@@ -1604,22 +1731,33 @@
           <a:lstStyle/>
           <a:p>
             <a:r>
-              <a:t>【口播模板】</a:t>
-            </a:r>
-          </a:p>
-          <a:p>
-            <a:r>
-              <a:t>在统计之前，先把定义说清楚。［类别A］根据［判定条件A］识别，［类别B］根据［判定条件B］识别；证据不足的对象则按［处理规则］保留。这样，后面的数字才有一致的含义。</a:t>
-            </a:r>
-          </a:p>
-          <a:p>
-            <a:r>
-              <a:t>【使用与来源提示，不口播】</a:t>
-            </a:r>
-          </a:p>
-          <a:p>
-            <a:r>
-              <a:t>本页是定义与判定模板，括号内容与示意数字均待真实材料替换，不是实测结果。核对当前论文、听众、授权与目标时长后改写；这里的来源/制作说明不口播。</a:t>
+              <a:t>【口播稿】</a:t>
+            </a:r>
+          </a:p>
+          <a:p>
+            <a:r>
+              <a:t>先区分三个概念。True attack是真实成功攻击，攻击者成功使系统失陷或造成损害。Attack attempt是攻击尝试，发起了恶意行为，但未成功失陷系统或造成损害。Benign trigger是良性触发：规则命中了真实事件，但组织业务环境给出合理解释，SOC可安全忽略。例如弱SSL密钥的告警本身正确，但相关主机即将退役且已与公网隔离。</a:t>
+            </a:r>
+          </a:p>
+          <a:p>
+            <a:r>
+              <a:t>良性触发与一般误报不同，一般误报是良性行为被错误判成攻击。判定依据也不同：成功攻击由取证报告支持；攻击尝试主要通过保守BHR阻断规则识别，并剔除其中的良性触发；良性触发由两名SOC分析师逐类别核查、结合上下文和白名单确认。后两种识别只纳入证据明确的部分，因此是已确认范围的下界。</a:t>
+            </a:r>
+          </a:p>
+          <a:p>
+            <a:r>
+              <a:t>剩余23.72%原因不能可靠判定，单列unknown。它不表示已确认安全，可能混含尚未识别的攻击尝试、良性触发、误报，甚至未发现的成功攻击。因此不是把所有非成功攻击告警都自动当成误报。</a:t>
+            </a:r>
+          </a:p>
+          <a:p/>
+          <a:p>
+            <a:r>
+              <a:t>【来源与审校记录，不口播】</a:t>
+            </a:r>
+          </a:p>
+          <a:p>
+            <a:r>
+              <a:t>Table1 PDF4/1527；§6.2 PDF9/1532；§6.4 PDF11–12/1534–1535及AppendixC/Table9 PDF19/1542。BHR阻断量44.9%含良性，剔除约17.50个百分点后对应27.37%；三个百分数为舍入，44.9−17.50未精确等于27.37不应写成精确等式。下界为保守业务识别，非统计置信界。Table4第四类别是unknown，FP作为定义区别而非四分类额外第五块。取证定义成功，不涵盖全部潜在漏发现事件。</a:t>
             </a:r>
           </a:p>
         </p:txBody>
@@ -1689,22 +1827,33 @@
           <a:lstStyle/>
           <a:p>
             <a:r>
-              <a:t>【口播模板】</a:t>
-            </a:r>
-          </a:p>
-          <a:p>
-            <a:r>
-              <a:t>我们用［案例名称］把前面的方法串起来。最初处于［阶段A］，随后出现［阶段B的变化］，最后得到［阶段C的结果］。这说明［案例支持的认识］，但这一例还不能直接代表整体情况。</a:t>
-            </a:r>
-          </a:p>
-          <a:p>
-            <a:r>
-              <a:t>【使用与来源提示，不口播】</a:t>
-            </a:r>
-          </a:p>
-          <a:p>
-            <a:r>
-              <a:t>本页是案例过程模板，括号内容与示意数字均待真实材料替换，不是实测结果。核对当前论文、听众、授权与目标时长后改写；这里的来源/制作说明不口播。</a:t>
+              <a:t>【口播稿】</a:t>
+            </a:r>
+          </a:p>
+          <a:p>
+            <a:r>
+              <a:t>先看2021年11月的Postgres案例。攻击者在11月10日凌晨3点42分通过一个未设密码的账号连接内部服务器，3点44分下载三个文件，至少一个后来确认是恶意文件。根因是Postgres认证配置不当。</a:t>
+            </a:r>
+          </a:p>
+          <a:p>
+            <a:r>
+              <a:t>当次主机初始失陷前及过程中，没有网络告警。第一条告警出现在3点44分，因为失陷主机在5秒内扫描了250个外部主机。从3点44分到7点11分，共有1,101条告警，其中主机D关联1,100条、攻击者IP关联1条；1,069条是HTTP basic access authentication。作者用每主机4小时窗口作参照，平均仅0.14条、标准差12.65，主机D明显偏离背景。</a:t>
+            </a:r>
+          </a:p>
+          <a:p>
+            <a:r>
+              <a:t>7点11分分析师发现事件并封禁主机，8点10分确认恶意文件。为获取日志和主机快照还需要其他团队协助，快照到12月23日才恢复。回溯还发现，约一个月前同一来源在五个不同日期扫描至少175台主机，曾触发五条告警，说明早期线索存在，但本次初始失陷没有告警。这个案例展示了失陷后行为与初始失陷之间的监测差别，也展示了后续取证的时间成本。</a:t>
+            </a:r>
+          </a:p>
+          <a:p/>
+          <a:p>
+            <a:r>
+              <a:t>【来源与审校记录，不口播】</a:t>
+            </a:r>
+          </a:p>
+          <a:p>
+            <a:r>
+              <a:t>§4 PDF5–6/1528–1529 Figure2，AppendixB PDF19/1542支撑1,069 HTTP条。失陷03:42、第一条03:44、响应07:11、文件确认08:10；快照12/23。1,101=主机D1,100+攻击者IP1；均值0.14/SD12.65是每主机4小时窗口，异常比较对象为D的1,100，不是把所有1,101都当单主机。约一月前五次扫描/五日期/至少175主机/五条告警，故不能讲历史完全无预警。根因段明确认证misconfiguration及未设密码；Figure2原caption虽用vulnerability，不足以确认为软件0-day。口播自然说认证配置不当，不把图注与正文差异的纠错过程上屏。个案不能证明所有攻击初始失陷都无告警。</a:t>
             </a:r>
           </a:p>
         </p:txBody>
@@ -1774,22 +1923,68 @@
           <a:lstStyle/>
           <a:p>
             <a:r>
-              <a:t>【口播模板】</a:t>
-            </a:r>
-          </a:p>
-          <a:p>
-            <a:r>
-              <a:t>先看整体规模与变化。［指标］在［时期A］为［数值A］，在［时期B］为［数值B］，统计单位和窗口分别是［口径］。结合［来源支持的解释］，这组证据回答了前面的［研究问题］。</a:t>
-            </a:r>
-          </a:p>
-          <a:p>
-            <a:r>
-              <a:t>【使用与来源提示，不口播】</a:t>
-            </a:r>
-          </a:p>
-          <a:p>
-            <a:r>
-              <a:t>本页是规模与变化模板，括号内容与示意数字均待真实材料替换，不是实测结果。核对当前论文、听众、授权与目标时长后改写；这里的来源/制作说明不口播。</a:t>
+              <a:t>【口播稿】</a:t>
+            </a:r>
+          </a:p>
+          <a:p>
+            <a:r>
+              <a:t>第一点是告警体量。Figure8分别绘制两段日志，纵轴刻度不同，不能直接按曲线高度比较。前期2018年4月至2020年8月，751日、101,187,992条，日均</a:t>
+            </a:r>
+            <a:r>
+              <a:rPr b="1"/>
+              <a:t>134,738</a:t>
+            </a:r>
+            <a:r>
+              <a:t>条；后期2020年12月至2022年7月，578日、14,429,534条，日均</a:t>
+            </a:r>
+            <a:r>
+              <a:rPr b="1"/>
+              <a:t>24,965</a:t>
+            </a:r>
+            <a:r>
+              <a:t>条。两段合计1,329日、</a:t>
+            </a:r>
+            <a:r>
+              <a:rPr b="1"/>
+              <a:t>115,617,526</a:t>
+            </a:r>
+            <a:r>
+              <a:t>条，日均86,996条。这两个时期均值不是每天告警量的上下限。</a:t>
+            </a:r>
+          </a:p>
+          <a:p>
+            <a:r>
+              <a:t>后期BHR和防火墙规则自动处理6,474,204条，占该期</a:t>
+            </a:r>
+            <a:r>
+              <a:rPr b="1"/>
+              <a:t>44.9%</a:t>
+            </a:r>
+            <a:r>
+              <a:t>，不用人工实时介入。BHR处理量既有高置信攻击尝试，也含已知良性触发。扣除后剩余约</a:t>
+            </a:r>
+            <a:r>
+              <a:rPr b="1"/>
+              <a:t>13,764</a:t>
+            </a:r>
+            <a:r>
+              <a:t>条每天，这是非BHR自动处理的记录余量，作者据此讨论分析师压力；它不是实际逐条人工审阅量，更不是劳动工时。</a:t>
+            </a:r>
+          </a:p>
+          <a:p>
+            <a:r>
+              <a:t>2018年初峰值与Mirai新变种的大量地址扫描有关；2022年初与Log4j扫描及内部日志系统告警有关，合法外部渗透测试也是相关背景。两时期规则和自动化都在变化，因此观察到的下降不能单独归因于BHR，也不能解释为攻击量一定减少。作者强调，告警数量大且方差高，使排班和工作分配困难。</a:t>
+            </a:r>
+          </a:p>
+          <a:p/>
+          <a:p>
+            <a:r>
+              <a:t>【来源与审校记录，不口播】</a:t>
+            </a:r>
+          </a:p>
+          <a:p>
+            <a:r>
+              <a:t>Table3/§6.1/Remark3 PDF8/1531；Figure8 PDF9/1532；§6.4 PDF12/1535。两时期纵轴不同；日均134,738/24,965非上下限。6,474,204/14,429,534≈44.9%；非BHR余量7,955,330/578≈13,764条/日，由原数量推算且与作者报告一致，不是人工审阅实测或人时。自动化和规则变化共存，观察下降不证明BHR单独因果效果。Log4j具体披露月份不进入本轮口播；原论文脚注历史月份未独立核验，避免扩大疑点。</a:t>
             </a:r>
           </a:p>
         </p:txBody>
@@ -1859,22 +2054,38 @@
           <a:lstStyle/>
           <a:p>
             <a:r>
-              <a:t>【口播模板】</a:t>
-            </a:r>
-          </a:p>
-          <a:p>
-            <a:r>
-              <a:t>再看分类与来源。［主要类别］之间的差异说明［发现］。下方来源图帮助解释这些差异来自哪里；其中［重叠或选列范围］需要保留。这些记录的多少与其业务含义要分开理解。</a:t>
-            </a:r>
-          </a:p>
-          <a:p>
-            <a:r>
-              <a:t>【使用与来源提示，不口播】</a:t>
-            </a:r>
-          </a:p>
-          <a:p>
-            <a:r>
-              <a:t>本页是分类与来源模板，括号内容与示意数字均待真实材料替换，不是实测结果。核对当前论文、听众、授权与目标时长后改写；这里的来源/制作说明不口播。</a:t>
+              <a:t>【口播稿】</a:t>
+            </a:r>
+          </a:p>
+          <a:p>
+            <a:r>
+              <a:t>第二点看后期14,429,534条告警为什么触发，时间窗是2020年12月至2022年7月。与已知成功攻击相关的有1,114条，占0.01%；已确认攻击尝试3,948,645条，占27.37%；已确认良性触发7,057,012条，占48.91%；原因未知3,422,763条，占23.72%。0.01%是告警条数占比，经四舍五入，不是攻击事件比例、攻击成功率或检测召回率。unknown不能看作安全，其中可能混含其他类别甚至未发现的成功攻击。</a:t>
+            </a:r>
+          </a:p>
+          <a:p>
+            <a:r>
+              <a:t>良性触发指规则匹配正确，但业务背景提供了可以接受的解释。其识别采取保守规则和人工上下文核查，因此48.91%是已确认的范围。本页横条图选列四类主要良性来源，按告警数量从高到低排列：外部渗透测试和合规审计2,694,851条，多于Zeek日志故障2,553,794条；外部域名对应本地IP1,407,151条；内部合法扫描194,518条。完整表还列出其他DNS、SSL和新增IP空间等原因。精简展示仅选列主要来源，并非全集。</a:t>
+            </a:r>
+          </a:p>
+          <a:p>
+            <a:r>
+              <a:t>Table7各子项可重叠，例如内部扫描也可能包含DNS或SSL告警；7,057,012是并集，不能将子项求和作总量，也不能把横向条形理解为互斥份额。外部渗透测试中92%与2022年初Log4j有关。作者另调查了384个触发扫描告警的内部IP，最初列为unknown；部分是爬虫或未充分记录的扫描器，但不能据此把全部384个确认为合法来源。</a:t>
+            </a:r>
+          </a:p>
+          <a:p>
+            <a:r>
+              <a:t>对机器学习研究，作者提醒攻击尝试和良性触发具有类似恶意活动的模式，直接放入简单的良性/恶意二元标签可能产生噪声。这是对问题设定的分析，不是本文训练新模型验证的性能结论。</a:t>
+            </a:r>
+          </a:p>
+          <a:p/>
+          <a:p>
+            <a:r>
+              <a:t>【来源与审校记录，不口播】</a:t>
+            </a:r>
+          </a:p>
+          <a:p>
+            <a:r>
+              <a:t>Table4/§6.2 PDF9/1532；Table7/§6.4 PDF11–12/1534–1535；AppendixC/Table9 PDF19/1542；§8.1 PDF14–15/1537–1538。四分类用P09_data JSON；分母14,429,534为后期；0.01%为四舍五入的告警条数占比，不是事件率/recall。Table7 union7,057,012，12子项和7,084,278不应冒充总量。B/C同四项选列非全集，外部渗测2,694,851大于日志故障2,553,794。384IP初始unknown，部分例子不可扩成全体合法；92%只针对外部渗测告警。Remark6的23.77%与Table4的23.72%原文冲突，屏幕/口播按Table4计数；不在现场讲纠错。作者ML标签噪声论断是问题设定分析，无本研究新模型训练性能。用户已选择C方案：原生可编辑横条图，四项仅为主要来源选列，不代表全集或互斥份额。</a:t>
             </a:r>
           </a:p>
         </p:txBody>
@@ -2111,7 +2322,7 @@
                 <a:ea typeface="Times New Roman" panose="02020603050405020304"/>
                 <a:cs typeface="Times New Roman" panose="02020603050405020304"/>
               </a:rPr>
-              <a:t>RESEARCH PRESENTATION · EDITABLE TEMPLATE</a:t>
+              <a:t>USENIX SECURITY 2024 · MEASUREMENT STUDY · SOC ALERTS</a:t>
             </a:r>
             <a:endParaRPr sz="1120" spc="225">
               <a:solidFill>
@@ -2161,7 +2372,7 @@
                 <a:ea typeface="Times New Roman" panose="02020603050405020304"/>
                 <a:cs typeface="Times New Roman" panose="02020603050405020304"/>
               </a:rPr>
-              <a:t>论文英文题名</a:t>
+              <a:t>True Attacks, Attack Attempts,</a:t>
             </a:r>
             <a:endParaRPr sz="3890" b="1" spc="22">
               <a:solidFill>
@@ -2211,7 +2422,7 @@
                 <a:ea typeface="Times New Roman" panose="02020603050405020304"/>
                 <a:cs typeface="Times New Roman" panose="02020603050405020304"/>
               </a:rPr>
-              <a:t>或研究主题副标题</a:t>
+              <a:t>or Benign Triggers?</a:t>
             </a:r>
             <a:endParaRPr sz="3890" b="1" spc="22">
               <a:solidFill>
@@ -2261,7 +2472,7 @@
                 <a:ea typeface="微软雅黑" panose="020B0503020204020204" charset="-122"/>
                 <a:cs typeface="微软雅黑" panose="020B0503020204020204" charset="-122"/>
               </a:rPr>
-              <a:t>中文题名：研究对象、核心问题与范围</a:t>
+              <a:t>对一个安全运营中心（SOC）网络告警的实证测量 —— 2018—2022两段1.15亿条告警与20年227起已知成功攻击</a:t>
             </a:r>
             <a:endParaRPr sz="1720" spc="22">
               <a:solidFill>
@@ -2311,7 +2522,7 @@
                 <a:ea typeface="微软雅黑" panose="020B0503020204020204" charset="-122"/>
                 <a:cs typeface="微软雅黑" panose="020B0503020204020204" charset="-122"/>
               </a:rPr>
-              <a:t>论文作者：[填写作者]</a:t>
+              <a:t>Limin Yang*, Zhi Chen*（共同第一作者）, Chenkai Wang, Zhenning Zhang, Sushruth Booma, Phuong Cao, Constantin Adam, Alexander Withers, Zbigniew Kalbarczyk, Ravishankar K. Iyer, Gang Wang</a:t>
             </a:r>
             <a:endParaRPr sz="1270">
               <a:solidFill>
@@ -2337,7 +2548,7 @@
                 <a:ea typeface="微软雅黑" panose="020B0503020204020204" charset="-122"/>
                 <a:cs typeface="微软雅黑" panose="020B0503020204020204" charset="-122"/>
               </a:rPr>
-              <a:t>研究机构：[填写机构]</a:t>
+              <a:t>UIUC · NCSA · IBM Research</a:t>
             </a:r>
             <a:endParaRPr sz="1270">
               <a:solidFill>
@@ -2387,7 +2598,7 @@
                 <a:ea typeface="微软雅黑" panose="020B0503020204020204" charset="-122"/>
                 <a:cs typeface="微软雅黑" panose="020B0503020204020204" charset="-122"/>
               </a:rPr>
-              <a:t>研究定位：[说明论文类型、核心贡献与证据范围]</a:t>
+              <a:t>实证测量论文：不提出新攻击/防御算法，量化回答"告警中有多少真信号"</a:t>
             </a:r>
             <a:endParaRPr sz="1190" spc="75">
               <a:solidFill>
@@ -2499,7 +2710,7 @@
                 <a:ea typeface="微软雅黑" panose="020B0503020204020204" charset="-122"/>
                 <a:cs typeface="微软雅黑" panose="020B0503020204020204" charset="-122"/>
               </a:rPr>
-              <a:t>汇报人：[填写姓名]</a:t>
+              <a:t>汇报人：填写姓名 · 单位：填写单位</a:t>
             </a:r>
             <a:endParaRPr sz="1190">
               <a:solidFill>
@@ -2525,7 +2736,7 @@
                 <a:ea typeface="微软雅黑" panose="020B0503020204020204" charset="-122"/>
                 <a:cs typeface="微软雅黑" panose="020B0503020204020204" charset="-122"/>
               </a:rPr>
-              <a:t>报告日期：[填写日期]</a:t>
+              <a:t>研究汇报 · 填写日期</a:t>
             </a:r>
             <a:endParaRPr sz="1190">
               <a:solidFill>
@@ -2575,7 +2786,7 @@
                 <a:ea typeface="Times New Roman" panose="02020603050405020304"/>
                 <a:cs typeface="Times New Roman" panose="02020603050405020304"/>
               </a:rPr>
-              <a:t>RESEARCH TALK · 01 / 16</a:t>
+              <a:t>SOC ALERTS · 01 / 16</a:t>
             </a:r>
             <a:endParaRPr sz="1120" spc="150">
               <a:solidFill>
@@ -2625,7 +2836,7 @@
                 <a:ea typeface="微软雅黑" panose="020B0503020204020204" charset="-122"/>
                 <a:cs typeface="微软雅黑" panose="020B0503020204020204" charset="-122"/>
               </a:rPr>
-              <a:t>占位模板，无研究结果。新稿填写真实来源。</a:t>
+              <a:t>来源：Yang et al., USENIX Security 2024，首页、摘要、§3、Table 3。</a:t>
             </a:r>
             <a:endParaRPr sz="1040">
               <a:solidFill>
@@ -2707,12 +2918,18 @@
           </a:fontRef>
         </p:style>
       </p:cxnSp>
-      <p:sp>
-        <p:nvSpPr>
-          <p:cNvPr id="2000" name="Editable evidence placeholder"/>
-          <p:cNvSpPr txBox="1"/>
-          <p:nvPr/>
-        </p:nvSpPr>
+      <p:pic>
+        <p:nvPicPr>
+          <p:cNvPr id="3" name="el-1791698029399-8"/>
+          <p:cNvPicPr/>
+          <p:nvPr/>
+        </p:nvPicPr>
+        <p:blipFill>
+          <a:blip r:embed="rId1"/>
+          <a:stretch>
+            <a:fillRect/>
+          </a:stretch>
+        </p:blipFill>
         <p:spPr>
           <a:xfrm>
             <a:off x="685629" y="1867808"/>
@@ -2721,33 +2938,14 @@
           <a:prstGeom prst="rect">
             <a:avLst/>
           </a:prstGeom>
-          <a:solidFill>
-            <a:srgbClr val="F3F5F8"/>
-          </a:solidFill>
-          <a:ln w="9525">
+          <a:ln w="9523" algn="in">
             <a:solidFill>
               <a:srgbClr val="D8DDE3"/>
             </a:solidFill>
-          </a:ln>
-        </p:spPr>
-        <p:txBody>
-          <a:bodyPr anchor="ctr"/>
-          <a:lstStyle/>
-          <a:p>
-            <a:pPr algn="ctr"/>
-            <a:r>
-              <a:rPr lang="zh-CN" sz="1800">
-                <a:solidFill>
-                  <a:srgbClr val="5A6472"/>
-                </a:solidFill>
-                <a:latin typeface="Times New Roman"/>
-                <a:ea typeface="微软雅黑"/>
-              </a:rPr>
-              <a:t>研究证据图占位</a:t>
-            </a:r>
-          </a:p>
-        </p:txBody>
-      </p:sp>
+            <a:prstDash val="solid"/>
+          </a:ln>
+        </p:spPr>
+      </p:pic>
       <p:cxnSp>
         <p:nvCxnSpPr>
           <p:cNvPr id="4" name="el-1791698029401-13"/>
@@ -3049,7 +3247,7 @@
                 <a:ea typeface="Times New Roman" panose="02020603050405020304"/>
                 <a:cs typeface="Times New Roman" panose="02020603050405020304"/>
               </a:rPr>
-              <a:t>03 · 核心证据 / 对象特征</a:t>
+              <a:t>03 · 核心发现 / 3.3 攻击尝试画像</a:t>
             </a:r>
             <a:endParaRPr sz="1120" spc="150">
               <a:solidFill>
@@ -3099,7 +3297,7 @@
                 <a:ea typeface="Times New Roman" panose="02020603050405020304"/>
                 <a:cs typeface="Times New Roman" panose="02020603050405020304"/>
               </a:rPr>
-              <a:t>发现三：对象特征与分布差异</a:t>
+              <a:t>发现③：27.37% 的告警是"没得手的攻击"</a:t>
             </a:r>
             <a:endParaRPr sz="2990" b="1">
               <a:solidFill>
@@ -3149,7 +3347,7 @@
                 <a:ea typeface="微软雅黑" panose="020B0503020204020204" charset="-122"/>
                 <a:cs typeface="微软雅黑" panose="020B0503020204020204" charset="-122"/>
               </a:rPr>
-              <a:t>特征证据位：分布或比较图</a:t>
+              <a:t>论文 Figure 9（攻击者活跃天数 CDF）/ Figure 10（受害者告警集中度）</a:t>
             </a:r>
             <a:endParaRPr sz="970">
               <a:solidFill>
@@ -3199,7 +3397,7 @@
                 <a:ea typeface="Times New Roman" panose="02020603050405020304"/>
                 <a:cs typeface="Times New Roman" panose="02020603050405020304"/>
               </a:rPr>
-              <a:t>规模</a:t>
+              <a:t>721,169</a:t>
             </a:r>
             <a:endParaRPr sz="2090" b="1">
               <a:solidFill>
@@ -3249,7 +3447,7 @@
                 <a:ea typeface="微软雅黑" panose="020B0503020204020204" charset="-122"/>
                 <a:cs typeface="微软雅黑" panose="020B0503020204020204" charset="-122"/>
               </a:rPr>
-              <a:t>填写对象数量、统计单位与覆盖范围。</a:t>
+              <a:t>被封禁的外部攻击者 IP，来自 </a:t>
             </a:r>
             <a:r>
               <a:rPr sz="1120" b="1">
@@ -3260,7 +3458,7 @@
                 <a:ea typeface="微软雅黑" panose="020B0503020204020204" charset="-122"/>
                 <a:cs typeface="微软雅黑" panose="020B0503020204020204" charset="-122"/>
               </a:rPr>
-              <a:t/>
+              <a:t>223 个国家/地区</a:t>
             </a:r>
             <a:r>
               <a:rPr sz="1120">
@@ -3271,7 +3469,7 @@
                 <a:ea typeface="微软雅黑" panose="020B0503020204020204" charset="-122"/>
                 <a:cs typeface="微软雅黑" panose="020B0503020204020204" charset="-122"/>
               </a:rPr>
-              <a:t/>
+              <a:t>；Top5：中国、美国、印度、巴西、德国</a:t>
             </a:r>
             <a:endParaRPr sz="1120">
               <a:solidFill>
@@ -3321,7 +3519,7 @@
                 <a:ea typeface="Times New Roman" panose="02020603050405020304"/>
                 <a:cs typeface="Times New Roman" panose="02020603050405020304"/>
               </a:rPr>
-              <a:t>组成</a:t>
+              <a:t>96.7%</a:t>
             </a:r>
             <a:endParaRPr sz="2090" b="1">
               <a:solidFill>
@@ -3371,7 +3569,7 @@
                 <a:ea typeface="微软雅黑" panose="020B0503020204020204" charset="-122"/>
                 <a:cs typeface="微软雅黑" panose="020B0503020204020204" charset="-122"/>
               </a:rPr>
-              <a:t>填写主要类型及各自定义。</a:t>
+              <a:t>前三类扫描合计96.7%（按条数计算）；其余为SSH口令猜测及可疑客户端。</a:t>
             </a:r>
             <a:endParaRPr sz="1120">
               <a:solidFill>
@@ -3421,7 +3619,7 @@
                 <a:ea typeface="Times New Roman" panose="02020603050405020304"/>
                 <a:cs typeface="Times New Roman" panose="02020603050405020304"/>
               </a:rPr>
-              <a:t>分布</a:t>
+              <a:t>75%</a:t>
             </a:r>
             <a:endParaRPr sz="2090" b="1">
               <a:solidFill>
@@ -3471,7 +3669,7 @@
                 <a:ea typeface="微软雅黑" panose="020B0503020204020204" charset="-122"/>
                 <a:cs typeface="微软雅黑" panose="020B0503020204020204" charset="-122"/>
               </a:rPr>
-              <a:t>说明典型对象与少数特殊对象的差异。</a:t>
+              <a:t>约75%的来源IP仅活跃1日；最活跃者累计573日，后来确认是未记录的SOC测试扫描器。</a:t>
             </a:r>
             <a:endParaRPr sz="1120">
               <a:solidFill>
@@ -3521,7 +3719,7 @@
                 <a:ea typeface="Times New Roman" panose="02020603050405020304"/>
                 <a:cs typeface="Times New Roman" panose="02020603050405020304"/>
               </a:rPr>
-              <a:t>规律</a:t>
+              <a:t>66.22%</a:t>
             </a:r>
             <a:endParaRPr sz="2090" b="1">
               <a:solidFill>
@@ -3571,7 +3769,7 @@
                 <a:ea typeface="微软雅黑" panose="020B0503020204020204" charset="-122"/>
                 <a:cs typeface="微软雅黑" panose="020B0503020204020204" charset="-122"/>
               </a:rPr>
-              <a:t>解释指标如何计算，以及它不能证明什么。</a:t>
+              <a:t>足够连接的子集中，连接间隔具有botnet启发式规律性（Ljung–Box，p&lt;0.05）；非独立真值。</a:t>
             </a:r>
             <a:endParaRPr sz="1120">
               <a:solidFill>
@@ -3621,7 +3819,7 @@
                 <a:ea typeface="微软雅黑" panose="020B0503020204020204" charset="-122"/>
                 <a:cs typeface="微软雅黑" panose="020B0503020204020204" charset="-122"/>
               </a:rPr>
-              <a:t>说明图中差异如何回应研究问题，保留样本和比较条件。</a:t>
+              <a:t>受害端极不均衡：1,576个IP（2.3%）关联55%告警；部分高告警主机提供公网服务。每主机后期中位数203条，挑战per-host预测。</a:t>
             </a:r>
             <a:endParaRPr sz="1120" b="1">
               <a:solidFill>
@@ -3671,7 +3869,7 @@
                 <a:ea typeface="微软雅黑" panose="020B0503020204020204" charset="-122"/>
                 <a:cs typeface="微软雅黑" panose="020B0503020204020204" charset="-122"/>
               </a:rPr>
-              <a:t>占位模板，无研究结果。新稿填写真实来源。</a:t>
+              <a:t>来源：Yang et al., USENIX Security 2024，§6.3、Table 5、Figures 9–12。</a:t>
             </a:r>
             <a:endParaRPr sz="1040">
               <a:solidFill>
@@ -3938,7 +4136,7 @@
                 <a:ea typeface="Times New Roman" panose="02020603050405020304"/>
                 <a:cs typeface="Times New Roman" panose="02020603050405020304"/>
               </a:rPr>
-              <a:t>03 · 核心证据 / 系统输出</a:t>
+              <a:t>03 · 核心发现 / 3.4 告警 × 真实攻击</a:t>
             </a:r>
             <a:endParaRPr sz="1120" spc="150">
               <a:solidFill>
@@ -3988,7 +4186,7 @@
                 <a:ea typeface="Times New Roman" panose="02020603050405020304"/>
                 <a:cs typeface="Times New Roman" panose="02020603050405020304"/>
               </a:rPr>
-              <a:t>证据表、关键状态与解释</a:t>
+              <a:t>发现④：11起真实攻击的告警与发现渠道</a:t>
             </a:r>
             <a:endParaRPr sz="2990" b="1">
               <a:solidFill>
@@ -4038,7 +4236,7 @@
                 <a:ea typeface="微软雅黑" panose="020B0503020204020204" charset="-122"/>
                 <a:cs typeface="微软雅黑" panose="020B0503020204020204" charset="-122"/>
               </a:rPr>
-              <a:t>占位模板，无研究结果。新稿填写准确来源。</a:t>
+              <a:t>来源：Yang et al., USENIX Security 2024，§7.1、Table 8。 中文表据Table 8摘编。</a:t>
             </a:r>
             <a:endParaRPr sz="1040">
               <a:solidFill>
@@ -4201,7 +4399,7 @@
                           <a:ea typeface="微软雅黑" panose="020B0503020204020204" charset="-122"/>
                           <a:cs typeface="微软雅黑" panose="020B0503020204020204" charset="-122"/>
                         </a:rPr>
-                        <a:t>记录/事件</a:t>
+                        <a:t>事件ID及简写</a:t>
                       </a:r>
                       <a:endParaRPr sz="1275" b="1">
                         <a:solidFill>
@@ -4260,7 +4458,7 @@
                           <a:ea typeface="微软雅黑" panose="020B0503020204020204" charset="-122"/>
                           <a:cs typeface="微软雅黑" panose="020B0503020204020204" charset="-122"/>
                         </a:rPr>
-                        <a:t>证据状态</a:t>
+                        <a:t>告警数及状态</a:t>
                       </a:r>
                       <a:endParaRPr sz="1275" b="1">
                         <a:solidFill>
@@ -4366,7 +4564,7 @@
                           <a:ea typeface="微软雅黑" panose="020B0503020204020204" charset="-122"/>
                           <a:cs typeface="微软雅黑" panose="020B0503020204020204" charset="-122"/>
                         </a:rPr>
-                        <a:t>范围/总量</a:t>
+                        <a:t>同日告警总量</a:t>
                       </a:r>
                       <a:endParaRPr sz="1275" b="1">
                         <a:solidFill>
@@ -4421,7 +4619,7 @@
                           <a:ea typeface="微软雅黑" panose="020B0503020204020204" charset="-122"/>
                           <a:cs typeface="微软雅黑" panose="020B0503020204020204" charset="-122"/>
                         </a:rPr>
-                        <a:t>—</a:t>
+                        <a:t>01 账号失陷/凭证泄漏</a:t>
                       </a:r>
                       <a:endParaRPr sz="1350" b="0">
                         <a:solidFill>
@@ -4474,7 +4672,7 @@
                           <a:ea typeface="微软雅黑" panose="020B0503020204020204" charset="-122"/>
                           <a:cs typeface="微软雅黑" panose="020B0503020204020204" charset="-122"/>
                         </a:rPr>
-                        <a:t>—</a:t>
+                        <a:t>2（与攻击无关）</a:t>
                       </a:r>
                       <a:endParaRPr sz="1350" b="0">
                         <a:solidFill>
@@ -4521,7 +4719,7 @@
                           <a:ea typeface="微软雅黑" panose="020B0503020204020204" charset="-122"/>
                           <a:cs typeface="微软雅黑" panose="020B0503020204020204" charset="-122"/>
                         </a:rPr>
-                        <a:t>—</a:t>
+                        <a:t>用户</a:t>
                       </a:r>
                       <a:endParaRPr sz="1350" b="0">
                         <a:solidFill>
@@ -4568,7 +4766,7 @@
                           <a:ea typeface="微软雅黑" panose="020B0503020204020204" charset="-122"/>
                           <a:cs typeface="微软雅黑" panose="020B0503020204020204" charset="-122"/>
                         </a:rPr>
-                        <a:t>—</a:t>
+                        <a:t>55,499</a:t>
                       </a:r>
                       <a:endParaRPr sz="1350" b="0">
                         <a:solidFill>
@@ -4617,7 +4815,7 @@
                           <a:ea typeface="微软雅黑" panose="020B0503020204020204" charset="-122"/>
                           <a:cs typeface="微软雅黑" panose="020B0503020204020204" charset="-122"/>
                         </a:rPr>
-                        <a:t>—</a:t>
+                        <a:t>02 账号失陷/扫描</a:t>
                       </a:r>
                       <a:endParaRPr sz="1350" b="0">
                         <a:solidFill>
@@ -4670,7 +4868,7 @@
                           <a:ea typeface="微软雅黑" panose="020B0503020204020204" charset="-122"/>
                           <a:cs typeface="微软雅黑" panose="020B0503020204020204" charset="-122"/>
                         </a:rPr>
-                        <a:t>—</a:t>
+                        <a:t>22</a:t>
                       </a:r>
                       <a:endParaRPr sz="1350" b="0">
                         <a:solidFill>
@@ -4717,7 +4915,7 @@
                           <a:ea typeface="微软雅黑" panose="020B0503020204020204" charset="-122"/>
                           <a:cs typeface="微软雅黑" panose="020B0503020204020204" charset="-122"/>
                         </a:rPr>
-                        <a:t>—</a:t>
+                        <a:t>Zeek</a:t>
                       </a:r>
                       <a:endParaRPr sz="1350" b="0">
                         <a:solidFill>
@@ -4764,7 +4962,7 @@
                           <a:ea typeface="微软雅黑" panose="020B0503020204020204" charset="-122"/>
                           <a:cs typeface="微软雅黑" panose="020B0503020204020204" charset="-122"/>
                         </a:rPr>
-                        <a:t>—</a:t>
+                        <a:t>163,878</a:t>
                       </a:r>
                       <a:endParaRPr sz="1350" b="0">
                         <a:solidFill>
@@ -4813,7 +5011,7 @@
                           <a:ea typeface="微软雅黑" panose="020B0503020204020204" charset="-122"/>
                           <a:cs typeface="微软雅黑" panose="020B0503020204020204" charset="-122"/>
                         </a:rPr>
-                        <a:t>—</a:t>
+                        <a:t>03 账号失陷/数据泄漏</a:t>
                       </a:r>
                       <a:endParaRPr sz="1350" b="0">
                         <a:solidFill>
@@ -4866,7 +5064,7 @@
                           <a:ea typeface="微软雅黑" panose="020B0503020204020204" charset="-122"/>
                           <a:cs typeface="微软雅黑" panose="020B0503020204020204" charset="-122"/>
                         </a:rPr>
-                        <a:t>—</a:t>
+                        <a:t>0</a:t>
                       </a:r>
                       <a:endParaRPr sz="1350" b="0">
                         <a:solidFill>
@@ -4913,7 +5111,7 @@
                           <a:ea typeface="微软雅黑" panose="020B0503020204020204" charset="-122"/>
                           <a:cs typeface="微软雅黑" panose="020B0503020204020204" charset="-122"/>
                         </a:rPr>
-                        <a:t>—</a:t>
+                        <a:t>其他</a:t>
                       </a:r>
                       <a:endParaRPr sz="1350" b="0">
                         <a:solidFill>
@@ -4960,7 +5158,7 @@
                           <a:ea typeface="微软雅黑" panose="020B0503020204020204" charset="-122"/>
                           <a:cs typeface="微软雅黑" panose="020B0503020204020204" charset="-122"/>
                         </a:rPr>
-                        <a:t>—</a:t>
+                        <a:t>82,959</a:t>
                       </a:r>
                       <a:endParaRPr sz="1350" b="0">
                         <a:solidFill>
@@ -5009,7 +5207,7 @@
                           <a:ea typeface="微软雅黑" panose="020B0503020204020204" charset="-122"/>
                           <a:cs typeface="微软雅黑" panose="020B0503020204020204" charset="-122"/>
                         </a:rPr>
-                        <a:t>—</a:t>
+                        <a:t>04 账号失陷/垃圾邮件</a:t>
                       </a:r>
                       <a:endParaRPr sz="1350" b="0">
                         <a:solidFill>
@@ -5062,7 +5260,7 @@
                           <a:ea typeface="微软雅黑" panose="020B0503020204020204" charset="-122"/>
                           <a:cs typeface="微软雅黑" panose="020B0503020204020204" charset="-122"/>
                         </a:rPr>
-                        <a:t>—</a:t>
+                        <a:t>缺失*</a:t>
                       </a:r>
                       <a:endParaRPr sz="1350" b="0">
                         <a:solidFill>
@@ -5109,7 +5307,7 @@
                           <a:ea typeface="微软雅黑" panose="020B0503020204020204" charset="-122"/>
                           <a:cs typeface="微软雅黑" panose="020B0503020204020204" charset="-122"/>
                         </a:rPr>
-                        <a:t>—</a:t>
+                        <a:t>Zeek</a:t>
                       </a:r>
                       <a:endParaRPr sz="1350" b="0">
                         <a:solidFill>
@@ -5156,7 +5354,7 @@
                           <a:ea typeface="微软雅黑" panose="020B0503020204020204" charset="-122"/>
                           <a:cs typeface="微软雅黑" panose="020B0503020204020204" charset="-122"/>
                         </a:rPr>
-                        <a:t>—</a:t>
+                        <a:t>97,545</a:t>
                       </a:r>
                       <a:endParaRPr sz="1350" b="0">
                         <a:solidFill>
@@ -5205,7 +5403,7 @@
                           <a:ea typeface="微软雅黑" panose="020B0503020204020204" charset="-122"/>
                           <a:cs typeface="微软雅黑" panose="020B0503020204020204" charset="-122"/>
                         </a:rPr>
-                        <a:t>—</a:t>
+                        <a:t>05 0-day/扫描</a:t>
                       </a:r>
                       <a:endParaRPr sz="1350" b="0">
                         <a:solidFill>
@@ -5258,7 +5456,7 @@
                           <a:ea typeface="微软雅黑" panose="020B0503020204020204" charset="-122"/>
                           <a:cs typeface="微软雅黑" panose="020B0503020204020204" charset="-122"/>
                         </a:rPr>
-                        <a:t>—</a:t>
+                        <a:t>18</a:t>
                       </a:r>
                       <a:endParaRPr sz="1350" b="0">
                         <a:solidFill>
@@ -5305,7 +5503,7 @@
                           <a:ea typeface="微软雅黑" panose="020B0503020204020204" charset="-122"/>
                           <a:cs typeface="微软雅黑" panose="020B0503020204020204" charset="-122"/>
                         </a:rPr>
-                        <a:t>—</a:t>
+                        <a:t>Zeek</a:t>
                       </a:r>
                       <a:endParaRPr sz="1350" b="0">
                         <a:solidFill>
@@ -5352,7 +5550,7 @@
                           <a:ea typeface="微软雅黑" panose="020B0503020204020204" charset="-122"/>
                           <a:cs typeface="微软雅黑" panose="020B0503020204020204" charset="-122"/>
                         </a:rPr>
-                        <a:t>—</a:t>
+                        <a:t>124,154</a:t>
                       </a:r>
                       <a:endParaRPr sz="1350" b="0">
                         <a:solidFill>
@@ -5401,7 +5599,7 @@
                           <a:ea typeface="微软雅黑" panose="020B0503020204020204" charset="-122"/>
                           <a:cs typeface="微软雅黑" panose="020B0503020204020204" charset="-122"/>
                         </a:rPr>
-                        <a:t>—</a:t>
+                        <a:t>06 账号失陷/出站SSH</a:t>
                       </a:r>
                       <a:endParaRPr sz="1350" b="0">
                         <a:solidFill>
@@ -5454,7 +5652,7 @@
                           <a:ea typeface="微软雅黑" panose="020B0503020204020204" charset="-122"/>
                           <a:cs typeface="微软雅黑" panose="020B0503020204020204" charset="-122"/>
                         </a:rPr>
-                        <a:t>—</a:t>
+                        <a:t>缺失*</a:t>
                       </a:r>
                       <a:endParaRPr sz="1350" b="0">
                         <a:solidFill>
@@ -5501,7 +5699,7 @@
                           <a:ea typeface="微软雅黑" panose="020B0503020204020204" charset="-122"/>
                           <a:cs typeface="微软雅黑" panose="020B0503020204020204" charset="-122"/>
                         </a:rPr>
-                        <a:t>—</a:t>
+                        <a:t>Zeek</a:t>
                       </a:r>
                       <a:endParaRPr sz="1350" b="0">
                         <a:solidFill>
@@ -5548,7 +5746,7 @@
                           <a:ea typeface="微软雅黑" panose="020B0503020204020204" charset="-122"/>
                           <a:cs typeface="微软雅黑" panose="020B0503020204020204" charset="-122"/>
                         </a:rPr>
-                        <a:t>—</a:t>
+                        <a:t>缺失*</a:t>
                       </a:r>
                       <a:endParaRPr sz="1350" b="0">
                         <a:solidFill>
@@ -5597,7 +5795,7 @@
                           <a:ea typeface="微软雅黑" panose="020B0503020204020204" charset="-122"/>
                           <a:cs typeface="微软雅黑" panose="020B0503020204020204" charset="-122"/>
                         </a:rPr>
-                        <a:t>—</a:t>
+                        <a:t>07 账号失陷/钓鱼</a:t>
                       </a:r>
                       <a:endParaRPr sz="1350" b="0">
                         <a:solidFill>
@@ -5650,7 +5848,7 @@
                           <a:ea typeface="微软雅黑" panose="020B0503020204020204" charset="-122"/>
                           <a:cs typeface="微软雅黑" panose="020B0503020204020204" charset="-122"/>
                         </a:rPr>
-                        <a:t>—</a:t>
+                        <a:t>0</a:t>
                       </a:r>
                       <a:endParaRPr sz="1350" b="0">
                         <a:solidFill>
@@ -5697,7 +5895,7 @@
                           <a:ea typeface="微软雅黑" panose="020B0503020204020204" charset="-122"/>
                           <a:cs typeface="微软雅黑" panose="020B0503020204020204" charset="-122"/>
                         </a:rPr>
-                        <a:t>—</a:t>
+                        <a:t>用户</a:t>
                       </a:r>
                       <a:endParaRPr sz="1350" b="0">
                         <a:solidFill>
@@ -5744,7 +5942,7 @@
                           <a:ea typeface="微软雅黑" panose="020B0503020204020204" charset="-122"/>
                           <a:cs typeface="微软雅黑" panose="020B0503020204020204" charset="-122"/>
                         </a:rPr>
-                        <a:t>—</a:t>
+                        <a:t>134,847</a:t>
                       </a:r>
                       <a:endParaRPr sz="1350" b="0">
                         <a:solidFill>
@@ -5793,7 +5991,7 @@
                           <a:ea typeface="微软雅黑" panose="020B0503020204020204" charset="-122"/>
                           <a:cs typeface="微软雅黑" panose="020B0503020204020204" charset="-122"/>
                         </a:rPr>
-                        <a:t>—</a:t>
+                        <a:t>08 账号失陷/挖矿</a:t>
                       </a:r>
                       <a:endParaRPr sz="1350" b="0">
                         <a:solidFill>
@@ -5846,7 +6044,7 @@
                           <a:ea typeface="微软雅黑" panose="020B0503020204020204" charset="-122"/>
                           <a:cs typeface="微软雅黑" panose="020B0503020204020204" charset="-122"/>
                         </a:rPr>
-                        <a:t>—</a:t>
+                        <a:t>0</a:t>
                       </a:r>
                       <a:endParaRPr sz="1350" b="0">
                         <a:solidFill>
@@ -5893,7 +6091,7 @@
                           <a:ea typeface="微软雅黑" panose="020B0503020204020204" charset="-122"/>
                           <a:cs typeface="微软雅黑" panose="020B0503020204020204" charset="-122"/>
                         </a:rPr>
-                        <a:t>—</a:t>
+                        <a:t>其他</a:t>
                       </a:r>
                       <a:endParaRPr sz="1350" b="0">
                         <a:solidFill>
@@ -5940,7 +6138,7 @@
                           <a:ea typeface="微软雅黑" panose="020B0503020204020204" charset="-122"/>
                           <a:cs typeface="微软雅黑" panose="020B0503020204020204" charset="-122"/>
                         </a:rPr>
-                        <a:t>—</a:t>
+                        <a:t>31,438</a:t>
                       </a:r>
                       <a:endParaRPr sz="1350" b="0">
                         <a:solidFill>
@@ -5989,7 +6187,7 @@
                           <a:ea typeface="微软雅黑" panose="020B0503020204020204" charset="-122"/>
                           <a:cs typeface="微软雅黑" panose="020B0503020204020204" charset="-122"/>
                         </a:rPr>
-                        <a:t>—</a:t>
+                        <a:t>09 开放端口/反射DoS</a:t>
                       </a:r>
                       <a:endParaRPr sz="1350" b="0">
                         <a:solidFill>
@@ -6042,7 +6240,7 @@
                           <a:ea typeface="微软雅黑" panose="020B0503020204020204" charset="-122"/>
                           <a:cs typeface="微软雅黑" panose="020B0503020204020204" charset="-122"/>
                         </a:rPr>
-                        <a:t>—</a:t>
+                        <a:t>12</a:t>
                       </a:r>
                       <a:endParaRPr sz="1350" b="0">
                         <a:solidFill>
@@ -6089,7 +6287,7 @@
                           <a:ea typeface="微软雅黑" panose="020B0503020204020204" charset="-122"/>
                           <a:cs typeface="微软雅黑" panose="020B0503020204020204" charset="-122"/>
                         </a:rPr>
-                        <a:t>—</a:t>
+                        <a:t>Zeek</a:t>
                       </a:r>
                       <a:endParaRPr sz="1350" b="0">
                         <a:solidFill>
@@ -6136,7 +6334,7 @@
                           <a:ea typeface="微软雅黑" panose="020B0503020204020204" charset="-122"/>
                           <a:cs typeface="微软雅黑" panose="020B0503020204020204" charset="-122"/>
                         </a:rPr>
-                        <a:t>—</a:t>
+                        <a:t>17,946</a:t>
                       </a:r>
                       <a:endParaRPr sz="1350" b="0">
                         <a:solidFill>
@@ -6185,7 +6383,7 @@
                           <a:ea typeface="微软雅黑" panose="020B0503020204020204" charset="-122"/>
                           <a:cs typeface="微软雅黑" panose="020B0503020204020204" charset="-122"/>
                         </a:rPr>
-                        <a:t>—</a:t>
+                        <a:t>10 Postgres失陷/扫描</a:t>
                       </a:r>
                       <a:endParaRPr sz="1350" b="0">
                         <a:solidFill>
@@ -6238,7 +6436,7 @@
                           <a:ea typeface="微软雅黑" panose="020B0503020204020204" charset="-122"/>
                           <a:cs typeface="微软雅黑" panose="020B0503020204020204" charset="-122"/>
                         </a:rPr>
-                        <a:t>—</a:t>
+                        <a:t>1,101</a:t>
                       </a:r>
                       <a:endParaRPr sz="1350" b="0">
                         <a:solidFill>
@@ -6285,7 +6483,7 @@
                           <a:ea typeface="微软雅黑" panose="020B0503020204020204" charset="-122"/>
                           <a:cs typeface="微软雅黑" panose="020B0503020204020204" charset="-122"/>
                         </a:rPr>
-                        <a:t>—</a:t>
+                        <a:t>Zeek</a:t>
                       </a:r>
                       <a:endParaRPr sz="1350" b="0">
                         <a:solidFill>
@@ -6332,7 +6530,7 @@
                           <a:ea typeface="微软雅黑" panose="020B0503020204020204" charset="-122"/>
                           <a:cs typeface="微软雅黑" panose="020B0503020204020204" charset="-122"/>
                         </a:rPr>
-                        <a:t>—</a:t>
+                        <a:t>17,839</a:t>
                       </a:r>
                       <a:endParaRPr sz="1350" b="0">
                         <a:solidFill>
@@ -6381,7 +6579,7 @@
                           <a:ea typeface="微软雅黑" panose="020B0503020204020204" charset="-122"/>
                           <a:cs typeface="微软雅黑" panose="020B0503020204020204" charset="-122"/>
                         </a:rPr>
-                        <a:t>—</a:t>
+                        <a:t>11 内部账号挖矿</a:t>
                       </a:r>
                       <a:endParaRPr sz="1350" b="0">
                         <a:solidFill>
@@ -6434,7 +6632,7 @@
                           <a:ea typeface="微软雅黑" panose="020B0503020204020204" charset="-122"/>
                           <a:cs typeface="微软雅黑" panose="020B0503020204020204" charset="-122"/>
                         </a:rPr>
-                        <a:t>—</a:t>
+                        <a:t>1</a:t>
                       </a:r>
                       <a:endParaRPr sz="1350" b="0">
                         <a:solidFill>
@@ -6481,7 +6679,7 @@
                           <a:ea typeface="微软雅黑" panose="020B0503020204020204" charset="-122"/>
                           <a:cs typeface="微软雅黑" panose="020B0503020204020204" charset="-122"/>
                         </a:rPr>
-                        <a:t>—</a:t>
+                        <a:t>Zeek</a:t>
                       </a:r>
                       <a:endParaRPr sz="1350" b="0">
                         <a:solidFill>
@@ -6528,7 +6726,7 @@
                           <a:ea typeface="微软雅黑" panose="020B0503020204020204" charset="-122"/>
                           <a:cs typeface="微软雅黑" panose="020B0503020204020204" charset="-122"/>
                         </a:rPr>
-                        <a:t>—</a:t>
+                        <a:t>24,921</a:t>
                       </a:r>
                       <a:endParaRPr sz="1350" b="0">
                         <a:solidFill>
@@ -6620,7 +6818,7 @@
                 <a:ea typeface="Times New Roman" panose="02020603050405020304"/>
                 <a:cs typeface="Times New Roman" panose="02020603050405020304"/>
               </a:rPr>
-              <a:t>数量A</a:t>
+              <a:t>7 起</a:t>
             </a:r>
             <a:endParaRPr sz="3225" b="1">
               <a:solidFill>
@@ -6690,7 +6888,7 @@
                 <a:ea typeface="微软雅黑" panose="020B0503020204020204" charset="-122"/>
                 <a:cs typeface="微软雅黑" panose="020B0503020204020204" charset="-122"/>
               </a:rPr>
-              <a:t>填写集合A的定义</a:t>
+              <a:t>由Zeek发现</a:t>
             </a:r>
             <a:endParaRPr sz="1725" b="1">
               <a:solidFill>
@@ -6760,7 +6958,7 @@
                 <a:ea typeface="Times New Roman" panose="02020603050405020304"/>
                 <a:cs typeface="Times New Roman" panose="02020603050405020304"/>
               </a:rPr>
-              <a:t>数量B</a:t>
+              <a:t>4 起</a:t>
             </a:r>
             <a:endParaRPr sz="3225" b="1">
               <a:solidFill>
@@ -6830,7 +7028,7 @@
                 <a:ea typeface="微软雅黑" panose="020B0503020204020204" charset="-122"/>
                 <a:cs typeface="微软雅黑" panose="020B0503020204020204" charset="-122"/>
               </a:rPr>
-              <a:t>填写集合B的定义</a:t>
+              <a:t>由用户或其他渠道发现</a:t>
             </a:r>
             <a:endParaRPr sz="1650" b="1">
               <a:solidFill>
@@ -6900,7 +7098,7 @@
                 <a:ea typeface="微软雅黑" panose="020B0503020204020204" charset="-122"/>
                 <a:cs typeface="微软雅黑" panose="020B0503020204020204" charset="-122"/>
               </a:rPr>
-              <a:t>解释表中差异与研究问题之间的关系。关键子集、状态和分母保留在页面上。</a:t>
+              <a:t>网络告警多呈现失陷后的活跃行为。</a:t>
             </a:r>
             <a:endParaRPr sz="1200" b="0">
               <a:solidFill>
@@ -6931,7 +7129,7 @@
                 <a:ea typeface="微软雅黑" panose="020B0503020204020204" charset="-122"/>
                 <a:cs typeface="微软雅黑" panose="020B0503020204020204" charset="-122"/>
               </a:rPr>
-              <a:t/>
+              <a:t>ID8后新增挖矿规则，ID11触发；</a:t>
             </a:r>
             <a:endParaRPr sz="1200" b="0">
               <a:solidFill>
@@ -6962,7 +7160,7 @@
                 <a:ea typeface="微软雅黑" panose="020B0503020204020204" charset="-122"/>
                 <a:cs typeface="微软雅黑" panose="020B0503020204020204" charset="-122"/>
               </a:rPr>
-              <a:t/>
+              <a:t>少量数据窃取与钓鱼仍可能缺少信号。</a:t>
             </a:r>
             <a:endParaRPr sz="1200" b="0">
               <a:solidFill>
@@ -7032,7 +7230,7 @@
                 <a:ea typeface="微软雅黑" panose="020B0503020204020204" charset="-122"/>
                 <a:cs typeface="微软雅黑" panose="020B0503020204020204" charset="-122"/>
               </a:rPr>
-              <a:t>占位单元格用横线表示待填，不能读为零或缺失实测。</a:t>
+              <a:t>ID4/6日志缺失。ID6同日总量亦缺失。</a:t>
             </a:r>
             <a:endParaRPr sz="1275" b="0">
               <a:solidFill>
@@ -7063,7 +7261,7 @@
                 <a:ea typeface="微软雅黑" panose="020B0503020204020204" charset="-122"/>
                 <a:cs typeface="微软雅黑" panose="020B0503020204020204" charset="-122"/>
               </a:rPr>
-              <a:t/>
+              <a:t>ID1的2条告警与攻击无关。</a:t>
             </a:r>
             <a:endParaRPr sz="1275" b="0">
               <a:solidFill>
@@ -7133,7 +7331,7 @@
                 <a:ea typeface="微软雅黑" panose="020B0503020204020204" charset="-122"/>
                 <a:cs typeface="微软雅黑" panose="020B0503020204020204" charset="-122"/>
               </a:rPr>
-              <a:t>按证据说明覆盖与盲区，观察关联不扩大为检测性能。</a:t>
+              <a:t>网络告警对初始失陷和失陷后的隐蔽活动存在盲区。</a:t>
             </a:r>
             <a:endParaRPr sz="1275" b="0">
               <a:solidFill>
@@ -7288,7 +7486,7 @@
                 <a:ea typeface="Times New Roman" panose="02020603050405020304"/>
                 <a:cs typeface="Times New Roman" panose="02020603050405020304"/>
               </a:rPr>
-              <a:t>03 · 核心证据 / 并列指标</a:t>
+              <a:t>03 · 核心发现 / 3.5 稀有模式信号</a:t>
             </a:r>
             <a:endParaRPr sz="1120" spc="150">
               <a:solidFill>
@@ -7338,7 +7536,7 @@
                 <a:ea typeface="Times New Roman" panose="02020603050405020304"/>
                 <a:cs typeface="Times New Roman" panose="02020603050405020304"/>
               </a:rPr>
-              <a:t>对应子图的发现与适用范围</a:t>
+              <a:t>发现⑤：主机级告警特征的探索性线索</a:t>
             </a:r>
             <a:endParaRPr sz="2990" b="1">
               <a:solidFill>
@@ -7388,7 +7586,7 @@
                 <a:ea typeface="微软雅黑" panose="020B0503020204020204" charset="-122"/>
                 <a:cs typeface="微软雅黑" panose="020B0503020204020204" charset="-122"/>
               </a:rPr>
-              <a:t>占位模板，无研究结果。新稿填写准确来源。</a:t>
+              <a:t>来源：Yang et al., USENIX Security 2024，§7.2、Figure 13。</a:t>
             </a:r>
             <a:endParaRPr sz="1040">
               <a:solidFill>
@@ -7513,12 +7711,20 @@
           <a:p/>
         </p:txBody>
       </p:sp>
-      <p:sp>
-        <p:nvSpPr>
-          <p:cNvPr id="1000" name="Evidence placeholder"/>
-          <p:cNvSpPr txBox="1"/>
-          <p:nvPr/>
-        </p:nvSpPr>
+      <p:pic>
+        <p:nvPicPr>
+          <p:cNvPr id="20" name="v3_"/>
+          <p:cNvPicPr>
+            <a:picLocks noChangeAspect="1"/>
+          </p:cNvPicPr>
+          <p:nvPr/>
+        </p:nvPicPr>
+        <p:blipFill>
+          <a:blip r:embed="rId1"/>
+          <a:stretch>
+            <a:fillRect/>
+          </a:stretch>
+        </p:blipFill>
         <p:spPr>
           <a:xfrm>
             <a:off x="685800" y="1361065"/>
@@ -7527,33 +7733,8 @@
           <a:prstGeom prst="rect">
             <a:avLst/>
           </a:prstGeom>
-          <a:solidFill>
-            <a:srgbClr val="F3F5F8"/>
-          </a:solidFill>
-          <a:ln w="9525">
-            <a:solidFill>
-              <a:srgbClr val="D8DDE3"/>
-            </a:solidFill>
-          </a:ln>
-        </p:spPr>
-        <p:txBody>
-          <a:bodyPr anchor="ctr"/>
-          <a:lstStyle/>
-          <a:p>
-            <a:pPr algn="ctr"/>
-            <a:r>
-              <a:rPr lang="zh-CN" sz="1800">
-                <a:solidFill>
-                  <a:srgbClr val="5A6472"/>
-                </a:solidFill>
-                <a:latin typeface="Times New Roman"/>
-                <a:ea typeface="微软雅黑"/>
-              </a:rPr>
-              <a:t>证据图占位 · 按授权替换</a:t>
-            </a:r>
-          </a:p>
-        </p:txBody>
-      </p:sp>
+        </p:spPr>
+      </p:pic>
       <p:sp>
         <p:nvSpPr>
           <p:cNvPr id="21" name="v3_P12 divider"/>
@@ -7635,7 +7816,7 @@
                 <a:ea typeface="微软雅黑" panose="020B0503020204020204" charset="-122"/>
                 <a:cs typeface="微软雅黑" panose="020B0503020204020204" charset="-122"/>
               </a:rPr>
-              <a:t>(a) 指标A</a:t>
+              <a:t>(a) 每日告警量熵</a:t>
             </a:r>
             <a:endParaRPr sz="1650" b="1">
               <a:solidFill>
@@ -7705,7 +7886,7 @@
                 <a:ea typeface="微软雅黑" panose="020B0503020204020204" charset="-122"/>
                 <a:cs typeface="微软雅黑" panose="020B0503020204020204" charset="-122"/>
               </a:rPr>
-              <a:t>填写图(a)支持的发现</a:t>
+              <a:t>ID10离群</a:t>
             </a:r>
             <a:endParaRPr sz="1950" b="1">
               <a:solidFill>
@@ -7799,7 +7980,7 @@
                 <a:ea typeface="微软雅黑" panose="020B0503020204020204" charset="-122"/>
                 <a:cs typeface="微软雅黑" panose="020B0503020204020204" charset="-122"/>
               </a:rPr>
-              <a:t>(b) 指标B</a:t>
+              <a:t>(b) 告警序列熵</a:t>
             </a:r>
             <a:endParaRPr sz="1650" b="1">
               <a:solidFill>
@@ -7869,7 +8050,7 @@
                 <a:ea typeface="微软雅黑" panose="020B0503020204020204" charset="-122"/>
                 <a:cs typeface="微软雅黑" panose="020B0503020204020204" charset="-122"/>
               </a:rPr>
-              <a:t>填写图(b)支持的发现</a:t>
+              <a:t>ID10、11离群</a:t>
             </a:r>
             <a:endParaRPr sz="1950" b="1">
               <a:solidFill>
@@ -7963,7 +8144,7 @@
                 <a:ea typeface="微软雅黑" panose="020B0503020204020204" charset="-122"/>
                 <a:cs typeface="微软雅黑" panose="020B0503020204020204" charset="-122"/>
               </a:rPr>
-              <a:t>(c) 指标C</a:t>
+              <a:t>(c) 告警稀有度</a:t>
             </a:r>
             <a:endParaRPr sz="1650" b="1">
               <a:solidFill>
@@ -8033,7 +8214,7 @@
                 <a:ea typeface="微软雅黑" panose="020B0503020204020204" charset="-122"/>
                 <a:cs typeface="微软雅黑" panose="020B0503020204020204" charset="-122"/>
               </a:rPr>
-              <a:t>填写图(c)支持的发现</a:t>
+              <a:t>ID9、10、11均离群</a:t>
             </a:r>
             <a:endParaRPr sz="1950" b="1">
               <a:solidFill>
@@ -8103,7 +8284,7 @@
                 <a:ea typeface="微软雅黑" panose="020B0503020204020204" charset="-122"/>
                 <a:cs typeface="微软雅黑" panose="020B0503020204020204" charset="-122"/>
               </a:rPr>
-              <a:t>说明计算直觉、窗口和样本。</a:t>
+              <a:t>每日告警量的规律性；</a:t>
             </a:r>
             <a:endParaRPr sz="1200" b="0">
               <a:solidFill>
@@ -8134,7 +8315,7 @@
                 <a:ea typeface="微软雅黑" panose="020B0503020204020204" charset="-122"/>
                 <a:cs typeface="微软雅黑" panose="020B0503020204020204" charset="-122"/>
               </a:rPr>
-              <a:t/>
+              <a:t>使用主机此前10天告警。</a:t>
             </a:r>
             <a:endParaRPr sz="1200" b="0">
               <a:solidFill>
@@ -8204,7 +8385,7 @@
                 <a:ea typeface="微软雅黑" panose="020B0503020204020204" charset="-122"/>
                 <a:cs typeface="微软雅黑" panose="020B0503020204020204" charset="-122"/>
               </a:rPr>
-              <a:t>说明与前一指标的区别。</a:t>
+              <a:t>告警序列的规律性；</a:t>
             </a:r>
             <a:endParaRPr sz="1200" b="0">
               <a:solidFill>
@@ -8235,7 +8416,7 @@
                 <a:ea typeface="微软雅黑" panose="020B0503020204020204" charset="-122"/>
                 <a:cs typeface="微软雅黑" panose="020B0503020204020204" charset="-122"/>
               </a:rPr>
-              <a:t/>
+              <a:t>使用主机此前10天告警。</a:t>
             </a:r>
             <a:endParaRPr sz="1200" b="0">
               <a:solidFill>
@@ -8305,7 +8486,7 @@
                 <a:ea typeface="微软雅黑" panose="020B0503020204020204" charset="-122"/>
                 <a:cs typeface="微软雅黑" panose="020B0503020204020204" charset="-122"/>
               </a:rPr>
-              <a:t>解释比较对象及其含义。</a:t>
+              <a:t>告警类型按全网频率排名，</a:t>
             </a:r>
             <a:endParaRPr sz="1200" b="0">
               <a:solidFill>
@@ -8336,7 +8517,7 @@
                 <a:ea typeface="微软雅黑" panose="020B0503020204020204" charset="-122"/>
                 <a:cs typeface="微软雅黑" panose="020B0503020204020204" charset="-122"/>
               </a:rPr>
-              <a:t/>
+              <a:t>观察当日组合的罕见程度。</a:t>
             </a:r>
             <a:endParaRPr sz="1200" b="0">
               <a:solidFill>
@@ -8406,7 +8587,7 @@
                 <a:ea typeface="微软雅黑" panose="020B0503020204020204" charset="-122"/>
                 <a:cs typeface="微软雅黑" panose="020B0503020204020204" charset="-122"/>
               </a:rPr>
-              <a:t>按真实材料填写小样本、探索性或外推边界。</a:t>
+              <a:t>仅3起案例的探索性观察，尚不能视为已验证的检测方法。</a:t>
             </a:r>
             <a:endParaRPr sz="1425" b="0">
               <a:solidFill>
@@ -9256,7 +9437,7 @@
                 <a:ea typeface="Times New Roman" panose="02020603050405020304"/>
                 <a:cs typeface="Times New Roman" panose="02020603050405020304"/>
               </a:rPr>
-              <a:t>04 · 启示与建议</a:t>
+              <a:t>04 · 启示 / 4.1 运营侧</a:t>
             </a:r>
             <a:endParaRPr sz="1120" spc="150">
               <a:solidFill>
@@ -9306,7 +9487,7 @@
                 <a:ea typeface="Times New Roman" panose="02020603050405020304"/>
                 <a:cs typeface="Times New Roman" panose="02020603050405020304"/>
               </a:rPr>
-              <a:t>研究启示：证据、建议与验证状态</a:t>
+              <a:t>对 SOC 运营：瓶颈仍在"人 + 数据可链接性"</a:t>
             </a:r>
             <a:endParaRPr sz="2990" b="1">
               <a:solidFill>
@@ -9356,7 +9537,7 @@
                 <a:ea typeface="微软雅黑" panose="020B0503020204020204" charset="-122"/>
                 <a:cs typeface="微软雅黑" panose="020B0503020204020204" charset="-122"/>
               </a:rPr>
-              <a:t>证据支持的发现</a:t>
+              <a:t>瓶颈的证据（测量数据支持）</a:t>
             </a:r>
             <a:endParaRPr sz="1490" b="1">
               <a:solidFill>
@@ -9406,7 +9587,7 @@
                 <a:ea typeface="微软雅黑" panose="020B0503020204020204" charset="-122"/>
                 <a:cs typeface="微软雅黑" panose="020B0503020204020204" charset="-122"/>
               </a:rPr>
-              <a:t>填写对应来源</a:t>
+              <a:t>§5 / §8.2</a:t>
             </a:r>
             <a:endParaRPr sz="970">
               <a:solidFill>
@@ -9456,7 +9637,7 @@
                 <a:ea typeface="微软雅黑" panose="020B0503020204020204" charset="-122"/>
                 <a:cs typeface="微软雅黑" panose="020B0503020204020204" charset="-122"/>
               </a:rPr>
-              <a:t>指标A</a:t>
+              <a:t>65%</a:t>
             </a:r>
             <a:endParaRPr sz="930">
               <a:solidFill>
@@ -9506,7 +9687,7 @@
                 <a:ea typeface="微软雅黑" panose="020B0503020204020204" charset="-122"/>
                 <a:cs typeface="微软雅黑" panose="020B0503020204020204" charset="-122"/>
               </a:rPr>
-              <a:t>发现一的直接含义</a:t>
+              <a:t>单起攻击需要 ≥2 名分析师</a:t>
             </a:r>
             <a:endParaRPr sz="1270" b="1">
               <a:solidFill>
@@ -9556,7 +9737,7 @@
                 <a:ea typeface="微软雅黑" panose="020B0503020204020204" charset="-122"/>
                 <a:cs typeface="微软雅黑" panose="020B0503020204020204" charset="-122"/>
               </a:rPr>
-              <a:t>说明证据支持了什么，不扩大到未观察范围。</a:t>
+              <a:t>107 份报告记录了人力投入，部分涉及 6–7 人（含 SOC 之外的网络管理员）</a:t>
             </a:r>
             <a:endParaRPr sz="1120">
               <a:solidFill>
@@ -9606,7 +9787,7 @@
                 <a:ea typeface="微软雅黑" panose="020B0503020204020204" charset="-122"/>
                 <a:cs typeface="微软雅黑" panose="020B0503020204020204" charset="-122"/>
               </a:rPr>
-              <a:t>指标B</a:t>
+              <a:t>53.2 天</a:t>
             </a:r>
             <a:endParaRPr sz="930">
               <a:solidFill>
@@ -9656,7 +9837,7 @@
                 <a:ea typeface="微软雅黑" panose="020B0503020204020204" charset="-122"/>
                 <a:cs typeface="微软雅黑" panose="020B0503020204020204" charset="-122"/>
               </a:rPr>
-              <a:t>发现二的直接含义</a:t>
+              <a:t>攻击后调查平均历时（最长253天）</a:t>
             </a:r>
             <a:endParaRPr sz="1270" b="1">
               <a:solidFill>
@@ -9706,7 +9887,7 @@
                 <a:ea typeface="微软雅黑" panose="020B0503020204020204" charset="-122"/>
                 <a:cs typeface="微软雅黑" panose="020B0503020204020204" charset="-122"/>
               </a:rPr>
-              <a:t>保留单位、样本与窗口，区分观察关联与因果。</a:t>
+              <a:t>2016年后28起；53.2天为日历历时，非工时。</a:t>
             </a:r>
             <a:endParaRPr sz="1120">
               <a:solidFill>
@@ -9732,7 +9913,7 @@
                 <a:ea typeface="微软雅黑" panose="020B0503020204020204" charset="-122"/>
                 <a:cs typeface="微软雅黑" panose="020B0503020204020204" charset="-122"/>
               </a:rPr>
-              <a:t/>
+              <a:t>链接困难：告警聚合丢受害IP，连接日志只存2年。</a:t>
             </a:r>
             <a:endParaRPr sz="1120">
               <a:solidFill>
@@ -9782,7 +9963,7 @@
                 <a:ea typeface="微软雅黑" panose="020B0503020204020204" charset="-122"/>
                 <a:cs typeface="微软雅黑" panose="020B0503020204020204" charset="-122"/>
               </a:rPr>
-              <a:t>指标C</a:t>
+              <a:t>off-hours</a:t>
             </a:r>
             <a:endParaRPr sz="930">
               <a:solidFill>
@@ -9832,7 +10013,7 @@
                 <a:ea typeface="微软雅黑" panose="020B0503020204020204" charset="-122"/>
                 <a:cs typeface="微软雅黑" panose="020B0503020204020204" charset="-122"/>
               </a:rPr>
-              <a:t>发现三的直接含义</a:t>
+              <a:t>发现时间与分析师工作时间对齐</a:t>
             </a:r>
             <a:endParaRPr sz="1270" b="1">
               <a:solidFill>
@@ -9882,7 +10063,7 @@
                 <a:ea typeface="微软雅黑" panose="020B0503020204020204" charset="-122"/>
                 <a:cs typeface="微软雅黑" panose="020B0503020204020204" charset="-122"/>
               </a:rPr>
-              <a:t>解释它与研究问题的联系。</a:t>
+              <a:t>发现时间呈现工作时段相关的分布：周日最少、周一最多，8–10点最多；该观察不能确定延迟的因果来源。</a:t>
             </a:r>
             <a:endParaRPr sz="1120">
               <a:solidFill>
@@ -9932,7 +10113,7 @@
                 <a:ea typeface="微软雅黑" panose="020B0503020204020204" charset="-122"/>
                 <a:cs typeface="微软雅黑" panose="020B0503020204020204" charset="-122"/>
               </a:rPr>
-              <a:t>建议与后续验证</a:t>
+              <a:t>作者建议与落地成果</a:t>
             </a:r>
             <a:endParaRPr sz="1490" b="1">
               <a:solidFill>
@@ -9982,7 +10163,7 @@
                 <a:ea typeface="微软雅黑" panose="020B0503020204020204" charset="-122"/>
                 <a:cs typeface="微软雅黑" panose="020B0503020204020204" charset="-122"/>
               </a:rPr>
-              <a:t>填写对应来源</a:t>
+              <a:t>§7.3 / §8.2 / 附录 B</a:t>
             </a:r>
             <a:endParaRPr sz="970">
               <a:solidFill>
@@ -10032,7 +10213,7 @@
                 <a:ea typeface="微软雅黑" panose="020B0503020204020204" charset="-122"/>
                 <a:cs typeface="微软雅黑" panose="020B0503020204020204" charset="-122"/>
               </a:rPr>
-              <a:t>证据支持</a:t>
+              <a:t>数据支持</a:t>
             </a:r>
             <a:endParaRPr sz="930">
               <a:solidFill>
@@ -10082,7 +10263,7 @@
                 <a:ea typeface="微软雅黑" panose="020B0503020204020204" charset="-122"/>
                 <a:cs typeface="微软雅黑" panose="020B0503020204020204" charset="-122"/>
               </a:rPr>
-              <a:t>已有证据支持的建议</a:t>
+              <a:t>让日志可链接、可查询、存得久</a:t>
             </a:r>
             <a:endParaRPr sz="1270" b="1">
               <a:solidFill>
@@ -10132,7 +10313,7 @@
                 <a:ea typeface="微软雅黑" panose="020B0503020204020204" charset="-122"/>
                 <a:cs typeface="微软雅黑" panose="020B0503020204020204" charset="-122"/>
               </a:rPr>
-              <a:t>说明建议依据和适用条件。</a:t>
+              <a:t>关键元数据（如受害者 IP）写进告警；探索更省存储的日志表示</a:t>
             </a:r>
             <a:endParaRPr sz="1120">
               <a:solidFill>
@@ -10182,7 +10363,7 @@
                 <a:ea typeface="微软雅黑" panose="020B0503020204020204" charset="-122"/>
                 <a:cs typeface="微软雅黑" panose="020B0503020204020204" charset="-122"/>
               </a:rPr>
-              <a:t>待验证</a:t>
+              <a:t>数据支持</a:t>
             </a:r>
             <a:endParaRPr sz="930">
               <a:solidFill>
@@ -10232,7 +10413,7 @@
                 <a:ea typeface="微软雅黑" panose="020B0503020204020204" charset="-122"/>
                 <a:cs typeface="微软雅黑" panose="020B0503020204020204" charset="-122"/>
               </a:rPr>
-              <a:t>仍需实验或部署验证的方向</a:t>
+              <a:t>用资产管理维护白名单</a:t>
             </a:r>
             <a:endParaRPr sz="1270" b="1">
               <a:solidFill>
@@ -10282,7 +10463,7 @@
                 <a:ea typeface="微软雅黑" panose="020B0503020204020204" charset="-122"/>
                 <a:cs typeface="微软雅黑" panose="020B0503020204020204" charset="-122"/>
               </a:rPr>
-              <a:t>列出验证目标，勿当作已实现贡献。</a:t>
+              <a:t>连 SOC 自己的扫描器都没记录在案（活跃 573 天的 Top-1）；例外需文档化</a:t>
             </a:r>
             <a:endParaRPr sz="1120">
               <a:solidFill>
@@ -10332,7 +10513,7 @@
                 <a:ea typeface="微软雅黑" panose="020B0503020204020204" charset="-122"/>
                 <a:cs typeface="微软雅黑" panose="020B0503020204020204" charset="-122"/>
               </a:rPr>
-              <a:t>展望</a:t>
+              <a:t>前瞻讨论</a:t>
             </a:r>
             <a:endParaRPr sz="930">
               <a:solidFill>
@@ -10382,7 +10563,7 @@
                 <a:ea typeface="微软雅黑" panose="020B0503020204020204" charset="-122"/>
                 <a:cs typeface="微软雅黑" panose="020B0503020204020204" charset="-122"/>
               </a:rPr>
-              <a:t>作者提出的后续工作</a:t>
+              <a:t>off-hours 自动遏制 + LLM 辅助</a:t>
             </a:r>
             <a:endParaRPr sz="1270" b="1">
               <a:solidFill>
@@ -10432,7 +10613,7 @@
                 <a:ea typeface="微软雅黑" panose="020B0503020204020204" charset="-122"/>
                 <a:cs typeface="微软雅黑" panose="020B0503020204020204" charset="-122"/>
               </a:rPr>
-              <a:t>明确它是讨论或展望。</a:t>
+              <a:t>自动先"遏制"再等人工调查；LLM 引导分析是作者展望，</a:t>
             </a:r>
             <a:r>
               <a:rPr sz="1120" b="1">
@@ -10443,7 +10624,7 @@
                 <a:ea typeface="微软雅黑" panose="020B0503020204020204" charset="-122"/>
                 <a:cs typeface="微软雅黑" panose="020B0503020204020204" charset="-122"/>
               </a:rPr>
-              <a:t/>
+              <a:t>论文无实验</a:t>
             </a:r>
             <a:endParaRPr sz="1120">
               <a:solidFill>
@@ -10493,7 +10674,7 @@
                 <a:ea typeface="微软雅黑" panose="020B0503020204020204" charset="-122"/>
                 <a:cs typeface="微软雅黑" panose="020B0503020204020204" charset="-122"/>
               </a:rPr>
-              <a:t>已验证</a:t>
+              <a:t>已落地</a:t>
             </a:r>
             <a:endParaRPr sz="930">
               <a:solidFill>
@@ -10543,7 +10724,7 @@
                 <a:ea typeface="微软雅黑" panose="020B0503020204020204" charset="-122"/>
                 <a:cs typeface="微软雅黑" panose="020B0503020204020204" charset="-122"/>
               </a:rPr>
-              <a:t>确有证据支持的实现结果</a:t>
+              <a:t>新增 BHR 弱凭据封禁规则</a:t>
             </a:r>
             <a:endParaRPr sz="1270" b="1">
               <a:solidFill>
@@ -10593,7 +10774,7 @@
                 <a:ea typeface="微软雅黑" panose="020B0503020204020204" charset="-122"/>
                 <a:cs typeface="微软雅黑" panose="020B0503020204020204" charset="-122"/>
               </a:rPr>
-              <a:t>填写实现范围与验证指标；无此证据时调整此模块。</a:t>
+              <a:t>源自 Postgres 案例：同一组 Base64 弱凭据全网匹配 3,377 条告警，该用户名在同类尝试中排第 3（仅次于 admin 与空串）</a:t>
             </a:r>
             <a:endParaRPr sz="1120">
               <a:solidFill>
@@ -10643,7 +10824,7 @@
                 <a:ea typeface="微软雅黑" panose="020B0503020204020204" charset="-122"/>
                 <a:cs typeface="微软雅黑" panose="020B0503020204020204" charset="-122"/>
               </a:rPr>
-              <a:t>占位模板，无研究结果。新稿填写真实来源。</a:t>
+              <a:t>来源：Yang et al., USENIX Security 2024，§5、§7.3、§8.2、Appendices A–B。</a:t>
             </a:r>
             <a:endParaRPr sz="1040">
               <a:solidFill>
@@ -11126,7 +11307,7 @@
                 <a:ea typeface="Times New Roman" panose="02020603050405020304"/>
                 <a:cs typeface="Times New Roman" panose="02020603050405020304"/>
               </a:rPr>
-              <a:t>04 · 研究局限</a:t>
+              <a:t>04 · 局限 / 4.2</a:t>
             </a:r>
             <a:endParaRPr sz="1120" spc="150">
               <a:solidFill>
@@ -11176,7 +11357,7 @@
                 <a:ea typeface="Times New Roman" panose="02020603050405020304"/>
                 <a:cs typeface="Times New Roman" panose="02020603050405020304"/>
               </a:rPr>
-              <a:t>局限：这些结论适用于什么范围？</a:t>
+              <a:t>局限：这些数字能外推到哪里？</a:t>
             </a:r>
             <a:endParaRPr sz="2990" b="1">
               <a:solidFill>
@@ -11276,7 +11457,7 @@
                 <a:ea typeface="微软雅黑" panose="020B0503020204020204" charset="-122"/>
                 <a:cs typeface="微软雅黑" panose="020B0503020204020204" charset="-122"/>
               </a:rPr>
-              <a:t>场景范围</a:t>
+              <a:t>单一 SOC</a:t>
             </a:r>
             <a:endParaRPr sz="1420" b="1">
               <a:solidFill>
@@ -11326,7 +11507,7 @@
                 <a:ea typeface="微软雅黑" panose="020B0503020204020204" charset="-122"/>
                 <a:cs typeface="微软雅黑" panose="020B0503020204020204" charset="-122"/>
               </a:rPr>
-              <a:t>SCENARIO COVERAGE</a:t>
+              <a:t>SINGLE-SOC BIAS · 作者明确承认样本偏差</a:t>
             </a:r>
             <a:endParaRPr sz="970" spc="37">
               <a:solidFill>
@@ -11376,7 +11557,7 @@
                 <a:ea typeface="微软雅黑" panose="020B0503020204020204" charset="-122"/>
                 <a:cs typeface="微软雅黑" panose="020B0503020204020204" charset="-122"/>
               </a:rPr>
-              <a:t>说明研究场景与目标使用场景之间的差异。</a:t>
+              <a:t>NCSA 是开放网络科研设施（9 人团队、17,000+ 用户），不代表政府/大企业 SOC；如 off-hours 延迟对跨时区轮班组织未必成立，对资源更少的 SOC 可能更严重</a:t>
             </a:r>
             <a:endParaRPr sz="1120">
               <a:solidFill>
@@ -11476,7 +11657,7 @@
                 <a:ea typeface="微软雅黑" panose="020B0503020204020204" charset="-122"/>
                 <a:cs typeface="微软雅黑" panose="020B0503020204020204" charset="-122"/>
               </a:rPr>
-              <a:t>数据覆盖</a:t>
+              <a:t>仅网络告警（下界）</a:t>
             </a:r>
             <a:endParaRPr sz="1420" b="1">
               <a:solidFill>
@@ -11526,7 +11707,7 @@
                 <a:ea typeface="微软雅黑" panose="020B0503020204020204" charset="-122"/>
                 <a:cs typeface="微软雅黑" panose="020B0503020204020204" charset="-122"/>
               </a:rPr>
-              <a:t>OBSERVED DATA</a:t>
+              <a:t>NETWORK-ONLY LOWER BOUND</a:t>
             </a:r>
             <a:endParaRPr sz="970" spc="37">
               <a:solidFill>
@@ -11576,7 +11757,7 @@
                 <a:ea typeface="微软雅黑" panose="020B0503020204020204" charset="-122"/>
                 <a:cs typeface="微软雅黑" panose="020B0503020204020204" charset="-122"/>
               </a:rPr>
-              <a:t>交代观测到什么，以及哪些信息不可见。</a:t>
+              <a:t>不含主机 IDS / EDR / 合作方告警；漏报结论只在网络监控语境内成立，不能推广为"SOC 检测能力"的整体结论</a:t>
             </a:r>
             <a:endParaRPr sz="1120">
               <a:solidFill>
@@ -11676,7 +11857,7 @@
                 <a:ea typeface="微软雅黑" panose="020B0503020204020204" charset="-122"/>
                 <a:cs typeface="微软雅黑" panose="020B0503020204020204" charset="-122"/>
               </a:rPr>
-              <a:t>时间范围</a:t>
+              <a:t>时间较旧</a:t>
             </a:r>
             <a:endParaRPr sz="1420" b="1">
               <a:solidFill>
@@ -11726,7 +11907,7 @@
                 <a:ea typeface="微软雅黑" panose="020B0503020204020204" charset="-122"/>
                 <a:cs typeface="微软雅黑" panose="020B0503020204020204" charset="-122"/>
               </a:rPr>
-              <a:t>TIME WINDOW</a:t>
+              <a:t>2018–2022，事件至 2022.03</a:t>
             </a:r>
             <a:endParaRPr sz="970" spc="37">
               <a:solidFill>
@@ -11776,7 +11957,7 @@
                 <a:ea typeface="微软雅黑" panose="020B0503020204020204" charset="-122"/>
                 <a:cs typeface="微软雅黑" panose="020B0503020204020204" charset="-122"/>
               </a:rPr>
-              <a:t>说明数据时段和环境变化对结论的影响。</a:t>
+              <a:t>规则集与威胁面持续演化（Mirai、Log4j 均为当时事件）；引用比例数字时要注意时效</a:t>
             </a:r>
             <a:endParaRPr sz="1120">
               <a:solidFill>
@@ -11876,7 +12057,7 @@
                 <a:ea typeface="微软雅黑" panose="020B0503020204020204" charset="-122"/>
                 <a:cs typeface="微软雅黑" panose="020B0503020204020204" charset="-122"/>
               </a:rPr>
-              <a:t>定义与判定</a:t>
+              <a:t>归因保守且不完备</a:t>
             </a:r>
             <a:endParaRPr sz="1420" b="1">
               <a:solidFill>
@@ -11926,7 +12107,7 @@
                 <a:ea typeface="微软雅黑" panose="020B0503020204020204" charset="-122"/>
                 <a:cs typeface="微软雅黑" panose="020B0503020204020204" charset="-122"/>
               </a:rPr>
-              <a:t>LABEL UNCERTAINTY</a:t>
+              <a:t>CONSERVATIVE ATTRIBUTION</a:t>
             </a:r>
             <a:endParaRPr sz="970" spc="37">
               <a:solidFill>
@@ -11976,7 +12157,7 @@
                 <a:ea typeface="微软雅黑" panose="020B0503020204020204" charset="-122"/>
                 <a:cs typeface="微软雅黑" panose="020B0503020204020204" charset="-122"/>
               </a:rPr>
-              <a:t>说明判定条件、未判定对象及不完备性。</a:t>
+              <a:t>attempt 靠 BHR 高置信签名、benign trigger 靠 2 名分析师白名单——都是</a:t>
             </a:r>
             <a:r>
               <a:rPr sz="1120" b="1">
@@ -11987,7 +12168,7 @@
                 <a:ea typeface="微软雅黑" panose="020B0503020204020204" charset="-122"/>
                 <a:cs typeface="微软雅黑" panose="020B0503020204020204" charset="-122"/>
               </a:rPr>
-              <a:t/>
+              <a:t>下界</a:t>
             </a:r>
             <a:r>
               <a:rPr sz="1120">
@@ -11998,7 +12179,7 @@
                 <a:ea typeface="微软雅黑" panose="020B0503020204020204" charset="-122"/>
                 <a:cs typeface="微软雅黑" panose="020B0503020204020204" charset="-122"/>
               </a:rPr>
-              <a:t/>
+              <a:t>估计；unknown 占 23.72%，部分标签可能互相混淆</a:t>
             </a:r>
             <a:endParaRPr sz="1120">
               <a:solidFill>
@@ -12098,7 +12279,7 @@
                 <a:ea typeface="微软雅黑" panose="020B0503020204020204" charset="-122"/>
                 <a:cs typeface="微软雅黑" panose="020B0503020204020204" charset="-122"/>
               </a:rPr>
-              <a:t>推断范围</a:t>
+              <a:t>相关 ≠ 因果</a:t>
             </a:r>
             <a:endParaRPr sz="1420" b="1">
               <a:solidFill>
@@ -12148,7 +12329,7 @@
                 <a:ea typeface="微软雅黑" panose="020B0503020204020204" charset="-122"/>
                 <a:cs typeface="微软雅黑" panose="020B0503020204020204" charset="-122"/>
               </a:rPr>
-              <a:t>INFERENCE BOUNDARY</a:t>
+              <a:t>OBSERVATIONAL STUDY</a:t>
             </a:r>
             <a:endParaRPr sz="970" spc="37">
               <a:solidFill>
@@ -12198,7 +12379,7 @@
                 <a:ea typeface="微软雅黑" panose="020B0503020204020204" charset="-122"/>
                 <a:cs typeface="微软雅黑" panose="020B0503020204020204" charset="-122"/>
               </a:rPr>
-              <a:t>区分观察关联、因果证据与其他解释。</a:t>
+              <a:t>作者原话：2011 年升级与攻击数量变化"should only be interpreted as a correlation"；off-hours 另有时区差的替代解释</a:t>
             </a:r>
             <a:endParaRPr sz="1120">
               <a:solidFill>
@@ -12298,7 +12479,7 @@
                 <a:ea typeface="微软雅黑" panose="020B0503020204020204" charset="-122"/>
                 <a:cs typeface="微软雅黑" panose="020B0503020204020204" charset="-122"/>
               </a:rPr>
-              <a:t>样本规模</a:t>
+              <a:t>子分析样本量小</a:t>
             </a:r>
             <a:endParaRPr sz="1420" b="1">
               <a:solidFill>
@@ -12348,7 +12529,7 @@
                 <a:ea typeface="微软雅黑" panose="020B0503020204020204" charset="-122"/>
                 <a:cs typeface="微软雅黑" panose="020B0503020204020204" charset="-122"/>
               </a:rPr>
-              <a:t>SAMPLE SIZE</a:t>
+              <a:t>SMALL SUBSAMPLES</a:t>
             </a:r>
             <a:endParaRPr sz="970" spc="37">
               <a:solidFill>
@@ -12398,7 +12579,7 @@
                 <a:ea typeface="微软雅黑" panose="020B0503020204020204" charset="-122"/>
                 <a:cs typeface="微软雅黑" panose="020B0503020204020204" charset="-122"/>
               </a:rPr>
-              <a:t>交代总体与各子分析样本，保留不确定性。</a:t>
+              <a:t>调查耗时仅 28 起、小时级分布 88/91 起、双时间戳 96 起，比例对抽样波动敏感；稀有模式结论仅基于 3 起</a:t>
             </a:r>
             <a:endParaRPr sz="1120">
               <a:solidFill>
@@ -12448,7 +12629,7 @@
                 <a:ea typeface="微软雅黑" panose="020B0503020204020204" charset="-122"/>
                 <a:cs typeface="微软雅黑" panose="020B0503020204020204" charset="-122"/>
               </a:rPr>
-              <a:t>占位模板，无研究结果。新稿填写真实来源。</a:t>
+              <a:t>来源：Yang et al., USENIX Security 2024，§3、§5、§8.3、Appendix A。</a:t>
             </a:r>
             <a:endParaRPr sz="1040">
               <a:solidFill>
@@ -12895,7 +13076,7 @@
                 <a:ea typeface="Times New Roman" panose="02020603050405020304"/>
                 <a:cs typeface="Times New Roman" panose="02020603050405020304"/>
               </a:rPr>
-              <a:t>04 · 方法论借鉴</a:t>
+              <a:t>04 · 方法论借鉴 / 4.3</a:t>
             </a:r>
             <a:endParaRPr sz="1120" spc="150">
               <a:solidFill>
@@ -12945,7 +13126,7 @@
                 <a:ea typeface="Times New Roman" panose="02020603050405020304"/>
                 <a:cs typeface="Times New Roman" panose="02020603050405020304"/>
               </a:rPr>
-              <a:t>方法论借鉴：哪些做法可以迁移？</a:t>
+              <a:t>对我们的借鉴：测量研究怎么做才可信（方法论层面）</a:t>
             </a:r>
             <a:endParaRPr sz="2990" b="1">
               <a:solidFill>
@@ -13045,7 +13226,7 @@
                 <a:ea typeface="微软雅黑" panose="020B0503020204020204" charset="-122"/>
                 <a:cs typeface="微软雅黑" panose="020B0503020204020204" charset="-122"/>
               </a:rPr>
-              <a:t>互补证据与对齐条件</a:t>
+              <a:t>双数据源 × 事件对齐</a:t>
             </a:r>
             <a:endParaRPr sz="1420" b="1">
               <a:solidFill>
@@ -13095,7 +13276,7 @@
                 <a:ea typeface="微软雅黑" panose="020B0503020204020204" charset="-122"/>
                 <a:cs typeface="微软雅黑" panose="020B0503020204020204" charset="-122"/>
               </a:rPr>
-              <a:t>明确不同证据各自提供什么，以及如何连接。</a:t>
+              <a:t>自动日志描述规模，人工确认的事件提供证据；</a:t>
             </a:r>
             <a:endParaRPr sz="1120">
               <a:solidFill>
@@ -13121,7 +13302,7 @@
                 <a:ea typeface="微软雅黑" panose="020B0503020204020204" charset="-122"/>
                 <a:cs typeface="微软雅黑" panose="020B0503020204020204" charset="-122"/>
               </a:rPr>
-              <a:t/>
+              <a:t>按时间戳与IP对齐，评估系统输出与已知事件。</a:t>
             </a:r>
             <a:endParaRPr sz="1120">
               <a:solidFill>
@@ -13221,7 +13402,7 @@
                 <a:ea typeface="微软雅黑" panose="020B0503020204020204" charset="-122"/>
                 <a:cs typeface="微软雅黑" panose="020B0503020204020204" charset="-122"/>
               </a:rPr>
-              <a:t>定义先于分析</a:t>
+              <a:t>标签语义先于模型</a:t>
             </a:r>
             <a:endParaRPr sz="1420" b="1">
               <a:solidFill>
@@ -13271,7 +13452,7 @@
                 <a:ea typeface="微软雅黑" panose="020B0503020204020204" charset="-122"/>
                 <a:cs typeface="微软雅黑" panose="020B0503020204020204" charset="-122"/>
               </a:rPr>
-              <a:t>先说明对象、指标和标签语义，再比较结果。</a:t>
+              <a:t>attempt / benign trigger提示二分类会掩盖中间态；</a:t>
             </a:r>
             <a:endParaRPr sz="1120">
               <a:solidFill>
@@ -13297,7 +13478,7 @@
                 <a:ea typeface="微软雅黑" panose="020B0503020204020204" charset="-122"/>
                 <a:cs typeface="微软雅黑" panose="020B0503020204020204" charset="-122"/>
               </a:rPr>
-              <a:t/>
+              <a:t>测量前先定义标签、负样本和未判定样本。</a:t>
             </a:r>
             <a:endParaRPr sz="1120">
               <a:solidFill>
@@ -13397,7 +13578,7 @@
                 <a:ea typeface="微软雅黑" panose="020B0503020204020204" charset="-122"/>
                 <a:cs typeface="微软雅黑" panose="020B0503020204020204" charset="-122"/>
               </a:rPr>
-              <a:t>不确定性明确呈现</a:t>
+              <a:t>保守归因 + 显式下界</a:t>
             </a:r>
             <a:endParaRPr sz="1420" b="1">
               <a:solidFill>
@@ -13447,7 +13628,7 @@
                 <a:ea typeface="微软雅黑" panose="020B0503020204020204" charset="-122"/>
                 <a:cs typeface="微软雅黑" panose="020B0503020204020204" charset="-122"/>
               </a:rPr>
-              <a:t>保留未知、缺失及保守判定，避免强行补齐。</a:t>
+              <a:t>判定不了的单独列 unknown（23.72%），保守判定并声明是下界——可信度来自对不确定性的显式呈现</a:t>
             </a:r>
             <a:endParaRPr sz="1120">
               <a:solidFill>
@@ -13547,7 +13728,7 @@
                 <a:ea typeface="微软雅黑" panose="020B0503020204020204" charset="-122"/>
                 <a:cs typeface="微软雅黑" panose="020B0503020204020204" charset="-122"/>
               </a:rPr>
-              <a:t>结论强度与验证范围</a:t>
+              <a:t>相关性表述纪律</a:t>
             </a:r>
             <a:endParaRPr sz="1420" b="1">
               <a:solidFill>
@@ -13597,7 +13778,7 @@
                 <a:ea typeface="微软雅黑" panose="020B0503020204020204" charset="-122"/>
                 <a:cs typeface="微软雅黑" panose="020B0503020204020204" charset="-122"/>
               </a:rPr>
-              <a:t>让每个结论对应证据，不扩大样本或推断。</a:t>
+              <a:t>所有观察性结论不写成因果；子样本量（28/88/96/3 起）主动交代——实证论文的表述边界范例</a:t>
             </a:r>
             <a:endParaRPr sz="1120">
               <a:solidFill>
@@ -13647,7 +13828,7 @@
                 <a:ea typeface="微软雅黑" panose="020B0503020204020204" charset="-122"/>
                 <a:cs typeface="微软雅黑" panose="020B0503020204020204" charset="-122"/>
               </a:rPr>
-              <a:t>个人归纳：填写与当前研究的联系及迁移条件，不直接照搬旧论文结果。</a:t>
+              <a:t>定位一句话：</a:t>
             </a:r>
             <a:r>
               <a:rPr sz="1230">
@@ -13658,7 +13839,7 @@
                 <a:ea typeface="微软雅黑" panose="020B0503020204020204" charset="-122"/>
                 <a:cs typeface="微软雅黑" panose="020B0503020204020204" charset="-122"/>
               </a:rPr>
-              <a:t/>
+              <a:t>它提供的是</a:t>
             </a:r>
             <a:r>
               <a:rPr sz="1230" b="1">
@@ -13669,7 +13850,7 @@
                 <a:ea typeface="微软雅黑" panose="020B0503020204020204" charset="-122"/>
                 <a:cs typeface="微软雅黑" panose="020B0503020204020204" charset="-122"/>
               </a:rPr>
-              <a:t/>
+              <a:t>运营侧</a:t>
             </a:r>
             <a:r>
               <a:rPr sz="1230">
@@ -13680,7 +13861,7 @@
                 <a:ea typeface="微软雅黑" panose="020B0503020204020204" charset="-122"/>
                 <a:cs typeface="微软雅黑" panose="020B0503020204020204" charset="-122"/>
               </a:rPr>
-              <a:t/>
+              <a:t>真实告警数据的量化图景，与相关的</a:t>
             </a:r>
             <a:r>
               <a:rPr sz="1230" b="1">
@@ -13691,7 +13872,7 @@
                 <a:ea typeface="微软雅黑" panose="020B0503020204020204" charset="-122"/>
                 <a:cs typeface="微软雅黑" panose="020B0503020204020204" charset="-122"/>
               </a:rPr>
-              <a:t/>
+              <a:t>算法侧</a:t>
             </a:r>
             <a:r>
               <a:rPr sz="1230">
@@ -13702,7 +13883,7 @@
                 <a:ea typeface="微软雅黑" panose="020B0503020204020204" charset="-122"/>
                 <a:cs typeface="微软雅黑" panose="020B0503020204020204" charset="-122"/>
               </a:rPr>
-              <a:t/>
+              <a:t> WF 防御研究互补看待；借鉴限于实证分析方法，不迁移其具体结论</a:t>
             </a:r>
             <a:endParaRPr sz="1230">
               <a:solidFill>
@@ -13752,7 +13933,7 @@
                 <a:ea typeface="微软雅黑" panose="020B0503020204020204" charset="-122"/>
                 <a:cs typeface="微软雅黑" panose="020B0503020204020204" charset="-122"/>
               </a:rPr>
-              <a:t>占位模板，无研究结果。新稿填写真实来源。</a:t>
+              <a:t>方法论归纳；据Yang et al., USENIX Security 2024，§3、§6.2、§7–8。</a:t>
             </a:r>
             <a:endParaRPr sz="1040">
               <a:solidFill>
@@ -14141,7 +14322,7 @@
                 <a:ea typeface="Times New Roman" panose="02020603050405020304"/>
                 <a:cs typeface="Times New Roman" panose="02020603050405020304"/>
               </a:rPr>
-              <a:t>结语：研究问题与证据回答</a:t>
+              <a:t>结语：把"告警过载"从抱怨变成数字</a:t>
             </a:r>
             <a:endParaRPr sz="2990" b="1">
               <a:solidFill>
@@ -14191,7 +14372,7 @@
                 <a:ea typeface="Times New Roman" panose="02020603050405020304"/>
                 <a:cs typeface="Times New Roman" panose="02020603050405020304"/>
               </a:rPr>
-              <a:t>回答一</a:t>
+              <a:t>0.01%</a:t>
             </a:r>
             <a:endParaRPr sz="2770" b="1">
               <a:solidFill>
@@ -14241,7 +14422,7 @@
                 <a:ea typeface="微软雅黑" panose="020B0503020204020204" charset="-122"/>
                 <a:cs typeface="微软雅黑" panose="020B0503020204020204" charset="-122"/>
               </a:rPr>
-              <a:t>填写研究问题一对应的已支持结论</a:t>
+              <a:t>后期已知成功攻击相关告警占比</a:t>
             </a:r>
             <a:endParaRPr sz="1120">
               <a:solidFill>
@@ -14267,7 +14448,7 @@
                 <a:ea typeface="微软雅黑" panose="020B0503020204020204" charset="-122"/>
                 <a:cs typeface="微软雅黑" panose="020B0503020204020204" charset="-122"/>
               </a:rPr>
-              <a:t/>
+              <a:t>1,114 / 14,429,534；非检测率</a:t>
             </a:r>
             <a:endParaRPr sz="1120">
               <a:solidFill>
@@ -14317,7 +14498,7 @@
                 <a:ea typeface="Times New Roman" panose="02020603050405020304"/>
                 <a:cs typeface="Times New Roman" panose="02020603050405020304"/>
               </a:rPr>
-              <a:t>回答二</a:t>
+              <a:t>48.91%</a:t>
             </a:r>
             <a:endParaRPr sz="2770" b="1">
               <a:solidFill>
@@ -14367,7 +14548,7 @@
                 <a:ea typeface="微软雅黑" panose="020B0503020204020204" charset="-122"/>
                 <a:cs typeface="微软雅黑" panose="020B0503020204020204" charset="-122"/>
               </a:rPr>
-              <a:t>填写研究问题二对应的已支持结论</a:t>
+              <a:t>良性触发占比——触发正确但业务可忽略</a:t>
             </a:r>
             <a:endParaRPr sz="1120">
               <a:solidFill>
@@ -14417,7 +14598,7 @@
                 <a:ea typeface="Times New Roman" panose="02020603050405020304"/>
                 <a:cs typeface="Times New Roman" panose="02020603050405020304"/>
               </a:rPr>
-              <a:t>回答三</a:t>
+              <a:t>44.9%</a:t>
             </a:r>
             <a:endParaRPr sz="2770" b="1">
               <a:solidFill>
@@ -14467,7 +14648,7 @@
                 <a:ea typeface="微软雅黑" panose="020B0503020204020204" charset="-122"/>
                 <a:cs typeface="微软雅黑" panose="020B0503020204020204" charset="-122"/>
               </a:rPr>
-              <a:t>填写研究问题三对应的已支持结论</a:t>
+              <a:t>后期BHR自动封禁；余量约1.4万条/日可能需关注</a:t>
             </a:r>
             <a:endParaRPr sz="1120">
               <a:solidFill>
@@ -14517,7 +14698,7 @@
                 <a:ea typeface="Times New Roman" panose="02020603050405020304"/>
                 <a:cs typeface="Times New Roman" panose="02020603050405020304"/>
               </a:rPr>
-              <a:t>边界</a:t>
+              <a:t>4 / 11</a:t>
             </a:r>
             <a:endParaRPr sz="2770" b="1">
               <a:solidFill>
@@ -14567,7 +14748,7 @@
                 <a:ea typeface="微软雅黑" panose="020B0503020204020204" charset="-122"/>
                 <a:cs typeface="微软雅黑" panose="020B0503020204020204" charset="-122"/>
               </a:rPr>
-              <a:t>保留最关键的适用条件与不确定性</a:t>
+              <a:t>11起中4起由用户或其他渠道发现，不等同网络零告警</a:t>
             </a:r>
             <a:endParaRPr sz="1120">
               <a:solidFill>
@@ -14617,7 +14798,7 @@
                 <a:ea typeface="Times New Roman" panose="02020603050405020304"/>
                 <a:cs typeface="Times New Roman" panose="02020603050405020304"/>
               </a:rPr>
-              <a:t>回到开场的问题，说明研究带来了什么认识。</a:t>
+              <a:t>告警的价值不取决于数量，而取决于</a:t>
             </a:r>
             <a:r>
               <a:rPr sz="1940" b="1">
@@ -14628,7 +14809,7 @@
                 <a:ea typeface="Times New Roman" panose="02020603050405020304"/>
                 <a:cs typeface="Times New Roman" panose="02020603050405020304"/>
               </a:rPr>
-              <a:t/>
+              <a:t>信噪比与可行动性</a:t>
             </a:r>
             <a:r>
               <a:rPr sz="1940" b="1">
@@ -14639,7 +14820,7 @@
                 <a:ea typeface="Times New Roman" panose="02020603050405020304"/>
                 <a:cs typeface="Times New Roman" panose="02020603050405020304"/>
               </a:rPr>
-              <a:t/>
+              <a:t>；</a:t>
             </a:r>
             <a:endParaRPr sz="1940" b="1">
               <a:solidFill>
@@ -14689,7 +14870,7 @@
                 <a:ea typeface="Times New Roman" panose="02020603050405020304"/>
                 <a:cs typeface="Times New Roman" panose="02020603050405020304"/>
               </a:rPr>
-              <a:t>区分已支持发现、作者建议与后续工作。</a:t>
+              <a:t>运营瓶颈涉及人力与日志链接；标签定义和稀有模式提供探索机会。</a:t>
             </a:r>
             <a:endParaRPr sz="1940" b="1">
               <a:solidFill>
@@ -14739,7 +14920,7 @@
                 <a:ea typeface="微软雅黑" panose="020B0503020204020204" charset="-122"/>
                 <a:cs typeface="微软雅黑" panose="020B0503020204020204" charset="-122"/>
               </a:rPr>
-              <a:t>填写简短方法论借鉴。谢谢大家，欢迎讨论。</a:t>
+              <a:t>对我们：</a:t>
             </a:r>
             <a:r>
               <a:rPr sz="1230">
@@ -14750,7 +14931,7 @@
                 <a:ea typeface="微软雅黑" panose="020B0503020204020204" charset="-122"/>
                 <a:cs typeface="微软雅黑" panose="020B0503020204020204" charset="-122"/>
               </a:rPr>
-              <a:t/>
+              <a:t>借鉴它"双数据源 × 保守归因 × 相关性纪律"的测量方法；把它看作运营侧的量化图景，与算法侧的 WF 防御研究互补地看待。  谢谢大家，欢迎批评指正。</a:t>
             </a:r>
             <a:endParaRPr sz="1230">
               <a:solidFill>
@@ -14800,7 +14981,7 @@
                 <a:ea typeface="微软雅黑" panose="020B0503020204020204" charset="-122"/>
                 <a:cs typeface="微软雅黑" panose="020B0503020204020204" charset="-122"/>
               </a:rPr>
-              <a:t>占位模板，无研究结果。新稿填写真实来源。</a:t>
+              <a:t>来源：Yang et al., USENIX Security 2024，摘要、Tables 3、4、8、§7–8。</a:t>
             </a:r>
             <a:endParaRPr sz="1040">
               <a:solidFill>
@@ -14994,12 +15175,19 @@
           </a:fontRef>
         </p:style>
       </p:cxnSp>
-      <p:sp>
-        <p:nvSpPr>
-          <p:cNvPr id="2000" name="Editable evidence placeholder"/>
-          <p:cNvSpPr txBox="1"/>
-          <p:nvPr/>
-        </p:nvSpPr>
+      <p:pic>
+        <p:nvPicPr>
+          <p:cNvPr id="3" name="el-1791698028462-16"/>
+          <p:cNvPicPr/>
+          <p:nvPr/>
+        </p:nvPicPr>
+        <p:blipFill>
+          <a:blip r:embed="rId1"/>
+          <a:srcRect b="47388"/>
+          <a:stretch>
+            <a:fillRect/>
+          </a:stretch>
+        </p:blipFill>
         <p:spPr>
           <a:xfrm>
             <a:off x="5485028" y="991210"/>
@@ -15008,39 +15196,27 @@
           <a:prstGeom prst="rect">
             <a:avLst/>
           </a:prstGeom>
-          <a:solidFill>
-            <a:srgbClr val="F3F5F8"/>
-          </a:solidFill>
-          <a:ln w="9525">
+          <a:ln w="9523" algn="in">
             <a:solidFill>
               <a:srgbClr val="D8DDE3"/>
             </a:solidFill>
-          </a:ln>
-        </p:spPr>
-        <p:txBody>
-          <a:bodyPr anchor="ctr"/>
-          <a:lstStyle/>
-          <a:p>
-            <a:pPr algn="ctr"/>
-            <a:r>
-              <a:rPr lang="zh-CN" sz="1800">
-                <a:solidFill>
-                  <a:srgbClr val="5A6472"/>
-                </a:solidFill>
-                <a:latin typeface="Times New Roman"/>
-                <a:ea typeface="微软雅黑"/>
-              </a:rPr>
-              <a:t>公开来源截图占位</a:t>
-            </a:r>
-          </a:p>
-        </p:txBody>
-      </p:sp>
-      <p:sp>
-        <p:nvSpPr>
-          <p:cNvPr id="2001" name="Editable evidence placeholder"/>
-          <p:cNvSpPr txBox="1"/>
-          <p:nvPr/>
-        </p:nvSpPr>
+            <a:prstDash val="solid"/>
+          </a:ln>
+        </p:spPr>
+      </p:pic>
+      <p:pic>
+        <p:nvPicPr>
+          <p:cNvPr id="4" name="el-1791698028534-17"/>
+          <p:cNvPicPr/>
+          <p:nvPr/>
+        </p:nvPicPr>
+        <p:blipFill>
+          <a:blip r:embed="rId2"/>
+          <a:srcRect b="41883"/>
+          <a:stretch>
+            <a:fillRect/>
+          </a:stretch>
+        </p:blipFill>
         <p:spPr>
           <a:xfrm>
             <a:off x="5485028" y="3790860"/>
@@ -15049,33 +15225,14 @@
           <a:prstGeom prst="rect">
             <a:avLst/>
           </a:prstGeom>
-          <a:solidFill>
-            <a:srgbClr val="F3F5F8"/>
-          </a:solidFill>
-          <a:ln w="9525">
+          <a:ln w="9523" algn="in">
             <a:solidFill>
               <a:srgbClr val="D8DDE3"/>
             </a:solidFill>
-          </a:ln>
-        </p:spPr>
-        <p:txBody>
-          <a:bodyPr anchor="ctr"/>
-          <a:lstStyle/>
-          <a:p>
-            <a:pPr algn="ctr"/>
-            <a:r>
-              <a:rPr lang="zh-CN" sz="1800">
-                <a:solidFill>
-                  <a:srgbClr val="5A6472"/>
-                </a:solidFill>
-                <a:latin typeface="Times New Roman"/>
-                <a:ea typeface="微软雅黑"/>
-              </a:rPr>
-              <a:t>公开来源截图占位</a:t>
-            </a:r>
-          </a:p>
-        </p:txBody>
-      </p:sp>
+            <a:prstDash val="solid"/>
+          </a:ln>
+        </p:spPr>
+      </p:pic>
       <p:cxnSp>
         <p:nvCxnSpPr>
           <p:cNvPr id="5" name="el-1791698028418-3"/>
@@ -15199,7 +15356,7 @@
                 <a:ea typeface="Times New Roman" panose="02020603050405020304"/>
                 <a:cs typeface="Times New Roman" panose="02020603050405020304"/>
               </a:rPr>
-              <a:t>作者、团队与研究条件</a:t>
+              <a:t>第一作者与团队：UIUC × NCSA × IBM Research</a:t>
             </a:r>
             <a:endParaRPr sz="2990" b="1">
               <a:solidFill>
@@ -15299,7 +15456,7 @@
                 <a:ea typeface="微软雅黑" panose="020B0503020204020204" charset="-122"/>
                 <a:cs typeface="微软雅黑" panose="020B0503020204020204" charset="-122"/>
               </a:rPr>
-              <a:t>作者与研究背景</a:t>
+              <a:t>Limin Yang — 共同第一作者</a:t>
             </a:r>
             <a:endParaRPr sz="1420" b="1">
               <a:solidFill>
@@ -15349,7 +15506,7 @@
                 <a:ea typeface="微软雅黑" panose="020B0503020204020204" charset="-122"/>
                 <a:cs typeface="微软雅黑" panose="020B0503020204020204" charset="-122"/>
               </a:rPr>
-              <a:t>填写与本次研究直接相关的作者背景。</a:t>
+              <a:t>Limin Yang与Zhi Chen为共同第一作者，论文以*标注贡献相同。</a:t>
             </a:r>
             <a:endParaRPr sz="1230">
               <a:solidFill>
@@ -15449,7 +15606,7 @@
                 <a:ea typeface="微软雅黑" panose="020B0503020204020204" charset="-122"/>
                 <a:cs typeface="微软雅黑" panose="020B0503020204020204" charset="-122"/>
               </a:rPr>
-              <a:t>研究团队与方向</a:t>
+              <a:t>UIUC Gang Wang 组 · 安全 × 机器学习</a:t>
             </a:r>
             <a:endParaRPr sz="1420" b="1">
               <a:solidFill>
@@ -15499,7 +15656,7 @@
                 <a:ea typeface="微软雅黑" panose="020B0503020204020204" charset="-122"/>
                 <a:cs typeface="微软雅黑" panose="020B0503020204020204" charset="-122"/>
               </a:rPr>
-              <a:t>说明团队的研究基础，保留必要的公开来源。</a:t>
+              <a:t>此前一作发表 CADE（USENIX Security 2021，安全场景概念漂移检测）</a:t>
             </a:r>
             <a:endParaRPr sz="1230">
               <a:solidFill>
@@ -15599,7 +15756,7 @@
                 <a:ea typeface="微软雅黑" panose="020B0503020204020204" charset="-122"/>
                 <a:cs typeface="微软雅黑" panose="020B0503020204020204" charset="-122"/>
               </a:rPr>
-              <a:t>数据或实验合作</a:t>
+              <a:t>产学协作 + 真实运营数据</a:t>
             </a:r>
             <a:endParaRPr sz="1420" b="1">
               <a:solidFill>
@@ -15649,7 +15806,7 @@
                 <a:ea typeface="微软雅黑" panose="020B0503020204020204" charset="-122"/>
                 <a:cs typeface="微软雅黑" panose="020B0503020204020204" charset="-122"/>
               </a:rPr>
-              <a:t>交代数据、设施或领域经验如何支持研究。</a:t>
+              <a:t>NCSA安全团队（Phuong Cao、Alexander Withers）提供数据与运营上下文；IBM Research参与；合著者包含该SOC成员。</a:t>
             </a:r>
             <a:endParaRPr sz="1230">
               <a:solidFill>
@@ -15749,7 +15906,7 @@
                 <a:ea typeface="微软雅黑" panose="020B0503020204020204" charset="-122"/>
                 <a:cs typeface="微软雅黑" panose="020B0503020204020204" charset="-122"/>
               </a:rPr>
-              <a:t>开放与使用范围</a:t>
+              <a:t>伦理与开放</a:t>
             </a:r>
             <a:endParaRPr sz="1420" b="1">
               <a:solidFill>
@@ -15799,7 +15956,7 @@
                 <a:ea typeface="微软雅黑" panose="020B0503020204020204" charset="-122"/>
                 <a:cs typeface="微软雅黑" panose="020B0503020204020204" charset="-122"/>
               </a:rPr>
-              <a:t>按实际材料说明可访问内容与使用条件。</a:t>
+              <a:t>研究经IRB审查批准；多数分析使用哈希IP；公开项目代码与Postgres案例当月的脱敏告警样本。</a:t>
             </a:r>
             <a:endParaRPr sz="1230">
               <a:solidFill>
@@ -15849,7 +16006,7 @@
                 <a:ea typeface="微软雅黑" panose="020B0503020204020204" charset="-122"/>
                 <a:cs typeface="微软雅黑" panose="020B0503020204020204" charset="-122"/>
               </a:rPr>
-              <a:t>作者或书目证据位：按来源替换</a:t>
+              <a:t>dblp书目页面（含本论文条目；同名消歧页）</a:t>
             </a:r>
             <a:endParaRPr sz="970">
               <a:solidFill>
@@ -15899,7 +16056,7 @@
                 <a:ea typeface="微软雅黑" panose="020B0503020204020204" charset="-122"/>
                 <a:cs typeface="微软雅黑" panose="020B0503020204020204" charset="-122"/>
               </a:rPr>
-              <a:t>机构或研究设施证据位：按来源替换</a:t>
+              <a:t>数据来源机构：NCSA 官网（美国国家超级计算应用中心，ncsa.illinois.edu）</a:t>
             </a:r>
             <a:endParaRPr sz="970">
               <a:solidFill>
@@ -15949,7 +16106,7 @@
                 <a:ea typeface="微软雅黑" panose="020B0503020204020204" charset="-122"/>
                 <a:cs typeface="微软雅黑" panose="020B0503020204020204" charset="-122"/>
               </a:rPr>
-              <a:t>占位模板，无研究结果。新稿填写真实来源。</a:t>
+              <a:t>来源：Yang et al.，USENIX Security 2024，首页/§3/§8.3；USENIX 2021、作者CV；dblp/NCSA网页。</a:t>
             </a:r>
             <a:endParaRPr sz="1040">
               <a:solidFill>
@@ -16510,7 +16667,7 @@
                 <a:ea typeface="微软雅黑" panose="020B0503020204020204" charset="-122"/>
                 <a:cs typeface="微软雅黑" panose="020B0503020204020204" charset="-122"/>
               </a:rPr>
-              <a:t>背景与研究问题</a:t>
+              <a:t>背景与概念</a:t>
             </a:r>
             <a:endParaRPr sz="1720" b="1">
               <a:solidFill>
@@ -16560,7 +16717,7 @@
                 <a:ea typeface="微软雅黑" panose="020B0503020204020204" charset="-122"/>
                 <a:cs typeface="微软雅黑" panose="020B0503020204020204" charset="-122"/>
               </a:rPr>
-              <a:t>研究对象、关键概念与实际困难；说明为什么值得研究。</a:t>
+              <a:t>SOC / SIEM / 告警 triage 是什么；告警过载问题；为什么需要定量测量（3 个研究问题）</a:t>
             </a:r>
             <a:endParaRPr sz="1230">
               <a:solidFill>
@@ -16660,7 +16817,7 @@
                 <a:ea typeface="微软雅黑" panose="020B0503020204020204" charset="-122"/>
                 <a:cs typeface="微软雅黑" panose="020B0503020204020204" charset="-122"/>
               </a:rPr>
-              <a:t>总体方法与数据</a:t>
+              <a:t>数据集与方法</a:t>
             </a:r>
             <a:endParaRPr sz="1720" b="1">
               <a:solidFill>
@@ -16710,7 +16867,7 @@
                 <a:ea typeface="微软雅黑" panose="020B0503020204020204" charset="-122"/>
                 <a:cs typeface="微软雅黑" panose="020B0503020204020204" charset="-122"/>
               </a:rPr>
-              <a:t>先介绍总体思路，再展开数据、定义与处理依据。</a:t>
+              <a:t>两段1.15亿条Zeek告警与20年227起已知成功攻击取证；三类已解释原因与unknown的定义和判定</a:t>
             </a:r>
             <a:endParaRPr sz="1230">
               <a:solidFill>
@@ -16810,7 +16967,7 @@
                 <a:ea typeface="微软雅黑" panose="020B0503020204020204" charset="-122"/>
                 <a:cs typeface="微软雅黑" panose="020B0503020204020204" charset="-122"/>
               </a:rPr>
-              <a:t>核心证据与发现</a:t>
+              <a:t>核心量化发现</a:t>
             </a:r>
             <a:endParaRPr sz="1720" b="1">
               <a:solidFill>
@@ -16860,7 +17017,7 @@
                 <a:ea typeface="微软雅黑" panose="020B0503020204020204" charset="-122"/>
                 <a:cs typeface="微软雅黑" panose="020B0503020204020204" charset="-122"/>
               </a:rPr>
-              <a:t>案例、量化结果及比较；用证据回答研究问题。</a:t>
+              <a:t>Postgres案例；告警体量与自动化、四分类和尝试画像；</a:t>
             </a:r>
             <a:endParaRPr sz="1230">
               <a:solidFill>
@@ -16886,7 +17043,7 @@
                 <a:ea typeface="微软雅黑" panose="020B0503020204020204" charset="-122"/>
                 <a:cs typeface="微软雅黑" panose="020B0503020204020204" charset="-122"/>
               </a:rPr>
-              <a:t/>
+              <a:t>告警与事件关联、稀有主机模式线索。</a:t>
             </a:r>
             <a:endParaRPr sz="1230">
               <a:solidFill>
@@ -16986,7 +17143,7 @@
                 <a:ea typeface="微软雅黑" panose="020B0503020204020204" charset="-122"/>
                 <a:cs typeface="微软雅黑" panose="020B0503020204020204" charset="-122"/>
               </a:rPr>
-              <a:t>启示、局限与结语</a:t>
+              <a:t>启示 · 局限 · 借鉴</a:t>
             </a:r>
             <a:endParaRPr sz="1720" b="1">
               <a:solidFill>
@@ -17036,7 +17193,7 @@
                 <a:ea typeface="微软雅黑" panose="020B0503020204020204" charset="-122"/>
                 <a:cs typeface="微软雅黑" panose="020B0503020204020204" charset="-122"/>
               </a:rPr>
-              <a:t>区分发现、建议与个人归纳，说明结论适用范围。</a:t>
+              <a:t>SOC运营与ML研究启示（区分观察结果与作者建议）；</a:t>
             </a:r>
             <a:endParaRPr sz="1230">
               <a:solidFill>
@@ -17062,7 +17219,7 @@
                 <a:ea typeface="微软雅黑" panose="020B0503020204020204" charset="-122"/>
                 <a:cs typeface="微软雅黑" panose="020B0503020204020204" charset="-122"/>
               </a:rPr>
-              <a:t/>
+              <a:t>外推边界、方法论借鉴。</a:t>
             </a:r>
             <a:endParaRPr sz="1230">
               <a:solidFill>
@@ -17112,7 +17269,7 @@
                 <a:ea typeface="微软雅黑" panose="020B0503020204020204" charset="-122"/>
                 <a:cs typeface="微软雅黑" panose="020B0503020204020204" charset="-122"/>
               </a:rPr>
-              <a:t>占位模板，无研究结果。新稿填写真实来源。</a:t>
+              <a:t>来源：Yang et al., USENIX Security 2024，§1、§3–8。</a:t>
             </a:r>
             <a:endParaRPr sz="1040">
               <a:solidFill>
@@ -17499,7 +17656,7 @@
                 <a:ea typeface="Times New Roman" panose="02020603050405020304"/>
                 <a:cs typeface="Times New Roman" panose="02020603050405020304"/>
               </a:rPr>
-              <a:t>01 · 背景与研究问题</a:t>
+              <a:t>01 · 背景与概念</a:t>
             </a:r>
             <a:endParaRPr sz="1120" spc="150">
               <a:solidFill>
@@ -17549,7 +17706,7 @@
                 <a:ea typeface="Times New Roman" panose="02020603050405020304"/>
                 <a:cs typeface="Times New Roman" panose="02020603050405020304"/>
               </a:rPr>
-              <a:t>研究场景、关键概念与研究问题</a:t>
+              <a:t>SOC 的日常：从告警 triage 到安全响应</a:t>
             </a:r>
             <a:endParaRPr sz="2990" b="1">
               <a:solidFill>
@@ -17603,7 +17760,7 @@
                 <a:ea typeface="微软雅黑" panose="020B0503020204020204" charset="-122"/>
                 <a:cs typeface="微软雅黑" panose="020B0503020204020204" charset="-122"/>
               </a:rPr>
-              <a:t>RQ1 · 核心困难</a:t>
+              <a:t>RQ1 · 瓶颈在哪</a:t>
             </a:r>
             <a:endParaRPr sz="1420" b="1">
               <a:solidFill>
@@ -17657,7 +17814,7 @@
                 <a:ea typeface="微软雅黑" panose="020B0503020204020204" charset="-122"/>
                 <a:cs typeface="微软雅黑" panose="020B0503020204020204" charset="-122"/>
               </a:rPr>
-              <a:t>填写场景中的实际困难，以及为什么现有证据不足。</a:t>
+              <a:t>SOC 威胁检测的关键瓶颈是什么？攻击者如何利用/响应这些瓶颈？</a:t>
             </a:r>
             <a:endParaRPr sz="1190">
               <a:solidFill>
@@ -17711,7 +17868,7 @@
                 <a:ea typeface="微软雅黑" panose="020B0503020204020204" charset="-122"/>
                 <a:cs typeface="微软雅黑" panose="020B0503020204020204" charset="-122"/>
               </a:rPr>
-              <a:t>RQ2 · 量化对象</a:t>
+              <a:t>RQ2 · 有多过量</a:t>
             </a:r>
             <a:endParaRPr sz="1420" b="1">
               <a:solidFill>
@@ -17765,7 +17922,7 @@
                 <a:ea typeface="微软雅黑" panose="020B0503020204020204" charset="-122"/>
                 <a:cs typeface="微软雅黑" panose="020B0503020204020204" charset="-122"/>
               </a:rPr>
-              <a:t>填写需要测量或比较的对象、范围和统计单位。</a:t>
+              <a:t>告警到底过量到什么程度？触发背后的常见原因是什么？</a:t>
             </a:r>
             <a:endParaRPr sz="1190">
               <a:solidFill>
@@ -17819,7 +17976,7 @@
                 <a:ea typeface="微软雅黑" panose="020B0503020204020204" charset="-122"/>
                 <a:cs typeface="微软雅黑" panose="020B0503020204020204" charset="-122"/>
               </a:rPr>
-              <a:t>RQ3 · 证据能力</a:t>
+              <a:t>RQ3 · 指示能力</a:t>
             </a:r>
             <a:endParaRPr sz="1420" b="1">
               <a:solidFill>
@@ -17873,7 +18030,7 @@
                 <a:ea typeface="微软雅黑" panose="020B0503020204020204" charset="-122"/>
                 <a:cs typeface="微软雅黑" panose="020B0503020204020204" charset="-122"/>
               </a:rPr>
-              <a:t>填写系统输出与目标事件之间需要验证的关系。</a:t>
+              <a:t>告警在多大程度上能关联或指示真实/成功的攻击？</a:t>
             </a:r>
             <a:endParaRPr sz="1190">
               <a:solidFill>
@@ -17923,7 +18080,7 @@
                 <a:ea typeface="微软雅黑" panose="020B0503020204020204" charset="-122"/>
                 <a:cs typeface="微软雅黑" panose="020B0503020204020204" charset="-122"/>
               </a:rPr>
-              <a:t>占位版式：问题与挑战可由RQ、场景和口播共同讲清。</a:t>
+              <a:t>已有研究多使用较短期日志或黑盒评测；本文结合长期数据与运营上下文分析。</a:t>
             </a:r>
             <a:endParaRPr sz="1120">
               <a:solidFill>
@@ -17973,7 +18130,7 @@
                 <a:ea typeface="微软雅黑" panose="020B0503020204020204" charset="-122"/>
                 <a:cs typeface="微软雅黑" panose="020B0503020204020204" charset="-122"/>
               </a:rPr>
-              <a:t>占位模板，无研究结果。新稿填写准确来源。</a:t>
+              <a:t>来源：Yang et al., USENIX Security 2024，§1–3、Figure 1。</a:t>
             </a:r>
             <a:endParaRPr sz="1040">
               <a:solidFill>
@@ -18098,47 +18255,30 @@
           <a:p/>
         </p:txBody>
       </p:sp>
-      <p:sp>
-        <p:nvSpPr>
-          <p:cNvPr id="1000" name="Evidence placeholder"/>
-          <p:cNvSpPr txBox="1"/>
-          <p:nvPr/>
-        </p:nvSpPr>
+      <p:pic>
+        <p:nvPicPr>
+          <p:cNvPr id="37" name="v3_"/>
+          <p:cNvPicPr>
+            <a:picLocks noChangeAspect="1"/>
+          </p:cNvPicPr>
+          <p:nvPr/>
+        </p:nvPicPr>
+        <p:blipFill>
+          <a:blip r:embed="rId10"/>
+          <a:stretch>
+            <a:fillRect/>
+          </a:stretch>
+        </p:blipFill>
         <p:spPr>
           <a:xfrm>
             <a:off x="614045" y="1222975"/>
-            <a:ext cx="5410200" cy="2914720"/>
-          </a:xfrm>
-          <a:prstGeom prst="rect">
-            <a:avLst/>
-          </a:prstGeom>
-          <a:solidFill>
-            <a:srgbClr val="F3F5F8"/>
-          </a:solidFill>
-          <a:ln w="9525">
-            <a:solidFill>
-              <a:srgbClr val="D8DDE3"/>
-            </a:solidFill>
-          </a:ln>
-        </p:spPr>
-        <p:txBody>
-          <a:bodyPr anchor="ctr"/>
-          <a:lstStyle/>
-          <a:p>
-            <a:pPr algn="ctr"/>
-            <a:r>
-              <a:rPr lang="zh-CN" sz="1800">
-                <a:solidFill>
-                  <a:srgbClr val="5A6472"/>
-                </a:solidFill>
-                <a:latin typeface="Times New Roman"/>
-                <a:ea typeface="微软雅黑"/>
-              </a:rPr>
-              <a:t>证据图占位 · 按授权替换</a:t>
-            </a:r>
-          </a:p>
-        </p:txBody>
-      </p:sp>
+            <a:ext cx="5562600" cy="2914720"/>
+          </a:xfrm>
+          <a:prstGeom prst="rect">
+            <a:avLst/>
+          </a:prstGeom>
+        </p:spPr>
+      </p:pic>
       <p:sp>
         <p:nvSpPr>
           <p:cNvPr id="38" name="v3_P04 fig-cn"/>
@@ -18196,7 +18336,7 @@
                 <a:ea typeface="微软雅黑" panose="020B0503020204020204" charset="-122"/>
                 <a:cs typeface="微软雅黑" panose="020B0503020204020204" charset="-122"/>
               </a:rPr>
-              <a:t>证据位：按授权替换为场景图或原始图</a:t>
+              <a:t>Figure 1：绿色模块为本文数据来源</a:t>
             </a:r>
             <a:endParaRPr sz="1275" b="0">
               <a:solidFill>
@@ -18498,7 +18638,7 @@
                 <a:ea typeface="Times New Roman" panose="02020603050405020304"/>
                 <a:cs typeface="Times New Roman" panose="02020603050405020304"/>
               </a:rPr>
-              <a:t>对象</a:t>
+              <a:t>SOC</a:t>
             </a:r>
             <a:endParaRPr sz="1120" spc="75">
               <a:solidFill>
@@ -18548,7 +18688,7 @@
                 <a:ea typeface="微软雅黑" panose="020B0503020204020204" charset="-122"/>
                 <a:cs typeface="微软雅黑" panose="020B0503020204020204" charset="-122"/>
               </a:rPr>
-              <a:t>研究对象与范围</a:t>
+              <a:t>Security Operations Center 安全运营中心</a:t>
             </a:r>
             <a:endParaRPr sz="1490" b="1">
               <a:solidFill>
@@ -18598,7 +18738,7 @@
                 <a:ea typeface="微软雅黑" panose="020B0503020204020204" charset="-122"/>
                 <a:cs typeface="微软雅黑" panose="020B0503020204020204" charset="-122"/>
               </a:rPr>
-              <a:t>说明研究场景、输入与可观察范围，保留不可见部分。</a:t>
+              <a:t>组织内负责检测、分析、响应安全威胁的核心单元；由人、流程、技术三要素构成（团队 + playbook + IDS/SIEM 等工具）</a:t>
             </a:r>
             <a:endParaRPr sz="1190">
               <a:solidFill>
@@ -18648,7 +18788,7 @@
                 <a:ea typeface="Times New Roman" panose="02020603050405020304"/>
                 <a:cs typeface="Times New Roman" panose="02020603050405020304"/>
               </a:rPr>
-              <a:t>术语</a:t>
+              <a:t>SIEM</a:t>
             </a:r>
             <a:endParaRPr sz="1120" spc="75">
               <a:solidFill>
@@ -18698,7 +18838,7 @@
                 <a:ea typeface="微软雅黑" panose="020B0503020204020204" charset="-122"/>
                 <a:cs typeface="微软雅黑" panose="020B0503020204020204" charset="-122"/>
               </a:rPr>
-              <a:t>首次使用的关键概念</a:t>
+              <a:t>Security Information &amp; Event Management</a:t>
             </a:r>
             <a:endParaRPr sz="1490" b="1">
               <a:solidFill>
@@ -18748,7 +18888,7 @@
                 <a:ea typeface="微软雅黑" panose="020B0503020204020204" charset="-122"/>
                 <a:cs typeface="微软雅黑" panose="020B0503020204020204" charset="-122"/>
               </a:rPr>
-              <a:t>用听众能理解的语言解释定义，避免仅展开缩写却不说明含义。</a:t>
+              <a:t>聚合网络监控、系统日志、审计日志与威胁情报的平台，给分析师实时安全事件视图；本文 SOC 用 Splunk 实现</a:t>
             </a:r>
             <a:endParaRPr sz="1190">
               <a:solidFill>
@@ -18798,7 +18938,7 @@
                 <a:ea typeface="Times New Roman" panose="02020603050405020304"/>
                 <a:cs typeface="Times New Roman" panose="02020603050405020304"/>
               </a:rPr>
-              <a:t>问题</a:t>
+              <a:t>Triage</a:t>
             </a:r>
             <a:endParaRPr sz="1120" spc="75">
               <a:solidFill>
@@ -18848,7 +18988,7 @@
                 <a:ea typeface="微软雅黑" panose="020B0503020204020204" charset="-122"/>
                 <a:cs typeface="微软雅黑" panose="020B0503020204020204" charset="-122"/>
               </a:rPr>
-              <a:t>实际代价与研究缺口</a:t>
+              <a:t>告警分诊：分析师的日常瓶颈</a:t>
             </a:r>
             <a:endParaRPr sz="1490" b="1">
               <a:solidFill>
@@ -18898,7 +19038,7 @@
                 <a:ea typeface="微软雅黑" panose="020B0503020204020204" charset="-122"/>
                 <a:cs typeface="微软雅黑" panose="020B0503020204020204" charset="-122"/>
               </a:rPr>
-              <a:t>连接业务流程和研究问题，说明为什么值得进一步测量或设计。</a:t>
+              <a:t>IDS 等工具持续产生 alert，人工判断"哪些要处理"；告警过载导致 alert fatigue 与 burnout（用户研究结论）</a:t>
             </a:r>
             <a:endParaRPr sz="1190">
               <a:solidFill>
@@ -19161,7 +19301,7 @@
                 <a:ea typeface="Times New Roman" panose="02020603050405020304"/>
                 <a:cs typeface="Times New Roman" panose="02020603050405020304"/>
               </a:rPr>
-              <a:t>02 · 总体方法与数据</a:t>
+              <a:t>02 · 数据集与方法 / 2.1</a:t>
             </a:r>
             <a:endParaRPr sz="1120" spc="150">
               <a:solidFill>
@@ -19211,7 +19351,7 @@
                 <a:ea typeface="Times New Roman" panose="02020603050405020304"/>
                 <a:cs typeface="Times New Roman" panose="02020603050405020304"/>
               </a:rPr>
-              <a:t>双数据源与互补证据</a:t>
+              <a:t>双数据源：海量告警 × 人工确认的真实攻击</a:t>
             </a:r>
             <a:endParaRPr sz="2990" b="1">
               <a:solidFill>
@@ -19261,7 +19401,7 @@
                 <a:ea typeface="微软雅黑" panose="020B0503020204020204" charset="-122"/>
                 <a:cs typeface="微软雅黑" panose="020B0503020204020204" charset="-122"/>
               </a:rPr>
-              <a:t>① 数据源A</a:t>
+              <a:t>① 网络告警日志</a:t>
             </a:r>
             <a:endParaRPr sz="1570" b="1">
               <a:solidFill>
@@ -19311,7 +19451,7 @@
                 <a:ea typeface="Times New Roman" panose="02020603050405020304"/>
                 <a:cs typeface="Times New Roman" panose="02020603050405020304"/>
               </a:rPr>
-              <a:t>规模A</a:t>
+              <a:t>115,617,526</a:t>
             </a:r>
             <a:r>
               <a:rPr sz="1420" b="1">
@@ -19322,7 +19462,7 @@
                 <a:ea typeface="Times New Roman" panose="02020603050405020304"/>
                 <a:cs typeface="Times New Roman" panose="02020603050405020304"/>
               </a:rPr>
-              <a:t/>
+              <a:t> 条</a:t>
             </a:r>
             <a:endParaRPr sz="1420" b="1">
               <a:solidFill>
@@ -19372,7 +19512,7 @@
                 <a:ea typeface="微软雅黑" panose="020B0503020204020204" charset="-122"/>
                 <a:cs typeface="微软雅黑" panose="020B0503020204020204" charset="-122"/>
               </a:rPr>
-              <a:t>填写单位与时间窗</a:t>
+              <a:t>Zeek NIDS｜两段日志</a:t>
             </a:r>
             <a:endParaRPr sz="1080">
               <a:solidFill>
@@ -19398,7 +19538,7 @@
                 <a:ea typeface="微软雅黑" panose="020B0503020204020204" charset="-122"/>
                 <a:cs typeface="微软雅黑" panose="020B0503020204020204" charset="-122"/>
               </a:rPr>
-              <a:t/>
+              <a:t>2018/04—2020/08</a:t>
             </a:r>
             <a:endParaRPr sz="1080">
               <a:solidFill>
@@ -19424,7 +19564,7 @@
                 <a:ea typeface="微软雅黑" panose="020B0503020204020204" charset="-122"/>
                 <a:cs typeface="微软雅黑" panose="020B0503020204020204" charset="-122"/>
               </a:rPr>
-              <a:t/>
+              <a:t>2020/12—2022/07</a:t>
             </a:r>
             <a:endParaRPr sz="1080">
               <a:solidFill>
@@ -19474,7 +19614,7 @@
                 <a:ea typeface="微软雅黑" panose="020B0503020204020204" charset="-122"/>
                 <a:cs typeface="微软雅黑" panose="020B0503020204020204" charset="-122"/>
               </a:rPr>
-              <a:t>字段：输入及可观察信息</a:t>
+              <a:t>字段：</a:t>
             </a:r>
             <a:r>
               <a:rPr sz="1230">
@@ -19485,7 +19625,7 @@
                 <a:ea typeface="微软雅黑" panose="020B0503020204020204" charset="-122"/>
                 <a:cs typeface="微软雅黑" panose="020B0503020204020204" charset="-122"/>
               </a:rPr>
-              <a:t/>
+              <a:t>时间戳、涉及 IP、告警类别与元数据</a:t>
             </a:r>
             <a:endParaRPr sz="1230">
               <a:solidFill>
@@ -19535,7 +19675,7 @@
                 <a:ea typeface="微软雅黑" panose="020B0503020204020204" charset="-122"/>
                 <a:cs typeface="微软雅黑" panose="020B0503020204020204" charset="-122"/>
               </a:rPr>
-              <a:t>处理：如何由数据得到证据</a:t>
+              <a:t>BHR 标签：</a:t>
             </a:r>
             <a:r>
               <a:rPr sz="1230">
@@ -19546,7 +19686,7 @@
                 <a:ea typeface="微软雅黑" panose="020B0503020204020204" charset="-122"/>
                 <a:cs typeface="微软雅黑" panose="020B0503020204020204" charset="-122"/>
               </a:rPr>
-              <a:t/>
+              <a:t>2020 起自动封禁机制生效（2020–2022 可用于识别 attempt）</a:t>
             </a:r>
             <a:endParaRPr sz="1230">
               <a:solidFill>
@@ -19596,7 +19736,7 @@
                 <a:ea typeface="微软雅黑" panose="020B0503020204020204" charset="-122"/>
                 <a:cs typeface="微软雅黑" panose="020B0503020204020204" charset="-122"/>
               </a:rPr>
-              <a:t>用途：主要回答哪个研究问题</a:t>
+              <a:t>SIEM：</a:t>
             </a:r>
             <a:r>
               <a:rPr sz="1230">
@@ -19607,7 +19747,7 @@
                 <a:ea typeface="微软雅黑" panose="020B0503020204020204" charset="-122"/>
                 <a:cs typeface="微软雅黑" panose="020B0503020204020204" charset="-122"/>
               </a:rPr>
-              <a:t/>
+              <a:t>Splunk 聚合多源日志供分析师实时查看</a:t>
             </a:r>
             <a:endParaRPr sz="1230">
               <a:solidFill>
@@ -19657,7 +19797,7 @@
                 <a:ea typeface="微软雅黑" panose="020B0503020204020204" charset="-122"/>
                 <a:cs typeface="微软雅黑" panose="020B0503020204020204" charset="-122"/>
               </a:rPr>
-              <a:t>边界：缺失信息与覆盖范围</a:t>
+              <a:t>边界：</a:t>
             </a:r>
             <a:r>
               <a:rPr sz="1230">
@@ -19668,7 +19808,7 @@
                 <a:ea typeface="微软雅黑" panose="020B0503020204020204" charset="-122"/>
                 <a:cs typeface="微软雅黑" panose="020B0503020204020204" charset="-122"/>
               </a:rPr>
-              <a:t/>
+              <a:t>不含主机 IDS / EDR / 商业工具告警 → 是该 SOC 全部告警的</a:t>
             </a:r>
             <a:r>
               <a:rPr sz="1230" b="1">
@@ -19679,7 +19819,7 @@
                 <a:ea typeface="微软雅黑" panose="020B0503020204020204" charset="-122"/>
                 <a:cs typeface="微软雅黑" panose="020B0503020204020204" charset="-122"/>
               </a:rPr>
-              <a:t/>
+              <a:t>下界</a:t>
             </a:r>
             <a:endParaRPr sz="1230" b="1">
               <a:solidFill>
@@ -19729,7 +19869,7 @@
                 <a:ea typeface="微软雅黑" panose="020B0503020204020204" charset="-122"/>
                 <a:cs typeface="微软雅黑" panose="020B0503020204020204" charset="-122"/>
               </a:rPr>
-              <a:t>② 数据源B</a:t>
+              <a:t>② 真实攻击 Ground Truth</a:t>
             </a:r>
             <a:endParaRPr sz="1570" b="1">
               <a:solidFill>
@@ -19779,7 +19919,7 @@
                 <a:ea typeface="Times New Roman" panose="02020603050405020304"/>
                 <a:cs typeface="Times New Roman" panose="02020603050405020304"/>
               </a:rPr>
-              <a:t>规模B</a:t>
+              <a:t>227 </a:t>
             </a:r>
             <a:r>
               <a:rPr sz="1420" b="1">
@@ -19790,7 +19930,7 @@
                 <a:ea typeface="Times New Roman" panose="02020603050405020304"/>
                 <a:cs typeface="Times New Roman" panose="02020603050405020304"/>
               </a:rPr>
-              <a:t/>
+              <a:t>起 / 20 年</a:t>
             </a:r>
             <a:endParaRPr sz="1420" b="1">
               <a:solidFill>
@@ -19840,7 +19980,7 @@
                 <a:ea typeface="微软雅黑" panose="020B0503020204020204" charset="-122"/>
                 <a:cs typeface="微软雅黑" panose="020B0503020204020204" charset="-122"/>
               </a:rPr>
-              <a:t>填写来源与时间范围</a:t>
+              <a:t>攻击后取证报告 · 2002.01–2022.03</a:t>
             </a:r>
             <a:endParaRPr sz="1080">
               <a:solidFill>
@@ -19890,7 +20030,7 @@
                 <a:ea typeface="微软雅黑" panose="020B0503020204020204" charset="-122"/>
                 <a:cs typeface="微软雅黑" panose="020B0503020204020204" charset="-122"/>
               </a:rPr>
-              <a:t>定义：记录什么对象或事件</a:t>
+              <a:t>定义：</a:t>
             </a:r>
             <a:r>
               <a:rPr sz="1230">
@@ -19901,7 +20041,7 @@
                 <a:ea typeface="微软雅黑" panose="020B0503020204020204" charset="-122"/>
                 <a:cs typeface="微软雅黑" panose="020B0503020204020204" charset="-122"/>
               </a:rPr>
-              <a:t/>
+              <a:t>成功 compromise 系统/造成重大降级、数据泄露或失陷</a:t>
             </a:r>
             <a:endParaRPr sz="1230">
               <a:solidFill>
@@ -19951,7 +20091,7 @@
                 <a:ea typeface="微软雅黑" panose="020B0503020204020204" charset="-122"/>
                 <a:cs typeface="微软雅黑" panose="020B0503020204020204" charset="-122"/>
               </a:rPr>
-              <a:t>对齐：连接两来源的条件</a:t>
+              <a:t>重叠期：</a:t>
             </a:r>
             <a:r>
               <a:rPr sz="1230">
@@ -19962,7 +20102,7 @@
                 <a:ea typeface="微软雅黑" panose="020B0503020204020204" charset="-122"/>
                 <a:cs typeface="微软雅黑" panose="020B0503020204020204" charset="-122"/>
               </a:rPr>
-              <a:t/>
+              <a:t>其中 </a:t>
             </a:r>
             <a:r>
               <a:rPr sz="1230" b="1">
@@ -19973,7 +20113,7 @@
                 <a:ea typeface="微软雅黑" panose="020B0503020204020204" charset="-122"/>
                 <a:cs typeface="微软雅黑" panose="020B0503020204020204" charset="-122"/>
               </a:rPr>
-              <a:t/>
+              <a:t>11 起</a:t>
             </a:r>
             <a:r>
               <a:rPr sz="1230">
@@ -19984,7 +20124,7 @@
                 <a:ea typeface="微软雅黑" panose="020B0503020204020204" charset="-122"/>
                 <a:cs typeface="微软雅黑" panose="020B0503020204020204" charset="-122"/>
               </a:rPr>
-              <a:t/>
+              <a:t>落在告警数据覆盖的 2018–2022</a:t>
             </a:r>
             <a:endParaRPr sz="1230">
               <a:solidFill>
@@ -20034,7 +20174,7 @@
                 <a:ea typeface="微软雅黑" panose="020B0503020204020204" charset="-122"/>
                 <a:cs typeface="微软雅黑" panose="020B0503020204020204" charset="-122"/>
               </a:rPr>
-              <a:t>形态：结构与关键字段</a:t>
+              <a:t>形态：</a:t>
             </a:r>
             <a:r>
               <a:rPr sz="1230">
@@ -20045,7 +20185,7 @@
                 <a:ea typeface="微软雅黑" panose="020B0503020204020204" charset="-122"/>
                 <a:cs typeface="微软雅黑" panose="020B0503020204020204" charset="-122"/>
               </a:rPr>
-              <a:t/>
+              <a:t>非结构化报告（账号、IP、机器、调查过程与结论）</a:t>
             </a:r>
             <a:endParaRPr sz="1230">
               <a:solidFill>
@@ -20095,7 +20235,7 @@
                 <a:ea typeface="微软雅黑" panose="020B0503020204020204" charset="-122"/>
                 <a:cs typeface="微软雅黑" panose="020B0503020204020204" charset="-122"/>
               </a:rPr>
-              <a:t>标注：依据、人员或过程</a:t>
+              <a:t>标注：</a:t>
             </a:r>
             <a:r>
               <a:rPr sz="1230">
@@ -20106,7 +20246,7 @@
                 <a:ea typeface="微软雅黑" panose="020B0503020204020204" charset="-122"/>
                 <a:cs typeface="微软雅黑" panose="020B0503020204020204" charset="-122"/>
               </a:rPr>
-              <a:t/>
+              <a:t>2 名研究人员人工标注 1–2 个月 + MITRE ATT&amp;CK 编码</a:t>
             </a:r>
             <a:endParaRPr sz="1230">
               <a:solidFill>
@@ -20156,7 +20296,7 @@
                 <a:ea typeface="微软雅黑" panose="020B0503020204020204" charset="-122"/>
                 <a:cs typeface="微软雅黑" panose="020B0503020204020204" charset="-122"/>
               </a:rPr>
-              <a:t>先用口播概述输入、关键处理、输出与RQ的对应，再展开数据细节。保留不可见信息和选择条件。</a:t>
+              <a:t>环境特征：NCSA为中大型科研设施，数千台服务器、17,000+活跃用户、9人SOC团队，取得SOC-2-Type-2认证。网络为分段开放网络，内外部研究者均可访问计算节点。单一SOC且仅含网络告警，限制了结论外推范围。</a:t>
             </a:r>
             <a:endParaRPr sz="1190" b="1">
               <a:solidFill>
@@ -20206,7 +20346,7 @@
                 <a:ea typeface="微软雅黑" panose="020B0503020204020204" charset="-122"/>
                 <a:cs typeface="微软雅黑" panose="020B0503020204020204" charset="-122"/>
               </a:rPr>
-              <a:t>占位模板，无研究结果。新稿填写准确来源。</a:t>
+              <a:t>来源：Yang et al., USENIX Security 2024，§3、§5、Table 3、Appendix A。</a:t>
             </a:r>
             <a:endParaRPr sz="1040">
               <a:solidFill>
@@ -20400,12 +20540,18 @@
           </a:fontRef>
         </p:style>
       </p:cxnSp>
-      <p:sp>
-        <p:nvSpPr>
-          <p:cNvPr id="1000" name="Evidence placeholder"/>
-          <p:cNvSpPr txBox="1"/>
-          <p:nvPr/>
-        </p:nvSpPr>
+      <p:pic>
+        <p:nvPicPr>
+          <p:cNvPr id="3" name="el-1791698028992-8"/>
+          <p:cNvPicPr/>
+          <p:nvPr/>
+        </p:nvPicPr>
+        <p:blipFill>
+          <a:blip r:embed="rId1"/>
+          <a:stretch>
+            <a:fillRect/>
+          </a:stretch>
+        </p:blipFill>
         <p:spPr>
           <a:xfrm>
             <a:off x="685629" y="2049565"/>
@@ -20414,33 +20560,14 @@
           <a:prstGeom prst="rect">
             <a:avLst/>
           </a:prstGeom>
-          <a:solidFill>
-            <a:srgbClr val="F3F5F8"/>
-          </a:solidFill>
-          <a:ln w="9525">
+          <a:ln w="9523" algn="in">
             <a:solidFill>
               <a:srgbClr val="D8DDE3"/>
             </a:solidFill>
-          </a:ln>
-        </p:spPr>
-        <p:txBody>
-          <a:bodyPr anchor="ctr"/>
-          <a:lstStyle/>
-          <a:p>
-            <a:pPr algn="ctr"/>
-            <a:r>
-              <a:rPr lang="zh-CN" sz="1800">
-                <a:solidFill>
-                  <a:srgbClr val="5A6472"/>
-                </a:solidFill>
-                <a:latin typeface="Times New Roman"/>
-                <a:ea typeface="微软雅黑"/>
-              </a:rPr>
-              <a:t>证据图占位 · 按授权替换</a:t>
-            </a:r>
-          </a:p>
-        </p:txBody>
-      </p:sp>
+            <a:prstDash val="solid"/>
+          </a:ln>
+        </p:spPr>
+      </p:pic>
       <p:cxnSp>
         <p:nvCxnSpPr>
           <p:cNvPr id="4" name="el-1791698029002-13"/>
@@ -20706,7 +20833,7 @@
                 <a:ea typeface="Times New Roman" panose="02020603050405020304"/>
                 <a:cs typeface="Times New Roman" panose="02020603050405020304"/>
               </a:rPr>
-              <a:t>02 · 定义与判定</a:t>
+              <a:t>02 · 数据集与方法 / 2.2</a:t>
             </a:r>
             <a:endParaRPr sz="1120" spc="150">
               <a:solidFill>
@@ -20756,7 +20883,7 @@
                 <a:ea typeface="Times New Roman" panose="02020603050405020304"/>
                 <a:cs typeface="Times New Roman" panose="02020603050405020304"/>
               </a:rPr>
-              <a:t>标签语义与判定依据</a:t>
+              <a:t>告警三分法：True Attack / Attack Attempt / Benign Trigger</a:t>
             </a:r>
             <a:endParaRPr sz="2990" b="1">
               <a:solidFill>
@@ -20806,7 +20933,7 @@
                 <a:ea typeface="微软雅黑" panose="020B0503020204020204" charset="-122"/>
                 <a:cs typeface="微软雅黑" panose="020B0503020204020204" charset="-122"/>
               </a:rPr>
-              <a:t>证据位：替换为可追溯定义表</a:t>
+              <a:t>论文 Table 1：关键术语定义（Definitions）</a:t>
             </a:r>
             <a:endParaRPr sz="970">
               <a:solidFill>
@@ -20906,7 +21033,7 @@
                 <a:ea typeface="微软雅黑" panose="020B0503020204020204" charset="-122"/>
                 <a:cs typeface="微软雅黑" panose="020B0503020204020204" charset="-122"/>
               </a:rPr>
-              <a:t>类别A的判定依据</a:t>
+              <a:t>Attack attempts ← BHR 自动封禁标签</a:t>
             </a:r>
             <a:endParaRPr sz="1420" b="1">
               <a:solidFill>
@@ -20956,7 +21083,7 @@
                 <a:ea typeface="微软雅黑" panose="020B0503020204020204" charset="-122"/>
                 <a:cs typeface="微软雅黑" panose="020B0503020204020204" charset="-122"/>
               </a:rPr>
-              <a:t>填写明确的证据条件，说明为何此标签能回答前面的研究问题。</a:t>
+              <a:t>BHR仅封禁匹配高置信签名的行为；其标签仍混有良性触发，剔除后攻击尝试占27.37%。该分类是保守估计。</a:t>
             </a:r>
             <a:endParaRPr sz="1160">
               <a:solidFill>
@@ -21056,7 +21183,7 @@
                 <a:ea typeface="微软雅黑" panose="020B0503020204020204" charset="-122"/>
                 <a:cs typeface="微软雅黑" panose="020B0503020204020204" charset="-122"/>
               </a:rPr>
-              <a:t>类别B的判定依据</a:t>
+              <a:t>Benign triggers ← 2 名分析师 + IP 白名单</a:t>
             </a:r>
             <a:endParaRPr sz="1420" b="1">
               <a:solidFill>
@@ -21106,7 +21233,7 @@
                 <a:ea typeface="微软雅黑" panose="020B0503020204020204" charset="-122"/>
                 <a:cs typeface="微软雅黑" panose="020B0503020204020204" charset="-122"/>
               </a:rPr>
-              <a:t>填写与类别A的区别，保留保守识别或不完备的范围。</a:t>
+              <a:t>逐告警类别复核，结合组织上下文人工确认；方法刻意保守、只标有明确证据者 → 结果是</a:t>
             </a:r>
             <a:r>
               <a:rPr sz="1160" b="1">
@@ -21117,7 +21244,7 @@
                 <a:ea typeface="微软雅黑" panose="020B0503020204020204" charset="-122"/>
                 <a:cs typeface="微软雅黑" panose="020B0503020204020204" charset="-122"/>
               </a:rPr>
-              <a:t/>
+              <a:t>下界</a:t>
             </a:r>
             <a:r>
               <a:rPr sz="1160">
@@ -21128,7 +21255,7 @@
                 <a:ea typeface="微软雅黑" panose="020B0503020204020204" charset="-122"/>
                 <a:cs typeface="微软雅黑" panose="020B0503020204020204" charset="-122"/>
               </a:rPr>
-              <a:t/>
+              <a:t>估计</a:t>
             </a:r>
             <a:endParaRPr sz="1160">
               <a:solidFill>
@@ -21228,7 +21355,7 @@
                 <a:ea typeface="微软雅黑" panose="020B0503020204020204" charset="-122"/>
                 <a:cs typeface="微软雅黑" panose="020B0503020204020204" charset="-122"/>
               </a:rPr>
-              <a:t>类别C与未判定状态</a:t>
+              <a:t>True attacks ← 攻击后取证报告</a:t>
             </a:r>
             <a:endParaRPr sz="1420" b="1">
               <a:solidFill>
@@ -21278,7 +21405,7 @@
                 <a:ea typeface="微软雅黑" panose="020B0503020204020204" charset="-122"/>
                 <a:cs typeface="微软雅黑" panose="020B0503020204020204" charset="-122"/>
               </a:rPr>
-              <a:t>解释如何处理证据不足，不强行补成完整标签。</a:t>
+              <a:t>取证结论确认成功失陷或造成重大降级、中断、数据泄漏。</a:t>
             </a:r>
             <a:endParaRPr sz="1160">
               <a:solidFill>
@@ -21328,7 +21455,7 @@
                 <a:ea typeface="微软雅黑" panose="020B0503020204020204" charset="-122"/>
                 <a:cs typeface="微软雅黑" panose="020B0503020204020204" charset="-122"/>
               </a:rPr>
-              <a:t>关键限定：未知、缺失和零值各有语义。按实际材料说明，不能直接搬用本模板。</a:t>
+              <a:t>良性触发≠误报：规则正确命中事件，但业务背景允许忽略；FP是错误判为攻击。原因不明的23.72%单列unknown，不代表已确认安全。</a:t>
             </a:r>
             <a:endParaRPr sz="1160" b="1">
               <a:solidFill>
@@ -21378,7 +21505,7 @@
                 <a:ea typeface="微软雅黑" panose="020B0503020204020204" charset="-122"/>
                 <a:cs typeface="微软雅黑" panose="020B0503020204020204" charset="-122"/>
               </a:rPr>
-              <a:t>占位模板，无研究结果。新稿填写准确来源。</a:t>
+              <a:t>来源：Yang et al., USENIX Security 2024，Table 1、§6.2、§6.4、Appendix C。</a:t>
             </a:r>
             <a:endParaRPr sz="1040">
               <a:solidFill>
@@ -21572,12 +21699,18 @@
           </a:fontRef>
         </p:style>
       </p:cxnSp>
-      <p:sp>
-        <p:nvSpPr>
-          <p:cNvPr id="2000" name="Editable evidence placeholder"/>
-          <p:cNvSpPr txBox="1"/>
-          <p:nvPr/>
-        </p:nvSpPr>
+      <p:pic>
+        <p:nvPicPr>
+          <p:cNvPr id="3" name="el-1791698029047-9"/>
+          <p:cNvPicPr/>
+          <p:nvPr/>
+        </p:nvPicPr>
+        <p:blipFill>
+          <a:blip r:embed="rId1"/>
+          <a:stretch>
+            <a:fillRect/>
+          </a:stretch>
+        </p:blipFill>
         <p:spPr>
           <a:xfrm>
             <a:off x="685629" y="1158451"/>
@@ -21586,33 +21719,14 @@
           <a:prstGeom prst="rect">
             <a:avLst/>
           </a:prstGeom>
-          <a:solidFill>
-            <a:srgbClr val="F3F5F8"/>
-          </a:solidFill>
-          <a:ln w="9525">
+          <a:ln w="9523" algn="in">
             <a:solidFill>
               <a:srgbClr val="D8DDE3"/>
             </a:solidFill>
-          </a:ln>
-        </p:spPr>
-        <p:txBody>
-          <a:bodyPr anchor="ctr"/>
-          <a:lstStyle/>
-          <a:p>
-            <a:pPr algn="ctr"/>
-            <a:r>
-              <a:rPr lang="zh-CN" sz="1800">
-                <a:solidFill>
-                  <a:srgbClr val="5A6472"/>
-                </a:solidFill>
-                <a:latin typeface="Times New Roman"/>
-                <a:ea typeface="微软雅黑"/>
-              </a:rPr>
-              <a:t>研究证据图占位</a:t>
-            </a:r>
-          </a:p>
-        </p:txBody>
-      </p:sp>
+            <a:prstDash val="solid"/>
+          </a:ln>
+        </p:spPr>
+      </p:pic>
       <p:cxnSp>
         <p:nvCxnSpPr>
           <p:cNvPr id="4" name="el-1791698029022-8"/>
@@ -21722,7 +21836,7 @@
                 <a:ea typeface="Times New Roman" panose="02020603050405020304"/>
                 <a:cs typeface="Times New Roman" panose="02020603050405020304"/>
               </a:rPr>
-              <a:t>03 · 核心证据 / 案例</a:t>
+              <a:t>03 · 核心发现 / 3.0 案例研究</a:t>
             </a:r>
             <a:endParaRPr sz="1120" spc="150">
               <a:solidFill>
@@ -21772,7 +21886,7 @@
                 <a:ea typeface="Times New Roman" panose="02020603050405020304"/>
                 <a:cs typeface="Times New Roman" panose="02020603050405020304"/>
               </a:rPr>
-              <a:t>案例：方法如何解释一个具体过程</a:t>
+              <a:t>案例：一次 Postgres 失陷，告警何时才响？</a:t>
             </a:r>
             <a:endParaRPr sz="2990" b="1">
               <a:solidFill>
@@ -21822,7 +21936,7 @@
                 <a:ea typeface="微软雅黑" panose="020B0503020204020204" charset="-122"/>
                 <a:cs typeface="微软雅黑" panose="020B0503020204020204" charset="-122"/>
               </a:rPr>
-              <a:t>案例证据位：事件时间线或过程图</a:t>
+              <a:t>论文 Figure 2：攻击者时间线（上）与 SOC 分析师响应（下）</a:t>
             </a:r>
             <a:endParaRPr sz="970">
               <a:solidFill>
@@ -21872,7 +21986,7 @@
                 <a:ea typeface="Times New Roman" panose="02020603050405020304"/>
                 <a:cs typeface="Times New Roman" panose="02020603050405020304"/>
               </a:rPr>
-              <a:t>阶段A</a:t>
+              <a:t>0 条</a:t>
             </a:r>
             <a:endParaRPr sz="2020" b="1">
               <a:solidFill>
@@ -21922,7 +22036,7 @@
                 <a:ea typeface="微软雅黑" panose="020B0503020204020204" charset="-122"/>
                 <a:cs typeface="微软雅黑" panose="020B0503020204020204" charset="-122"/>
               </a:rPr>
-              <a:t>填写初始状态、可观察信息及其边界。</a:t>
+              <a:t>当次初始失陷阶段无网络告警：03:42经无口令账号登入，03:44下载3个文件（至少1个恶意）。</a:t>
             </a:r>
             <a:endParaRPr sz="1120">
               <a:solidFill>
@@ -21972,7 +22086,7 @@
                 <a:ea typeface="Times New Roman" panose="02020603050405020304"/>
                 <a:cs typeface="Times New Roman" panose="02020603050405020304"/>
               </a:rPr>
-              <a:t>阶段B</a:t>
+              <a:t>1,101 条</a:t>
             </a:r>
             <a:endParaRPr sz="2020" b="1">
               <a:solidFill>
@@ -22022,7 +22136,7 @@
                 <a:ea typeface="微软雅黑" panose="020B0503020204020204" charset="-122"/>
                 <a:cs typeface="微软雅黑" panose="020B0503020204020204" charset="-122"/>
               </a:rPr>
-              <a:t>填写关键变化及对应证据，说明与前一阶段的联系。</a:t>
+              <a:t>03:44—07:11共1,101条：主机D 1,100条，攻击者IP 1条。参照每主机4小时均值0.14条，偏离超过3个标准差。</a:t>
             </a:r>
             <a:endParaRPr sz="1120">
               <a:solidFill>
@@ -22072,7 +22186,7 @@
                 <a:ea typeface="Times New Roman" panose="02020603050405020304"/>
                 <a:cs typeface="Times New Roman" panose="02020603050405020304"/>
               </a:rPr>
-              <a:t>阶段C</a:t>
+              <a:t>1 个多月</a:t>
             </a:r>
             <a:endParaRPr sz="2020" b="1">
               <a:solidFill>
@@ -22122,7 +22236,7 @@
                 <a:ea typeface="微软雅黑" panose="020B0503020204020204" charset="-122"/>
                 <a:cs typeface="微软雅黑" panose="020B0503020204020204" charset="-122"/>
               </a:rPr>
-              <a:t>填写结果与后续处理，保留案例不能代表整体的限定。</a:t>
+              <a:t>07:11发现并封禁；08:10确认恶意文件；12-23取得取证快照。该案例反映了攻击后调查的日历时间延迟。</a:t>
             </a:r>
             <a:endParaRPr sz="1120">
               <a:solidFill>
@@ -22172,7 +22286,7 @@
                 <a:ea typeface="微软雅黑" panose="020B0503020204020204" charset="-122"/>
                 <a:cs typeface="微软雅黑" panose="020B0503020204020204" charset="-122"/>
               </a:rPr>
-              <a:t>占位模板，无研究结果。新稿填写真实来源。</a:t>
+              <a:t>来源：Yang et al., USENIX Security 2024，§4、Figure 2。</a:t>
             </a:r>
             <a:endParaRPr sz="1040">
               <a:solidFill>
@@ -22439,7 +22553,7 @@
                 <a:ea typeface="Times New Roman" panose="02020603050405020304"/>
                 <a:cs typeface="Times New Roman" panose="02020603050405020304"/>
               </a:rPr>
-              <a:t>03 · 核心证据 / 规模与变化</a:t>
+              <a:t>03 · 核心发现 / 3.1 告警体量</a:t>
             </a:r>
             <a:endParaRPr sz="1120" spc="150">
               <a:solidFill>
@@ -22489,7 +22603,7 @@
                 <a:ea typeface="Times New Roman" panose="02020603050405020304"/>
                 <a:cs typeface="Times New Roman" panose="02020603050405020304"/>
               </a:rPr>
-              <a:t>发现一：对象规模、变化及解释</a:t>
+              <a:t>发现①：海量告警与自动化后的余量</a:t>
             </a:r>
             <a:endParaRPr sz="2990" b="1">
               <a:solidFill>
@@ -22539,7 +22653,7 @@
                 <a:ea typeface="微软雅黑" panose="020B0503020204020204" charset="-122"/>
                 <a:cs typeface="微软雅黑" panose="020B0503020204020204" charset="-122"/>
               </a:rPr>
-              <a:t>占位模板，无研究结果。新稿填写真实来源。</a:t>
+              <a:t>来源：Yang et al., USENIX Security 2024，§6.1、Table 3、Figure 8。</a:t>
             </a:r>
             <a:endParaRPr sz="1040">
               <a:solidFill>
@@ -22664,12 +22778,20 @@
           <a:p/>
         </p:txBody>
       </p:sp>
-      <p:sp>
-        <p:nvSpPr>
-          <p:cNvPr id="2000" name="Editable evidence placeholder"/>
-          <p:cNvSpPr txBox="1"/>
-          <p:nvPr/>
-        </p:nvSpPr>
+      <p:pic>
+        <p:nvPicPr>
+          <p:cNvPr id="23" name="v3_"/>
+          <p:cNvPicPr>
+            <a:picLocks noChangeAspect="1"/>
+          </p:cNvPicPr>
+          <p:nvPr/>
+        </p:nvPicPr>
+        <p:blipFill>
+          <a:blip r:embed="rId1"/>
+          <a:stretch>
+            <a:fillRect/>
+          </a:stretch>
+        </p:blipFill>
         <p:spPr>
           <a:xfrm>
             <a:off x="685800" y="1266969"/>
@@ -22678,33 +22800,8 @@
           <a:prstGeom prst="rect">
             <a:avLst/>
           </a:prstGeom>
-          <a:solidFill>
-            <a:srgbClr val="F3F5F8"/>
-          </a:solidFill>
-          <a:ln w="9525">
-            <a:solidFill>
-              <a:srgbClr val="D8DDE3"/>
-            </a:solidFill>
-          </a:ln>
-        </p:spPr>
-        <p:txBody>
-          <a:bodyPr anchor="ctr"/>
-          <a:lstStyle/>
-          <a:p>
-            <a:pPr algn="ctr"/>
-            <a:r>
-              <a:rPr lang="zh-CN" sz="1800">
-                <a:solidFill>
-                  <a:srgbClr val="5A6472"/>
-                </a:solidFill>
-                <a:latin typeface="Times New Roman"/>
-                <a:ea typeface="微软雅黑"/>
-              </a:rPr>
-              <a:t>研究证据图占位</a:t>
-            </a:r>
-          </a:p>
-        </p:txBody>
-      </p:sp>
+        </p:spPr>
+      </p:pic>
       <p:sp>
         <p:nvSpPr>
           <p:cNvPr id="24" name="v3_P08 scale"/>
@@ -22762,7 +22859,7 @@
                 <a:ea typeface="微软雅黑" panose="020B0503020204020204" charset="-122"/>
                 <a:cs typeface="微软雅黑" panose="020B0503020204020204" charset="-122"/>
               </a:rPr>
-              <a:t>说明纵轴、时间窗与比较口径。</a:t>
+              <a:t>两段纵轴不同。134,738与24,965是各时期日均值</a:t>
             </a:r>
             <a:endParaRPr sz="1200" b="0">
               <a:solidFill>
@@ -22832,7 +22929,7 @@
                 <a:ea typeface="微软雅黑" panose="020B0503020204020204" charset="-122"/>
                 <a:cs typeface="微软雅黑" panose="020B0503020204020204" charset="-122"/>
               </a:rPr>
-              <a:t>仅在来源支持时解释变化原因。</a:t>
+              <a:t>峰值背景：2018年Mirai变种扫描；2022年Log4j扫描及内部日志告警。</a:t>
             </a:r>
             <a:endParaRPr sz="1125" b="0">
               <a:solidFill>
@@ -22926,7 +23023,7 @@
                 <a:ea typeface="Times New Roman" panose="02020603050405020304"/>
                 <a:cs typeface="Times New Roman" panose="02020603050405020304"/>
               </a:rPr>
-              <a:t>总量</a:t>
+              <a:t>115,617,526</a:t>
             </a:r>
             <a:endParaRPr sz="2325" b="1">
               <a:solidFill>
@@ -22996,7 +23093,7 @@
                 <a:ea typeface="微软雅黑" panose="020B0503020204020204" charset="-122"/>
                 <a:cs typeface="微软雅黑" panose="020B0503020204020204" charset="-122"/>
               </a:rPr>
-              <a:t>填写总量、单位与覆盖范围</a:t>
+              <a:t>全期1,329天</a:t>
             </a:r>
             <a:endParaRPr sz="1275" b="0">
               <a:solidFill>
@@ -23027,7 +23124,7 @@
                 <a:ea typeface="微软雅黑" panose="020B0503020204020204" charset="-122"/>
                 <a:cs typeface="微软雅黑" panose="020B0503020204020204" charset="-122"/>
               </a:rPr>
-              <a:t/>
+              <a:t>均86,996条/日</a:t>
             </a:r>
             <a:endParaRPr sz="1275" b="0">
               <a:solidFill>
@@ -23121,7 +23218,7 @@
                 <a:ea typeface="Times New Roman" panose="02020603050405020304"/>
                 <a:cs typeface="Times New Roman" panose="02020603050405020304"/>
               </a:rPr>
-              <a:t>时期A</a:t>
+              <a:t>134,738</a:t>
             </a:r>
             <a:endParaRPr sz="2325" b="1">
               <a:solidFill>
@@ -23191,7 +23288,7 @@
                 <a:ea typeface="微软雅黑" panose="020B0503020204020204" charset="-122"/>
                 <a:cs typeface="微软雅黑" panose="020B0503020204020204" charset="-122"/>
               </a:rPr>
-              <a:t>填写前期统计及时间窗</a:t>
+              <a:t>2018/04—2020/08</a:t>
             </a:r>
             <a:endParaRPr sz="1275" b="0">
               <a:solidFill>
@@ -23222,7 +23319,7 @@
                 <a:ea typeface="微软雅黑" panose="020B0503020204020204" charset="-122"/>
                 <a:cs typeface="微软雅黑" panose="020B0503020204020204" charset="-122"/>
               </a:rPr>
-              <a:t/>
+              <a:t>条/日（前期均值）</a:t>
             </a:r>
             <a:endParaRPr sz="1275" b="0">
               <a:solidFill>
@@ -23316,7 +23413,7 @@
                 <a:ea typeface="Times New Roman" panose="02020603050405020304"/>
                 <a:cs typeface="Times New Roman" panose="02020603050405020304"/>
               </a:rPr>
-              <a:t>时期B</a:t>
+              <a:t>24,965</a:t>
             </a:r>
             <a:endParaRPr sz="2325" b="1">
               <a:solidFill>
@@ -23386,7 +23483,7 @@
                 <a:ea typeface="微软雅黑" panose="020B0503020204020204" charset="-122"/>
                 <a:cs typeface="微软雅黑" panose="020B0503020204020204" charset="-122"/>
               </a:rPr>
-              <a:t>填写后期统计及时间窗</a:t>
+              <a:t>2020/12—2022/07</a:t>
             </a:r>
             <a:endParaRPr sz="1275" b="0">
               <a:solidFill>
@@ -23417,7 +23514,7 @@
                 <a:ea typeface="微软雅黑" panose="020B0503020204020204" charset="-122"/>
                 <a:cs typeface="微软雅黑" panose="020B0503020204020204" charset="-122"/>
               </a:rPr>
-              <a:t/>
+              <a:t>条/日（后期均值）</a:t>
             </a:r>
             <a:endParaRPr sz="1275" b="0">
               <a:solidFill>
@@ -23511,7 +23608,7 @@
                 <a:ea typeface="Times New Roman" panose="02020603050405020304"/>
                 <a:cs typeface="Times New Roman" panose="02020603050405020304"/>
               </a:rPr>
-              <a:t>比例</a:t>
+              <a:t>44.9%</a:t>
             </a:r>
             <a:endParaRPr sz="2325" b="1">
               <a:solidFill>
@@ -23581,7 +23678,7 @@
                 <a:ea typeface="微软雅黑" panose="020B0503020204020204" charset="-122"/>
                 <a:cs typeface="微软雅黑" panose="020B0503020204020204" charset="-122"/>
               </a:rPr>
-              <a:t>填写比例的分子、分母和含义</a:t>
+              <a:t>BHR自动处理比例</a:t>
             </a:r>
             <a:endParaRPr sz="1275" b="0">
               <a:solidFill>
@@ -23612,7 +23709,7 @@
                 <a:ea typeface="微软雅黑" panose="020B0503020204020204" charset="-122"/>
                 <a:cs typeface="微软雅黑" panose="020B0503020204020204" charset="-122"/>
               </a:rPr>
-              <a:t/>
+              <a:t>对应6,474,204条</a:t>
             </a:r>
             <a:endParaRPr sz="1275" b="0">
               <a:solidFill>
@@ -23682,7 +23779,7 @@
                 <a:ea typeface="微软雅黑" panose="020B0503020204020204" charset="-122"/>
                 <a:cs typeface="微软雅黑" panose="020B0503020204020204" charset="-122"/>
               </a:rPr>
-              <a:t>写出这组证据对研究问题的回答</a:t>
+              <a:t>自动处理后，仍约13,764条/日可能需进一步关注</a:t>
             </a:r>
             <a:endParaRPr sz="1500" b="1">
               <a:solidFill>
@@ -23752,7 +23849,7 @@
                 <a:ea typeface="微软雅黑" panose="020B0503020204020204" charset="-122"/>
                 <a:cs typeface="微软雅黑" panose="020B0503020204020204" charset="-122"/>
               </a:rPr>
-              <a:t>保留数据缺失、选择条件和推断边界。</a:t>
+              <a:t>这是未自动处理余量，不等于逐条人工阅读量。下降与规则/BHR等并行变化</a:t>
             </a:r>
             <a:endParaRPr sz="1200" b="0">
               <a:solidFill>
@@ -23943,7 +24040,7 @@
                 <a:ea typeface="Times New Roman" panose="02020603050405020304"/>
                 <a:cs typeface="Times New Roman" panose="02020603050405020304"/>
               </a:rPr>
-              <a:t>03 · 核心证据 / 分类与来源</a:t>
+              <a:t>03 · 核心发现 / 3.2 告警四分类</a:t>
             </a:r>
             <a:endParaRPr sz="1120" spc="150">
               <a:solidFill>
@@ -23993,7 +24090,7 @@
                 <a:ea typeface="Times New Roman" panose="02020603050405020304"/>
                 <a:cs typeface="Times New Roman" panose="02020603050405020304"/>
               </a:rPr>
-              <a:t>分类证据、来源分布与解释</a:t>
+              <a:t>发现②：后期告警构成与良性触发来源</a:t>
             </a:r>
             <a:endParaRPr sz="2990" b="1">
               <a:solidFill>
@@ -24043,7 +24140,7 @@
                 <a:ea typeface="Times New Roman" panose="02020603050405020304"/>
                 <a:cs typeface="Times New Roman" panose="02020603050405020304"/>
               </a:rPr>
-              <a:t>25%</a:t>
+              <a:t>0.01%</a:t>
             </a:r>
             <a:r>
               <a:rPr sz="840" b="1">
@@ -24054,7 +24151,7 @@
                 <a:ea typeface="Times New Roman" panose="02020603050405020304"/>
                 <a:cs typeface="Times New Roman" panose="02020603050405020304"/>
               </a:rPr>
-              <a:t/>
+              <a:t> </a:t>
             </a:r>
             <a:r>
               <a:rPr sz="1120">
@@ -24065,7 +24162,7 @@
                 <a:ea typeface="微软雅黑" panose="020B0503020204020204" charset="-122"/>
                 <a:cs typeface="微软雅黑" panose="020B0503020204020204" charset="-122"/>
               </a:rPr>
-              <a:t/>
+              <a:t>1,114 条</a:t>
             </a:r>
             <a:endParaRPr sz="1120">
               <a:solidFill>
@@ -24115,7 +24212,7 @@
                 <a:ea typeface="微软雅黑" panose="020B0503020204020204" charset="-122"/>
                 <a:cs typeface="微软雅黑" panose="020B0503020204020204" charset="-122"/>
               </a:rPr>
-              <a:t>类别A</a:t>
+              <a:t>True Attacks</a:t>
             </a:r>
             <a:endParaRPr sz="1270" b="1">
               <a:solidFill>
@@ -24165,7 +24262,7 @@
                 <a:ea typeface="微软雅黑" panose="020B0503020204020204" charset="-122"/>
                 <a:cs typeface="微软雅黑" panose="020B0503020204020204" charset="-122"/>
               </a:rPr>
-              <a:t>占位定义A</a:t>
+              <a:t>与已知成功攻击相关</a:t>
             </a:r>
             <a:endParaRPr sz="1040">
               <a:solidFill>
@@ -24215,7 +24312,7 @@
                 <a:ea typeface="Times New Roman" panose="02020603050405020304"/>
                 <a:cs typeface="Times New Roman" panose="02020603050405020304"/>
               </a:rPr>
-              <a:t>25%</a:t>
+              <a:t>27.37%</a:t>
             </a:r>
             <a:r>
               <a:rPr sz="840" b="1">
@@ -24226,7 +24323,7 @@
                 <a:ea typeface="Times New Roman" panose="02020603050405020304"/>
                 <a:cs typeface="Times New Roman" panose="02020603050405020304"/>
               </a:rPr>
-              <a:t/>
+              <a:t> </a:t>
             </a:r>
             <a:r>
               <a:rPr sz="1120">
@@ -24237,7 +24334,7 @@
                 <a:ea typeface="微软雅黑" panose="020B0503020204020204" charset="-122"/>
                 <a:cs typeface="微软雅黑" panose="020B0503020204020204" charset="-122"/>
               </a:rPr>
-              <a:t/>
+              <a:t>3,948,645 条</a:t>
             </a:r>
             <a:endParaRPr sz="1120">
               <a:solidFill>
@@ -24287,7 +24384,7 @@
                 <a:ea typeface="微软雅黑" panose="020B0503020204020204" charset="-122"/>
                 <a:cs typeface="微软雅黑" panose="020B0503020204020204" charset="-122"/>
               </a:rPr>
-              <a:t>类别B</a:t>
+              <a:t>Attack Attempts</a:t>
             </a:r>
             <a:endParaRPr sz="1270" b="1">
               <a:solidFill>
@@ -24337,7 +24434,7 @@
                 <a:ea typeface="微软雅黑" panose="020B0503020204020204" charset="-122"/>
                 <a:cs typeface="微软雅黑" panose="020B0503020204020204" charset="-122"/>
               </a:rPr>
-              <a:t>占位定义B</a:t>
+              <a:t>发起过攻击但未得手</a:t>
             </a:r>
             <a:endParaRPr sz="1040">
               <a:solidFill>
@@ -24387,7 +24484,7 @@
                 <a:ea typeface="Times New Roman" panose="02020603050405020304"/>
                 <a:cs typeface="Times New Roman" panose="02020603050405020304"/>
               </a:rPr>
-              <a:t>25%</a:t>
+              <a:t>48.91%</a:t>
             </a:r>
             <a:r>
               <a:rPr sz="840" b="1">
@@ -24398,7 +24495,7 @@
                 <a:ea typeface="Times New Roman" panose="02020603050405020304"/>
                 <a:cs typeface="Times New Roman" panose="02020603050405020304"/>
               </a:rPr>
-              <a:t/>
+              <a:t> </a:t>
             </a:r>
             <a:r>
               <a:rPr sz="1120">
@@ -24409,7 +24506,7 @@
                 <a:ea typeface="微软雅黑" panose="020B0503020204020204" charset="-122"/>
                 <a:cs typeface="微软雅黑" panose="020B0503020204020204" charset="-122"/>
               </a:rPr>
-              <a:t/>
+              <a:t>7,057,012 条</a:t>
             </a:r>
             <a:endParaRPr sz="1120">
               <a:solidFill>
@@ -24459,7 +24556,7 @@
                 <a:ea typeface="微软雅黑" panose="020B0503020204020204" charset="-122"/>
                 <a:cs typeface="微软雅黑" panose="020B0503020204020204" charset="-122"/>
               </a:rPr>
-              <a:t>类别C</a:t>
+              <a:t>Benign Triggers</a:t>
             </a:r>
             <a:endParaRPr sz="1270" b="1">
               <a:solidFill>
@@ -24509,7 +24606,7 @@
                 <a:ea typeface="微软雅黑" panose="020B0503020204020204" charset="-122"/>
                 <a:cs typeface="微软雅黑" panose="020B0503020204020204" charset="-122"/>
               </a:rPr>
-              <a:t>占位定义C</a:t>
+              <a:t>规则触发正确，业务背景可解释</a:t>
             </a:r>
             <a:endParaRPr sz="1040">
               <a:solidFill>
@@ -24559,7 +24656,7 @@
                 <a:ea typeface="Times New Roman" panose="02020603050405020304"/>
                 <a:cs typeface="Times New Roman" panose="02020603050405020304"/>
               </a:rPr>
-              <a:t>25%</a:t>
+              <a:t>23.72%</a:t>
             </a:r>
             <a:r>
               <a:rPr sz="840" b="1">
@@ -24570,7 +24667,7 @@
                 <a:ea typeface="Times New Roman" panose="02020603050405020304"/>
                 <a:cs typeface="Times New Roman" panose="02020603050405020304"/>
               </a:rPr>
-              <a:t/>
+              <a:t> </a:t>
             </a:r>
             <a:r>
               <a:rPr sz="1120">
@@ -24581,7 +24678,7 @@
                 <a:ea typeface="微软雅黑" panose="020B0503020204020204" charset="-122"/>
                 <a:cs typeface="微软雅黑" panose="020B0503020204020204" charset="-122"/>
               </a:rPr>
-              <a:t/>
+              <a:t>3,422,763 条</a:t>
             </a:r>
             <a:endParaRPr sz="1120">
               <a:solidFill>
@@ -24631,7 +24728,7 @@
                 <a:ea typeface="微软雅黑" panose="020B0503020204020204" charset="-122"/>
                 <a:cs typeface="微软雅黑" panose="020B0503020204020204" charset="-122"/>
               </a:rPr>
-              <a:t>类别D</a:t>
+              <a:t>Unknown</a:t>
             </a:r>
             <a:endParaRPr sz="1270" b="1">
               <a:solidFill>
@@ -24681,7 +24778,7 @@
                 <a:ea typeface="微软雅黑" panose="020B0503020204020204" charset="-122"/>
                 <a:cs typeface="微软雅黑" panose="020B0503020204020204" charset="-122"/>
               </a:rPr>
-              <a:t>占位定义D</a:t>
+              <a:t>未判定，不等于安全</a:t>
             </a:r>
             <a:endParaRPr sz="1040">
               <a:solidFill>
@@ -24731,7 +24828,7 @@
                 <a:ea typeface="微软雅黑" panose="020B0503020204020204" charset="-122"/>
                 <a:cs typeface="微软雅黑" panose="020B0503020204020204" charset="-122"/>
               </a:rPr>
-              <a:t>占位模板，无研究结果。新稿填写准确来源。</a:t>
+              <a:t>来源：Yang et al., USENIX Security 2024，§6.2、§6.4、Tables 4、7。</a:t>
             </a:r>
             <a:endParaRPr sz="1040">
               <a:solidFill>
@@ -24904,28 +25001,42 @@
           <a:p/>
         </p:txBody>
       </p:sp>
-      <p:sp>
-        <p:nvSpPr>
-          <p:cNvPr id="37" name="editable quarter A"/>
-          <p:cNvSpPr/>
-          <p:nvPr/>
-        </p:nvSpPr>
-        <p:spPr>
-          <a:xfrm>
-            <a:off x="685629" y="1810155"/>
-            <a:ext cx="713787" cy="76181"/>
-          </a:xfrm>
-          <a:prstGeom prst="rect">
-            <a:avLst/>
-          </a:prstGeom>
-          <a:solidFill>
-            <a:srgbClr val="3E5C9A"/>
-          </a:solidFill>
-          <a:ln>
-            <a:noFill/>
-          </a:ln>
-        </p:spPr>
-      </p:sp>
+      <p:cxnSp>
+        <p:nvCxnSpPr>
+          <p:cNvPr id="37" name="el-1791698029370-31"/>
+          <p:cNvCxnSpPr/>
+          <p:nvPr/>
+        </p:nvCxnSpPr>
+        <p:spPr>
+          <a:xfrm>
+            <a:off x="699838" y="1810155"/>
+            <a:ext cx="914" cy="76181"/>
+          </a:xfrm>
+          <a:prstGeom prst="line">
+            <a:avLst/>
+          </a:prstGeom>
+          <a:ln w="28419" cap="flat">
+            <a:solidFill>
+              <a:srgbClr val="3E5C9A"/>
+            </a:solidFill>
+            <a:prstDash val="solid"/>
+          </a:ln>
+        </p:spPr>
+        <p:style>
+          <a:lnRef idx="2">
+            <a:schemeClr val="accent1"/>
+          </a:lnRef>
+          <a:fillRef idx="0">
+            <a:schemeClr val="accent1"/>
+          </a:fillRef>
+          <a:effectRef idx="1">
+            <a:schemeClr val="accent1"/>
+          </a:effectRef>
+          <a:fontRef idx="minor">
+            <a:schemeClr val="tx1"/>
+          </a:fontRef>
+        </p:style>
+      </p:cxnSp>
       <p:sp>
         <p:nvSpPr>
           <p:cNvPr id="38" name="el-1791698029367-24"/>
@@ -24983,7 +25094,7 @@
         <p:spPr>
           <a:xfrm>
             <a:off x="3693139" y="1810155"/>
-            <a:ext cx="571060" cy="76181"/>
+            <a:ext cx="625071" cy="76181"/>
           </a:xfrm>
           <a:custGeom>
             <a:avLst/>
@@ -25081,7 +25192,7 @@
         <p:spPr>
           <a:xfrm>
             <a:off x="6129739" y="1810155"/>
-            <a:ext cx="856589" cy="76181"/>
+            <a:ext cx="1675683" cy="76181"/>
           </a:xfrm>
           <a:custGeom>
             <a:avLst/>
@@ -25179,7 +25290,7 @@
         <p:spPr>
           <a:xfrm>
             <a:off x="9708459" y="1810155"/>
-            <a:ext cx="448716" cy="76181"/>
+            <a:ext cx="425691" cy="76181"/>
           </a:xfrm>
           <a:custGeom>
             <a:avLst/>
@@ -25275,7 +25386,7 @@
                 <a:ea typeface="微软雅黑" panose="020B0503020204020204" charset="-122"/>
                 <a:cs typeface="微软雅黑" panose="020B0503020204020204" charset="-122"/>
               </a:rPr>
-              <a:t>占位演示数据：八个来源，数值8至1</a:t>
+              <a:t>据论文Table 7摘编并重绘：主要来源（非全集，可重叠）</a:t>
             </a:r>
             <a:endParaRPr sz="1350" b="1">
               <a:solidFill>
@@ -25345,7 +25456,7 @@
                 <a:ea typeface="微软雅黑" panose="020B0503020204020204" charset="-122"/>
                 <a:cs typeface="微软雅黑" panose="020B0503020204020204" charset="-122"/>
               </a:rPr>
-              <a:t>示意单位；新稿说明并集、重叠与选列范围</a:t>
+              <a:t>良性触发并集7,057,012条，选列项不能累加作为总量</a:t>
             </a:r>
             <a:endParaRPr sz="1275" b="0">
               <a:solidFill>
@@ -25439,7 +25550,7 @@
                 <a:ea typeface="微软雅黑" panose="020B0503020204020204" charset="-122"/>
                 <a:cs typeface="微软雅黑" panose="020B0503020204020204" charset="-122"/>
               </a:rPr>
-              <a:t>主要差异</a:t>
+              <a:t>业务背景决定解释</a:t>
             </a:r>
             <a:endParaRPr sz="1500" b="1">
               <a:solidFill>
@@ -25509,7 +25620,7 @@
                 <a:ea typeface="微软雅黑" panose="020B0503020204020204" charset="-122"/>
                 <a:cs typeface="微软雅黑" panose="020B0503020204020204" charset="-122"/>
               </a:rPr>
-              <a:t>解释哪条证据支持本页回答，而不重复全部数字。</a:t>
+              <a:t>合规测试、合作域名及运行问题</a:t>
             </a:r>
             <a:endParaRPr sz="1275" b="0">
               <a:solidFill>
@@ -25540,7 +25651,7 @@
                 <a:ea typeface="微软雅黑" panose="020B0503020204020204" charset="-122"/>
                 <a:cs typeface="微软雅黑" panose="020B0503020204020204" charset="-122"/>
               </a:rPr>
-              <a:t/>
+              <a:t>均可能命中有效规则</a:t>
             </a:r>
             <a:endParaRPr sz="1275" b="0">
               <a:solidFill>
@@ -25634,7 +25745,7 @@
                 <a:ea typeface="微软雅黑" panose="020B0503020204020204" charset="-122"/>
                 <a:cs typeface="微软雅黑" panose="020B0503020204020204" charset="-122"/>
               </a:rPr>
-              <a:t>原因或机制</a:t>
+              <a:t>外部测试高于日志故障</a:t>
             </a:r>
             <a:endParaRPr sz="1500" b="1">
               <a:solidFill>
@@ -25704,7 +25815,7 @@
                 <a:ea typeface="微软雅黑" panose="020B0503020204020204" charset="-122"/>
                 <a:cs typeface="微软雅黑" panose="020B0503020204020204" charset="-122"/>
               </a:rPr>
-              <a:t>连接图中差异与已给出的业务或方法上下文。</a:t>
+              <a:t>2,694,851 &gt; 2,553,794条</a:t>
             </a:r>
             <a:endParaRPr sz="1275" b="0">
               <a:solidFill>
@@ -25735,7 +25846,7 @@
                 <a:ea typeface="微软雅黑" panose="020B0503020204020204" charset="-122"/>
                 <a:cs typeface="微软雅黑" panose="020B0503020204020204" charset="-122"/>
               </a:rPr>
-              <a:t/>
+              <a:t>日志故障不是最大单项</a:t>
             </a:r>
             <a:endParaRPr sz="1275" b="0">
               <a:solidFill>
@@ -25829,7 +25940,7 @@
                 <a:ea typeface="微软雅黑" panose="020B0503020204020204" charset="-122"/>
                 <a:cs typeface="微软雅黑" panose="020B0503020204020204" charset="-122"/>
               </a:rPr>
-              <a:t>证据范围</a:t>
+              <a:t>分类仍有边界</a:t>
             </a:r>
             <a:endParaRPr sz="1500" b="1">
               <a:solidFill>
@@ -25899,7 +26010,7 @@
                 <a:ea typeface="微软雅黑" panose="020B0503020204020204" charset="-122"/>
                 <a:cs typeface="微软雅黑" panose="020B0503020204020204" charset="-122"/>
               </a:rPr>
-              <a:t>写清分母、时间窗与未判定部分，避免扩大结论。</a:t>
+              <a:t>尝试与良性触发为保守识别下界</a:t>
             </a:r>
             <a:endParaRPr sz="1275" b="0">
               <a:solidFill>
@@ -25930,7 +26041,7 @@
                 <a:ea typeface="微软雅黑" panose="020B0503020204020204" charset="-122"/>
                 <a:cs typeface="微软雅黑" panose="020B0503020204020204" charset="-122"/>
               </a:rPr>
-              <a:t/>
+              <a:t>unknown不等于安全</a:t>
             </a:r>
             <a:endParaRPr sz="1275" b="0">
               <a:solidFill>
@@ -25980,7 +26091,7 @@
                 <a:ea typeface="微软雅黑" panose="020B0503020204020204" charset="-122"/>
                 <a:cs typeface="微软雅黑" panose="020B0503020204020204" charset="-122"/>
               </a:rPr>
-              <a:t>四组25%及来源8至1均为排版示意，两个区域无统计关联。</a:t>
+              <a:t>2020/12—2022/07 · 14,429,534条；0.01%为告警条数比例，非事件率或检测率。</a:t>
             </a:r>
             <a:endParaRPr sz="1100">
               <a:solidFill>
@@ -26030,7 +26141,7 @@
                 <a:ea typeface="微软雅黑" panose="020B0503020204020204" charset="-122"/>
                 <a:cs typeface="微软雅黑" panose="020B0503020204020204" charset="-122"/>
               </a:rPr>
-              <a:t>来源A</a:t>
+              <a:t>外部渗透测试／合规审计</a:t>
             </a:r>
             <a:endParaRPr sz="1010">
               <a:solidFill>
@@ -26080,7 +26191,7 @@
                 <a:ea typeface="Times New Roman" panose="02020603050405020304"/>
                 <a:cs typeface="Times New Roman" panose="02020603050405020304"/>
               </a:rPr>
-              <a:t>8</a:t>
+              <a:t>2,694,851</a:t>
             </a:r>
             <a:endParaRPr sz="1010" b="1">
               <a:solidFill>
@@ -26130,7 +26241,7 @@
                 <a:ea typeface="微软雅黑" panose="020B0503020204020204" charset="-122"/>
                 <a:cs typeface="微软雅黑" panose="020B0503020204020204" charset="-122"/>
               </a:rPr>
-              <a:t>来源B</a:t>
+              <a:t>Zeek 日志记录故障</a:t>
             </a:r>
             <a:endParaRPr sz="1010">
               <a:solidFill>
@@ -26180,7 +26291,7 @@
                 <a:ea typeface="Times New Roman" panose="02020603050405020304"/>
                 <a:cs typeface="Times New Roman" panose="02020603050405020304"/>
               </a:rPr>
-              <a:t>7</a:t>
+              <a:t>2,553,794</a:t>
             </a:r>
             <a:endParaRPr sz="1010" b="1">
               <a:solidFill>
@@ -26230,7 +26341,7 @@
                 <a:ea typeface="微软雅黑" panose="020B0503020204020204" charset="-122"/>
                 <a:cs typeface="微软雅黑" panose="020B0503020204020204" charset="-122"/>
               </a:rPr>
-              <a:t>来源C</a:t>
+              <a:t>外部域名指向本地 IP</a:t>
             </a:r>
             <a:endParaRPr sz="1010">
               <a:solidFill>
@@ -26280,7 +26391,7 @@
                 <a:ea typeface="Times New Roman" panose="02020603050405020304"/>
                 <a:cs typeface="Times New Roman" panose="02020603050405020304"/>
               </a:rPr>
-              <a:t>6</a:t>
+              <a:t>1,407,151</a:t>
             </a:r>
             <a:endParaRPr sz="1010" b="1">
               <a:solidFill>
@@ -26330,7 +26441,7 @@
                 <a:ea typeface="微软雅黑" panose="020B0503020204020204" charset="-122"/>
                 <a:cs typeface="微软雅黑" panose="020B0503020204020204" charset="-122"/>
               </a:rPr>
-              <a:t>来源D</a:t>
+              <a:t>内部合法扫描</a:t>
             </a:r>
             <a:endParaRPr sz="1010">
               <a:solidFill>
@@ -26380,7 +26491,7 @@
                 <a:ea typeface="Times New Roman" panose="02020603050405020304"/>
                 <a:cs typeface="Times New Roman" panose="02020603050405020304"/>
               </a:rPr>
-              <a:t>5</a:t>
+              <a:t>194,518</a:t>
             </a:r>
             <a:endParaRPr sz="1010" b="1">
               <a:solidFill>
@@ -26430,7 +26541,7 @@
                 <a:ea typeface="微软雅黑" panose="020B0503020204020204" charset="-122"/>
                 <a:cs typeface="微软雅黑" panose="020B0503020204020204" charset="-122"/>
               </a:rPr>
-              <a:t>来源E</a:t>
+              <a:t>非攻击类（新地址空间等）</a:t>
             </a:r>
             <a:endParaRPr sz="1010">
               <a:solidFill>
@@ -26480,7 +26591,7 @@
                 <a:ea typeface="Times New Roman" panose="02020603050405020304"/>
                 <a:cs typeface="Times New Roman" panose="02020603050405020304"/>
               </a:rPr>
-              <a:t>4</a:t>
+              <a:t>138,893</a:t>
             </a:r>
             <a:endParaRPr sz="1010" b="1">
               <a:solidFill>
@@ -26530,7 +26641,7 @@
                 <a:ea typeface="微软雅黑" panose="020B0503020204020204" charset="-122"/>
                 <a:cs typeface="微软雅黑" panose="020B0503020204020204" charset="-122"/>
               </a:rPr>
-              <a:t>来源F</a:t>
+              <a:t>DNS 类</a:t>
             </a:r>
             <a:endParaRPr sz="1010">
               <a:solidFill>
@@ -26580,7 +26691,7 @@
                 <a:ea typeface="Times New Roman" panose="02020603050405020304"/>
                 <a:cs typeface="Times New Roman" panose="02020603050405020304"/>
               </a:rPr>
-              <a:t>3</a:t>
+              <a:t>55,253</a:t>
             </a:r>
             <a:endParaRPr sz="1010" b="1">
               <a:solidFill>
@@ -26630,7 +26741,7 @@
                 <a:ea typeface="微软雅黑" panose="020B0503020204020204" charset="-122"/>
                 <a:cs typeface="微软雅黑" panose="020B0503020204020204" charset="-122"/>
               </a:rPr>
-              <a:t>来源G</a:t>
+              <a:t>SSL 类</a:t>
             </a:r>
             <a:endParaRPr sz="1010">
               <a:solidFill>
@@ -26680,7 +26791,7 @@
                 <a:ea typeface="Times New Roman" panose="02020603050405020304"/>
                 <a:cs typeface="Times New Roman" panose="02020603050405020304"/>
               </a:rPr>
-              <a:t>2</a:t>
+              <a:t>39,818</a:t>
             </a:r>
             <a:endParaRPr sz="1010" b="1">
               <a:solidFill>
@@ -26730,7 +26841,7 @@
                 <a:ea typeface="微软雅黑" panose="020B0503020204020204" charset="-122"/>
                 <a:cs typeface="微软雅黑" panose="020B0503020204020204" charset="-122"/>
               </a:rPr>
-              <a:t>来源H</a:t>
+              <a:t>例外服务</a:t>
             </a:r>
             <a:endParaRPr sz="1010">
               <a:solidFill>
@@ -26780,7 +26891,7 @@
                 <a:ea typeface="Times New Roman" panose="02020603050405020304"/>
                 <a:cs typeface="Times New Roman" panose="02020603050405020304"/>
               </a:rPr>
-              <a:t>1</a:t>
+              <a:t>260</a:t>
             </a:r>
             <a:endParaRPr sz="1010" b="1">
               <a:solidFill>
@@ -26830,7 +26941,7 @@
                 <a:ea typeface="微软雅黑" panose="020B0503020204020204" charset="-122"/>
                 <a:cs typeface="微软雅黑" panose="020B0503020204020204" charset="-122"/>
               </a:rPr>
-              <a:t>示意条形采用共同基线和线性比例。新稿须按真实来源与数值更新，不能只改数字。</a:t>
+              <a:t>单位：条。仅列示 Table 7 中的 8 个主要来源（按条数排序），并非全部细项；条长以最大项（外部渗透测试）为基准。</a:t>
             </a:r>
             <a:endParaRPr sz="930">
               <a:solidFill>
@@ -26996,7 +27107,7 @@
         <p:spPr>
           <a:xfrm>
             <a:off x="2301791" y="3451208"/>
-            <a:ext cx="3649544" cy="180930"/>
+            <a:ext cx="3953970" cy="180930"/>
           </a:xfrm>
           <a:custGeom>
             <a:avLst/>
@@ -27092,7 +27203,7 @@
         <p:spPr>
           <a:xfrm>
             <a:off x="2301791" y="3729744"/>
-            <a:ext cx="3128180" cy="180930"/>
+            <a:ext cx="2177109" cy="180930"/>
           </a:xfrm>
           <a:custGeom>
             <a:avLst/>
@@ -27188,7 +27299,7 @@
         <p:spPr>
           <a:xfrm>
             <a:off x="2301791" y="4008281"/>
-            <a:ext cx="2606817" cy="180930"/>
+            <a:ext cx="300260" cy="180930"/>
           </a:xfrm>
           <a:custGeom>
             <a:avLst/>
@@ -27284,7 +27395,7 @@
         <p:spPr>
           <a:xfrm>
             <a:off x="2301791" y="4286817"/>
-            <a:ext cx="2085454" cy="180930"/>
+            <a:ext cx="216788" cy="180930"/>
           </a:xfrm>
           <a:custGeom>
             <a:avLst/>
@@ -27380,7 +27491,7 @@
         <p:spPr>
           <a:xfrm>
             <a:off x="2301791" y="4565354"/>
-            <a:ext cx="1564090" cy="180930"/>
+            <a:ext cx="87489" cy="180930"/>
           </a:xfrm>
           <a:custGeom>
             <a:avLst/>
@@ -27476,7 +27587,7 @@
         <p:spPr>
           <a:xfrm>
             <a:off x="2301791" y="4843891"/>
-            <a:ext cx="1042727" cy="180930"/>
+            <a:ext cx="62492" cy="180930"/>
           </a:xfrm>
           <a:custGeom>
             <a:avLst/>
@@ -27563,28 +27674,42 @@
           <a:p/>
         </p:txBody>
       </p:sp>
-      <p:sp>
-        <p:nvSpPr>
-          <p:cNvPr id="110" name="editable bar H"/>
-          <p:cNvSpPr/>
-          <p:nvPr/>
-        </p:nvSpPr>
-        <p:spPr>
-          <a:xfrm>
-            <a:off x="2301791" y="5122427"/>
-            <a:ext cx="521363" cy="180930"/>
-          </a:xfrm>
-          <a:prstGeom prst="rect">
-            <a:avLst/>
-          </a:prstGeom>
-          <a:solidFill>
-            <a:srgbClr val="7E93BC"/>
-          </a:solidFill>
-          <a:ln>
-            <a:noFill/>
-          </a:ln>
-        </p:spPr>
-      </p:sp>
+      <p:cxnSp>
+        <p:nvCxnSpPr>
+          <p:cNvPr id="110" name="el-1791803793310-60"/>
+          <p:cNvCxnSpPr/>
+          <p:nvPr/>
+        </p:nvCxnSpPr>
+        <p:spPr>
+          <a:xfrm>
+            <a:off x="2311313" y="5122427"/>
+            <a:ext cx="914" cy="180930"/>
+          </a:xfrm>
+          <a:prstGeom prst="line">
+            <a:avLst/>
+          </a:prstGeom>
+          <a:ln w="19045" cap="flat">
+            <a:solidFill>
+              <a:srgbClr val="7E93BC"/>
+            </a:solidFill>
+            <a:prstDash val="solid"/>
+          </a:ln>
+        </p:spPr>
+        <p:style>
+          <a:lnRef idx="2">
+            <a:schemeClr val="accent1"/>
+          </a:lnRef>
+          <a:fillRef idx="0">
+            <a:schemeClr val="accent1"/>
+          </a:fillRef>
+          <a:effectRef idx="1">
+            <a:schemeClr val="accent1"/>
+          </a:effectRef>
+          <a:fontRef idx="minor">
+            <a:schemeClr val="tx1"/>
+          </a:fontRef>
+        </p:style>
+      </p:cxnSp>
     </p:spTree>
   </p:cSld>
   <p:clrMapOvr>

</xml_diff>